<commit_message>
Report and deck: housing officer, rework, trades together, floods
- Report 3.9 with the rework rule, the trades-together saving and the
  modelled flood; Appendix I adds the housing officer and the flood
  response; recommendation 6 adds shared vehicles and a surge panel.
  Still 8 body pages, summary 249 words
- Deck: new slide 10 on floods and surge crews; trades travelling
  together on the planning slide; housing officer on the trust slide;
  98 automated checks; notes trimmed so the spoken length is unchanged
- Pitch script regenerated, with answers on the housing officer, rework,
  trades together and floods
</commit_message>
<xml_diff>
--- a/docs/deck/DataChallenge_Team AIC015_Slides.pptx
+++ b/docs/deck/DataChallenge_Team AIC015_Slides.pptx
@@ -19,9 +19,10 @@
     <p:sldId id="267" r:id="rId13"/>
     <p:sldId id="268" r:id="rId14"/>
     <p:sldId id="269" r:id="rId15"/>
+    <p:sldId id="270" r:id="rId16"/>
   </p:sldIdLst>
   <p:notesMasterIdLst>
-    <p:notesMasterId r:id="rId16"/>
+    <p:notesMasterId r:id="rId17"/>
   </p:notesMasterIdLst>
   <p:sldSz cx="12192000" cy="6858000"/>
   <p:notesSz cx="6858000" cy="12192000"/>
@@ -120,23 +121,23 @@
   <p:extLst>
     <p:ext uri="{521415D9-36F7-43E2-AB2F-B90AF26B5E84}">
       <p14:sectionLst xmlns:p14="http://schemas.microsoft.com/office/powerpoint/2010/main">
-        <p14:section name="Opening" id="{971c04b0-399b-047d-27aa-267c9dc0662f}">
+        <p14:section name="Opening" id="{6a2b5af1-2cf6-02bf-e132-e184b715b762}">
           <p14:sldIdLst>
             <p14:sldId id="256"/>
           </p14:sldIdLst>
         </p14:section>
-        <p14:section name="Problem" id="{fcca1bd1-7c49-cb3f-749d-982f216a2228}">
+        <p14:section name="Problem" id="{a558f3f2-7a5f-d32c-5dac-81a0d9409602}">
           <p14:sldIdLst>
             <p14:sldId id="257"/>
             <p14:sldId id="258"/>
           </p14:sldIdLst>
         </p14:section>
-        <p14:section name="Solution" id="{05f66e9c-cd7b-4a46-cee2-0d0b87b796dd}">
+        <p14:section name="Solution" id="{d69e74d5-5a23-436b-b725-e7ca1ec29663}">
           <p14:sldIdLst>
             <p14:sldId id="259"/>
           </p14:sldIdLst>
         </p14:section>
-        <p14:section name="Technology" id="{740598cc-0bc6-26cc-d47e-1c427ecd293e}">
+        <p14:section name="Technology" id="{4c097d64-e9c4-9df2-f0f5-a7e866436d4d}">
           <p14:sldIdLst>
             <p14:sldId id="260"/>
             <p14:sldId id="261"/>
@@ -144,26 +145,27 @@
             <p14:sldId id="263"/>
           </p14:sldIdLst>
         </p14:section>
-        <p14:section name="Results" id="{db0820a3-9cfd-8695-3a7b-2183c5209dc9}">
+        <p14:section name="Results" id="{b66a1b54-901b-e064-f42a-f235b5a8d142}">
           <p14:sldIdLst>
             <p14:sldId id="264"/>
-          </p14:sldIdLst>
-        </p14:section>
-        <p14:section name="Product" id="{8946873a-f5bd-8460-775f-b98c0cf152a7}">
-          <p14:sldIdLst>
             <p14:sldId id="265"/>
           </p14:sldIdLst>
         </p14:section>
-        <p14:section name="Trust" id="{d499d603-3c1a-5db7-a446-adbf7e237d1f}">
+        <p14:section name="Product" id="{20adb541-6246-695c-6cc0-3adfc2b982dd}">
           <p14:sldIdLst>
             <p14:sldId id="266"/>
-            <p14:sldId id="267"/>
           </p14:sldIdLst>
         </p14:section>
-        <p14:section name="Close" id="{675c0e61-2687-247d-ea52-88c0ea89a800}">
+        <p14:section name="Trust" id="{075291d2-32c7-0c22-3c9f-fa2a9380583d}">
           <p14:sldIdLst>
+            <p14:sldId id="267"/>
             <p14:sldId id="268"/>
+          </p14:sldIdLst>
+        </p14:section>
+        <p14:section name="Close" id="{7a149782-aade-9fe0-4300-e1c099221b1c}">
+          <p14:sldIdLst>
             <p14:sldId id="269"/>
+            <p14:sldId id="270"/>
           </p14:sldIdLst>
         </p14:section>
       </p14:sectionLst>
@@ -1228,11 +1230,10 @@
           <a:p>
             <a:r>
               <a:rPr lang="en-US" dirty="0"/>
-              <a:t>[HARSH, about 75 seconds, including a short live demo if there's time]
-This is the working prototype, live at reachnt dot vercel dot app.
-On the left is the coordinator's week: each hexagon is a community, the number is repairs waiting, green means a tradesperson goes this week, and the blue lines are shared trips.
-[Live demo, keep it short: New report, log "toilet blocked pls come" from the housing officer and answer the questions; on the job, show the time left and Check the urgency; switch to Tenant and show the timeline.]
-On the phone, the tradesperson gets a run sheet that works with no signal and can take open jobs, and the tenant sees every week their repair waited, and why.</a:t>
+              <a:t>[AASHISH, about 35 seconds]
+Floods and cyclones hit whole communities at once. The coordinator declares an event: every house made safe within 48 hours, one team trip with all the trades, and surge crews from the contractor panel.
+We modelled a flood like January 2023 at Kalkarindji. With the usual crews, flood repairs took 15 days, and everyone else in the region slipped from 3 to 10.
+With surge crews, both stayed at 3 days. A disaster shouldn't quietly take other communities' trades.</a:t>
             </a:r>
             <a:endParaRPr lang="en-US" dirty="0"/>
           </a:p>
@@ -1320,12 +1321,11 @@
           <a:p>
             <a:r>
               <a:rPr lang="en-US" dirty="0"/>
-              <a:t>[AASHISH, about 45 seconds]
-Because this affects people's homes, people stay in charge.
-A named coordinator signs how much cost counts.
-Urgency can change any time, so a person can change it: on a call, on site, from a photo. The computer never makes danger less urgent.
-If a tradesperson couldn't do a job, it's never closed. The coordinator sends it to the next trip, another crew, or anyone who can go sooner, and it keeps its waiting time.
-Tenants can ask for a review or say it got worse, and personal details stay in an encrypted vault.</a:t>
+              <a:t>[HARSH, about 65 seconds, including a short live demo if there's time]
+This is the working prototype, live at reachnt dot vercel dot app.
+On the left is the coordinator's week: each hexagon is a community, the number is repairs waiting, green means a tradesperson goes this week, and the blue lines are shared trips.
+[Live demo, keep it short: Housing officer view, record "still broken" for a tenant; Coordinator, Checks, send it to another crew; Tenant timeline.]
+On the phone, tradespeople get a run sheet that works with no signal, and tenants see every week their repair waited, and why.</a:t>
             </a:r>
             <a:endParaRPr lang="en-US" dirty="0"/>
           </a:p>
@@ -1413,11 +1413,12 @@
           <a:p>
             <a:r>
               <a:rPr lang="en-US" dirty="0"/>
-              <a:t>[HARSH, about 50 seconds]
-We want to be straight about what we've proven and what we haven't.
-On the left: we have ninety-two automated checks that run on every change, we tested five random years, we checked every community's location against satellite photos, and the site passes accessibility checks.
-On the right: the repair requests are synthetic, because no public repair data exists. The reader is tested in English only, and many tenants speak Kriol or Aboriginal English. And no community has reviewed this yet.
-That's why our first recommendation is about people, not code.</a:t>
+              <a:t>[AASHISH, about 45 seconds]
+Because this affects people's homes, people stay in charge.
+A named coordinator signs how much cost counts.
+Urgency can change any time, so a person can change it: on a call, on site, from a photo. The computer never makes danger less urgent.
+If a tradesperson couldn't do a job, it's never closed. The coordinator sends it to the next trip, another crew, or anyone who can go sooner, and it keeps its waiting time.
+No app is needed: the housing officer can record anything for a tenant, and a fix that didn't hold moves up the line.</a:t>
             </a:r>
             <a:endParaRPr lang="en-US" dirty="0"/>
           </a:p>
@@ -1505,11 +1506,11 @@
           <a:p>
             <a:r>
               <a:rPr lang="en-US" dirty="0"/>
-              <a:t>[AASHISH, about 40 seconds]
-Three recommendations.
-One: make the trade-off a signed decision. Publish the rules, ask every tenant the same questions, and record who decides how much cost counts.
-Two: pilot it in one region, the Katherine hub's sixteen communities, and design it with tenants, Aboriginal Housing NT, land councils and interpreters.
-Three: test the AI on real words before it reads anything on its own.</a:t>
+              <a:t>[HARSH, about 50 seconds]
+We want to be straight about what we've proven and what we haven't.
+On the left: we have ninety-eight automated checks that run on every change, we tested five random years, we checked every community's location against satellite photos, and the site passes accessibility checks.
+On the right: the repair requests are synthetic, because no public repair data exists. The reader is tested in English only, and many tenants speak Kriol or Aboriginal English. And no community has reviewed this yet.
+That's why our first recommendation is about people, not code.</a:t>
             </a:r>
             <a:endParaRPr lang="en-US" dirty="0"/>
           </a:p>
@@ -1597,10 +1598,11 @@
           <a:p>
             <a:r>
               <a:rPr lang="en-US" dirty="0"/>
-              <a:t>[HARSH, about 20 seconds]
-To finish: where someone lives shouldn't decide how long they wait for water, power or a safe home.
-ReachNT fixes urgent remote repairs in days instead of months, for a cost we can see and name, and it makes someone own that choice.
-Thank you. We're happy to take questions.</a:t>
+              <a:t>[AASHISH, about 40 seconds]
+Three recommendations.
+One: make the trade-off a signed decision. Publish the rules, ask every tenant the same questions, and record who decides how much cost counts.
+Two: pilot it in one region, the Katherine hub's sixteen communities, and design it with tenants, Aboriginal Housing NT, land councils and interpreters.
+Three: test the AI on real words before it reads anything on its own.</a:t>
             </a:r>
             <a:endParaRPr lang="en-US" dirty="0"/>
           </a:p>
@@ -1624,6 +1626,97 @@
             <a:fld id="{F7021451-1387-4CA6-816F-3879F97B5CBC}" type="slidenum">
               <a:rPr lang="en-US"/>
               <a:t>14</a:t>
+            </a:fld>
+            <a:endParaRPr lang="en-US"/>
+          </a:p>
+        </p:txBody>
+      </p:sp>
+    </p:spTree>
+    <p:extLst>
+      <p:ext uri="{BB962C8B-B14F-4D97-AF65-F5344CB8AC3E}">
+        <p14:creationId xmlns:p14="http://schemas.microsoft.com/office/powerpoint/2010/main" val="1024086991"/>
+      </p:ext>
+    </p:extLst>
+  </p:cSld>
+  <p:clrMapOvr>
+    <a:masterClrMapping/>
+  </p:clrMapOvr>
+</p:notes>
+</file>
+
+<file path=ppt/notesSlides/notesSlide15.xml><?xml version="1.0" encoding="utf-8"?>
+<p:notes xmlns:a="http://schemas.openxmlformats.org/drawingml/2006/main" xmlns:r="http://schemas.openxmlformats.org/officeDocument/2006/relationships" xmlns:p="http://schemas.openxmlformats.org/presentationml/2006/main">
+  <p:cSld>
+    <p:spTree>
+      <p:nvGrpSpPr>
+        <p:cNvPr id="1" name=""/>
+        <p:cNvGrpSpPr/>
+        <p:nvPr/>
+      </p:nvGrpSpPr>
+      <p:grpSpPr>
+        <a:xfrm>
+          <a:off x="0" y="0"/>
+          <a:ext cx="0" cy="0"/>
+          <a:chOff x="0" y="0"/>
+          <a:chExt cx="0" cy="0"/>
+        </a:xfrm>
+      </p:grpSpPr>
+      <p:sp>
+        <p:nvSpPr>
+          <p:cNvPr id="2" name="Slide Image Placeholder 1"/>
+          <p:cNvSpPr>
+            <a:spLocks noGrp="1" noRot="1" noChangeAspect="1"/>
+          </p:cNvSpPr>
+          <p:nvPr>
+            <p:ph type="sldImg"/>
+          </p:nvPr>
+        </p:nvSpPr>
+        <p:spPr/>
+      </p:sp>
+      <p:sp>
+        <p:nvSpPr>
+          <p:cNvPr id="3" name="Notes Placeholder 2"/>
+          <p:cNvSpPr>
+            <a:spLocks noGrp="1"/>
+          </p:cNvSpPr>
+          <p:nvPr>
+            <p:ph type="body" idx="1"/>
+          </p:nvPr>
+        </p:nvSpPr>
+        <p:spPr/>
+        <p:txBody>
+          <a:bodyPr/>
+          <a:lstStyle/>
+          <a:p>
+            <a:r>
+              <a:rPr lang="en-US" dirty="0"/>
+              <a:t>[HARSH, about 20 seconds]
+To finish: where someone lives shouldn't decide how long they wait for water, power or a safe home.
+ReachNT fixes urgent remote repairs in days instead of months, for a cost we can see and name, and it makes someone own that choice.
+Thank you. We're happy to take questions.</a:t>
+            </a:r>
+            <a:endParaRPr lang="en-US" dirty="0"/>
+          </a:p>
+        </p:txBody>
+      </p:sp>
+      <p:sp>
+        <p:nvSpPr>
+          <p:cNvPr id="4" name="Slide Number Placeholder 3"/>
+          <p:cNvSpPr>
+            <a:spLocks noGrp="1"/>
+          </p:cNvSpPr>
+          <p:nvPr>
+            <p:ph type="sldNum" sz="quarter" idx="10"/>
+          </p:nvPr>
+        </p:nvSpPr>
+        <p:spPr/>
+        <p:txBody>
+          <a:bodyPr/>
+          <a:lstStyle/>
+          <a:p>
+            <a:fld id="{F7021451-1387-4CA6-816F-3879F97B5CBC}" type="slidenum">
+              <a:rPr lang="en-US"/>
+              <a:t>15</a:t>
             </a:fld>
             <a:endParaRPr lang="en-US"/>
           </a:p>
@@ -1688,11 +1781,10 @@
           <a:p>
             <a:r>
               <a:rPr lang="en-US" dirty="0"/>
-              <a:t>[AASHISH, about 50 seconds]
+              <a:t>[AASHISH, about 40 seconds]
 Here's the problem in four numbers.
 There are 70 remote communities in our model, with about 4,500 public houses.
-Repairs there cost far more. Government research found emergency repairs in very remote communities cost eight and a half times as much, and travel can be almost the whole bill.
-Katherine's tradespeople, for example, drive up to six hours to reach some communities.
+Emergency repairs in very remote communities cost eight and a half times as much, and travel can be almost the whole bill. Katherine's tradespeople drive up to six hours.
 So here is the kind of message a tenant gets from our simulation: no water to the house, waited 57 days, held up by travel cost. Notice the last line: nobody signed off on that. It just happened.</a:t>
             </a:r>
             <a:endParaRPr lang="en-US" dirty="0"/>
@@ -1873,12 +1965,12 @@
           <a:p>
             <a:r>
               <a:rPr lang="en-US" dirty="0"/>
-              <a:t>[HARSH, about 50 seconds]
+              <a:t>[HARSH, about 40 seconds]
 Thanks Aashish. ReachNT does four things.
-One: it reads the repair report the way the tenant said it, and works out the fault and how urgent it is. If it isn't sure, a person calls back.
-Two: it ranks repairs by need alone. Danger, health, who lives in the house, how long they've waited. Where you live is never part of your score.
-Three: every week it plans the trips. And when two communities are close, one tradesperson visits both on one trip. That's where H3 comes in, which I'll come back to.
-Four: cost still matters, but a named person has to sign how much it counts. And every tenant can see why their repair is where it is.</a:t>
+One: it reads the report the way the tenant said it. If it isn't sure, a person calls back.
+Two: it ranks repairs by need alone. Where you live is never part of your score.
+Three: every week it plans the trips, and close communities share one trip.
+Four: a named person signs how much cost counts, and every tenant can see why their repair is where it is.</a:t>
             </a:r>
             <a:endParaRPr lang="en-US" dirty="0"/>
           </a:p>
@@ -1966,10 +2058,10 @@
           <a:p>
             <a:r>
               <a:rPr lang="en-US" dirty="0"/>
-              <a:t>[HARSH, about 60 seconds]
+              <a:t>[HARSH, about 50 seconds]
 Now the AI. Tenants don't fill in forms. They say things like "no sparks now but the switch is black and the kids touch it".
-ReachNT reads that with two methods: word rules for phrases we know, and a learning model for wording the rules miss.
-The key design choice is that it knows when to ask. If it's unsure, or anything sounds dangerous, a person checks the same day. And it never downgrades danger on its own. In that example, "no sparks" doesn't make it safe.
+ReachNT reads that with word rules and a learning model for wording the rules miss.
+The key design choice: if it's unsure, or anything sounds dangerous, a person checks the same day, and it never downgrades danger on its own.
 We tested it on wording it had never seen. The model alone is decent, a ROC-AUC of 0.84. With the person in the loop, the system caught 99.3 percent of dangerous reports.
 And we're honest about its limits: its confidence isn't reliable, so we never show tenants a percentage.</a:t>
             </a:r>
@@ -2152,11 +2244,11 @@
           <a:p>
             <a:r>
               <a:rPr lang="en-US" dirty="0"/>
-              <a:t>[AASHISH, about 50 seconds]
+              <a:t>[AASHISH, about 40 seconds]
 This was my favourite decision. Early on I suggested Uber's H3, an open-source map grid made of hexagons, and Harsh built the whole system around it.
 Why hexagons? The middle square has neighbours at two different distances, the sides and the corners. A hexagon's six neighbours are all the same distance away.
 So "within two hexagons" means the same distance in every direction, and the rule for sharing a trip treats every community the same.
-And one grid does four jobs: shared trips, a house stored as a hexagon instead of an address, waiting times published by area without exposing any household, and the maps and "nearby jobs" list for tradespeople.</a:t>
+And one grid does four jobs: shared trips, privacy, public numbers by area, and the maps.</a:t>
             </a:r>
             <a:endParaRPr lang="en-US" dirty="0"/>
           </a:p>
@@ -2246,7 +2338,7 @@
               <a:rPr lang="en-US" dirty="0"/>
               <a:t>[HARSH, about 35 seconds]
 Every week Google's OR-Tools plans the trips around crew hours, road closures and airstrips. A job running out of time gets a boost onto the next trip.
-Instead of two trips out and back, one tradesperson does one loop, and H3 tells us which pairs are close enough.
+Instead of two trips out and back, one tradesperson does one loop, and H3 tells us which pairs are close enough. And a plumber and an electrician going to the same place share the ute or the plane.
 That saves about $73 on every repair, and because the savings buy more visits, households spend 18% fewer days living with faults.
 And it's fast: the solver proved 99.4 percent of over 25 thousand weekly plans to be the best possible plan.</a:t>
             </a:r>
@@ -2337,7 +2429,7 @@
             <a:r>
               <a:rPr lang="en-US" dirty="0"/>
               <a:t>[HARSH, about 50 seconds]
-So what does it buy? We ran a year of 37,508 made-up requests over the real Territory: real communities, roads, closures and costs.
+So what does it buy? A year of 37,508 made-up requests over the real Territory.
 Planning for the cheapest jobs costs $559 a repair. ReachNT costs $803. About 44% more.
 For that, nine in ten urgent remote repairs are fixed within 3 days instead of 62, and households live with faults for 73% fewer days. That's the chart.
 We didn't trust one lucky year, so we ran five. The result held every time.
@@ -3457,7 +3549,7 @@
         <p:spPr>
           <a:xfrm>
             <a:off x="548640" y="365760"/>
-            <a:ext cx="11064240" cy="777240"/>
+            <a:ext cx="11064240" cy="868680"/>
           </a:xfrm>
           <a:prstGeom prst="rect">
             <a:avLst/>
@@ -3473,78 +3565,55 @@
               <a:buNone/>
             </a:pPr>
             <a:r>
-              <a:rPr lang="en-US" sz="3000" b="1" dirty="0">
-                <a:solidFill>
-                  <a:schemeClr val="bg1"/>
+              <a:rPr lang="en-US" sz="2800" b="1" dirty="0">
+                <a:solidFill>
+                  <a:schemeClr val="tx1"/>
                 </a:solidFill>
                 <a:latin typeface="Arial" pitchFamily="34" charset="0"/>
                 <a:ea typeface="Arial" pitchFamily="34" charset="-122"/>
                 <a:cs typeface="Arial" pitchFamily="34" charset="-120"/>
               </a:rPr>
-              <a:t>Live now, on a real satellite map, and on any phone</a:t>
-            </a:r>
-            <a:endParaRPr lang="en-US" sz="3000" dirty="0"/>
-          </a:p>
-        </p:txBody>
-      </p:sp>
-      <p:pic>
-        <p:nvPicPr>
-          <p:cNvPr id="3" name="shot-coord" descr="shot-coord">    </p:cNvPr>
-          <p:cNvPicPr>
-            <a:picLocks noChangeAspect="1"/>
-          </p:cNvPicPr>
-          <p:nvPr/>
-        </p:nvPicPr>
-        <p:blipFill>
-          <a:blip r:embed="rId1"/>
-          <a:stretch>
-            <a:fillRect/>
-          </a:stretch>
-        </p:blipFill>
-        <p:spPr>
-          <a:xfrm>
-            <a:off x="548640" y="1280160"/>
-            <a:ext cx="6949440" cy="4343400"/>
-          </a:xfrm>
-          <a:prstGeom prst="rect">
-            <a:avLst/>
-          </a:prstGeom>
-        </p:spPr>
-      </p:pic>
-      <p:pic>
-        <p:nvPicPr>
-          <p:cNvPr id="4" name="shot-coord_phone" descr="shot-coord_phone">    </p:cNvPr>
-          <p:cNvPicPr>
-            <a:picLocks noChangeAspect="1"/>
-          </p:cNvPicPr>
-          <p:nvPr/>
-        </p:nvPicPr>
-        <p:blipFill>
-          <a:blip r:embed="rId2"/>
-          <a:stretch>
-            <a:fillRect/>
-          </a:stretch>
-        </p:blipFill>
-        <p:spPr>
-          <a:xfrm>
-            <a:off x="7818120" y="1280160"/>
-            <a:ext cx="1188720" cy="2569464"/>
-          </a:xfrm>
-          <a:prstGeom prst="rect">
-            <a:avLst/>
-          </a:prstGeom>
-        </p:spPr>
-      </p:pic>
-      <p:sp>
-        <p:nvSpPr>
-          <p:cNvPr id="5" name="shot-l-0"/>
-          <p:cNvSpPr txBox="1"/>
-          <p:nvPr/>
-        </p:nvSpPr>
-        <p:spPr>
-          <a:xfrm>
-            <a:off x="7726680" y="3931920"/>
-            <a:ext cx="1371600" cy="274320"/>
+              <a:t>Floods: surge crews, not other communities' trades</a:t>
+            </a:r>
+            <a:endParaRPr lang="en-US" sz="2800" dirty="0"/>
+          </a:p>
+        </p:txBody>
+      </p:sp>
+      <p:sp>
+        <p:nvSpPr>
+          <p:cNvPr id="3" name="resp-hex-0"/>
+          <p:cNvSpPr/>
+          <p:nvPr/>
+        </p:nvSpPr>
+        <p:spPr>
+          <a:xfrm>
+            <a:off x="548640" y="1472184"/>
+            <a:ext cx="512064" cy="450616"/>
+          </a:xfrm>
+          <a:prstGeom prst="hexagon">
+            <a:avLst/>
+          </a:prstGeom>
+          <a:solidFill>
+            <a:srgbClr val="E5352B"/>
+          </a:solidFill>
+          <a:ln w="12700">
+            <a:solidFill>
+              <a:srgbClr val="E5352B"/>
+            </a:solidFill>
+            <a:prstDash val="solid"/>
+          </a:ln>
+        </p:spPr>
+      </p:sp>
+      <p:sp>
+        <p:nvSpPr>
+          <p:cNvPr id="4" name="resp-h-0"/>
+          <p:cNvSpPr txBox="1"/>
+          <p:nvPr/>
+        </p:nvSpPr>
+        <p:spPr>
+          <a:xfrm>
+            <a:off x="1280160" y="1417320"/>
+            <a:ext cx="5669280" cy="347472"/>
           </a:xfrm>
           <a:prstGeom prst="rect">
             <a:avLst/>
@@ -3556,58 +3625,34 @@
           <a:bodyPr wrap="square" lIns="0" tIns="0" rIns="0" bIns="0" rtlCol="0" anchor="t"/>
           <a:lstStyle/>
           <a:p>
-            <a:pPr algn="ctr" indent="0" marL="0">
-              <a:buNone/>
-            </a:pPr>
-            <a:r>
-              <a:rPr lang="en-US" sz="1200" dirty="0">
-                <a:solidFill>
-                  <a:srgbClr val="C9CFD6"/>
+            <a:pPr indent="0" marL="0">
+              <a:buNone/>
+            </a:pPr>
+            <a:r>
+              <a:rPr lang="en-US" sz="1700" b="1" dirty="0">
+                <a:solidFill>
+                  <a:srgbClr val="14181D"/>
                 </a:solidFill>
                 <a:latin typeface="Calibri" pitchFamily="34" charset="0"/>
                 <a:ea typeface="Calibri" pitchFamily="34" charset="-122"/>
                 <a:cs typeface="Calibri" pitchFamily="34" charset="-120"/>
               </a:rPr>
-              <a:t>Coordinator</a:t>
-            </a:r>
-            <a:endParaRPr lang="en-US" sz="1200" dirty="0"/>
-          </a:p>
-        </p:txBody>
-      </p:sp>
-      <p:pic>
-        <p:nvPicPr>
-          <p:cNvPr id="6" name="shot-field_phone" descr="shot-field_phone">    </p:cNvPr>
-          <p:cNvPicPr>
-            <a:picLocks noChangeAspect="1"/>
-          </p:cNvPicPr>
-          <p:nvPr/>
-        </p:nvPicPr>
-        <p:blipFill>
-          <a:blip r:embed="rId3"/>
-          <a:stretch>
-            <a:fillRect/>
-          </a:stretch>
-        </p:blipFill>
-        <p:spPr>
-          <a:xfrm>
-            <a:off x="9116568" y="1280160"/>
-            <a:ext cx="1188720" cy="2569464"/>
-          </a:xfrm>
-          <a:prstGeom prst="rect">
-            <a:avLst/>
-          </a:prstGeom>
-        </p:spPr>
-      </p:pic>
-      <p:sp>
-        <p:nvSpPr>
-          <p:cNvPr id="7" name="shot-l-1"/>
-          <p:cNvSpPr txBox="1"/>
-          <p:nvPr/>
-        </p:nvSpPr>
-        <p:spPr>
-          <a:xfrm>
-            <a:off x="9025128" y="3931920"/>
-            <a:ext cx="1371600" cy="274320"/>
+              <a:t>Make every house safe within 48 hours</a:t>
+            </a:r>
+            <a:endParaRPr lang="en-US" sz="1700" dirty="0"/>
+          </a:p>
+        </p:txBody>
+      </p:sp>
+      <p:sp>
+        <p:nvSpPr>
+          <p:cNvPr id="5" name="resp-b-0"/>
+          <p:cNvSpPr txBox="1"/>
+          <p:nvPr/>
+        </p:nvSpPr>
+        <p:spPr>
+          <a:xfrm>
+            <a:off x="1280160" y="1783080"/>
+            <a:ext cx="5669280" cy="457200"/>
           </a:xfrm>
           <a:prstGeom prst="rect">
             <a:avLst/>
@@ -3619,58 +3664,59 @@
           <a:bodyPr wrap="square" lIns="0" tIns="0" rIns="0" bIns="0" rtlCol="0" anchor="t"/>
           <a:lstStyle/>
           <a:p>
-            <a:pPr algn="ctr" indent="0" marL="0">
-              <a:buNone/>
-            </a:pPr>
-            <a:r>
-              <a:rPr lang="en-US" sz="1200" dirty="0">
-                <a:solidFill>
-                  <a:srgbClr val="C9CFD6"/>
+            <a:pPr indent="0" marL="0">
+              <a:buNone/>
+            </a:pPr>
+            <a:r>
+              <a:rPr lang="en-US" sz="1400" dirty="0">
+                <a:solidFill>
+                  <a:srgbClr val="4A525C"/>
                 </a:solidFill>
                 <a:latin typeface="Calibri" pitchFamily="34" charset="0"/>
                 <a:ea typeface="Calibri" pitchFamily="34" charset="-122"/>
                 <a:cs typeface="Calibri" pitchFamily="34" charset="-120"/>
               </a:rPr>
-              <a:t>Tradesperson</a:t>
-            </a:r>
-            <a:endParaRPr lang="en-US" sz="1200" dirty="0"/>
-          </a:p>
-        </p:txBody>
-      </p:sp>
-      <p:pic>
-        <p:nvPicPr>
-          <p:cNvPr id="8" name="shot-tenant_phone" descr="shot-tenant_phone">    </p:cNvPr>
-          <p:cNvPicPr>
-            <a:picLocks noChangeAspect="1"/>
-          </p:cNvPicPr>
-          <p:nvPr/>
-        </p:nvPicPr>
-        <p:blipFill>
-          <a:blip r:embed="rId4"/>
-          <a:stretch>
-            <a:fillRect/>
-          </a:stretch>
-        </p:blipFill>
-        <p:spPr>
-          <a:xfrm>
-            <a:off x="10415016" y="1280160"/>
-            <a:ext cx="1188720" cy="2569464"/>
-          </a:xfrm>
-          <a:prstGeom prst="rect">
-            <a:avLst/>
-          </a:prstGeom>
-        </p:spPr>
-      </p:pic>
-      <p:sp>
-        <p:nvSpPr>
-          <p:cNvPr id="9" name="shot-l-2"/>
-          <p:cNvSpPr txBox="1"/>
-          <p:nvPr/>
-        </p:nvSpPr>
-        <p:spPr>
-          <a:xfrm>
-            <a:off x="10323576" y="3931920"/>
-            <a:ext cx="1371600" cy="274320"/>
+              <a:t>Maintenance and housing officers check each one; danger is made safe that day</a:t>
+            </a:r>
+            <a:endParaRPr lang="en-US" sz="1400" dirty="0"/>
+          </a:p>
+        </p:txBody>
+      </p:sp>
+      <p:sp>
+        <p:nvSpPr>
+          <p:cNvPr id="6" name="resp-hex-1"/>
+          <p:cNvSpPr/>
+          <p:nvPr/>
+        </p:nvSpPr>
+        <p:spPr>
+          <a:xfrm>
+            <a:off x="548640" y="2459736"/>
+            <a:ext cx="512064" cy="450616"/>
+          </a:xfrm>
+          <a:prstGeom prst="hexagon">
+            <a:avLst/>
+          </a:prstGeom>
+          <a:solidFill>
+            <a:srgbClr val="0E8FB8"/>
+          </a:solidFill>
+          <a:ln w="12700">
+            <a:solidFill>
+              <a:srgbClr val="0E8FB8"/>
+            </a:solidFill>
+            <a:prstDash val="solid"/>
+          </a:ln>
+        </p:spPr>
+      </p:sp>
+      <p:sp>
+        <p:nvSpPr>
+          <p:cNvPr id="7" name="resp-h-1"/>
+          <p:cNvSpPr txBox="1"/>
+          <p:nvPr/>
+        </p:nvSpPr>
+        <p:spPr>
+          <a:xfrm>
+            <a:off x="1280160" y="2404872"/>
+            <a:ext cx="5669280" cy="347472"/>
           </a:xfrm>
           <a:prstGeom prst="rect">
             <a:avLst/>
@@ -3682,34 +3728,34 @@
           <a:bodyPr wrap="square" lIns="0" tIns="0" rIns="0" bIns="0" rtlCol="0" anchor="t"/>
           <a:lstStyle/>
           <a:p>
-            <a:pPr algn="ctr" indent="0" marL="0">
-              <a:buNone/>
-            </a:pPr>
-            <a:r>
-              <a:rPr lang="en-US" sz="1200" dirty="0">
-                <a:solidFill>
-                  <a:srgbClr val="C9CFD6"/>
+            <a:pPr indent="0" marL="0">
+              <a:buNone/>
+            </a:pPr>
+            <a:r>
+              <a:rPr lang="en-US" sz="1700" b="1" dirty="0">
+                <a:solidFill>
+                  <a:srgbClr val="14181D"/>
                 </a:solidFill>
                 <a:latin typeface="Calibri" pitchFamily="34" charset="0"/>
                 <a:ea typeface="Calibri" pitchFamily="34" charset="-122"/>
                 <a:cs typeface="Calibri" pitchFamily="34" charset="-120"/>
               </a:rPr>
-              <a:t>Tenant</a:t>
-            </a:r>
-            <a:endParaRPr lang="en-US" sz="1200" dirty="0"/>
-          </a:p>
-        </p:txBody>
-      </p:sp>
-      <p:sp>
-        <p:nvSpPr>
-          <p:cNvPr id="10" name="feat-0"/>
-          <p:cNvSpPr txBox="1"/>
-          <p:nvPr/>
-        </p:nvSpPr>
-        <p:spPr>
-          <a:xfrm>
-            <a:off x="7818120" y="4434840"/>
-            <a:ext cx="3840480" cy="548640"/>
+              <a:t>One team, one trip</a:t>
+            </a:r>
+            <a:endParaRPr lang="en-US" sz="1700" dirty="0"/>
+          </a:p>
+        </p:txBody>
+      </p:sp>
+      <p:sp>
+        <p:nvSpPr>
+          <p:cNvPr id="8" name="resp-b-1"/>
+          <p:cNvSpPr txBox="1"/>
+          <p:nvPr/>
+        </p:nvSpPr>
+        <p:spPr>
+          <a:xfrm>
+            <a:off x="1280160" y="2770632"/>
+            <a:ext cx="5669280" cy="457200"/>
           </a:xfrm>
           <a:prstGeom prst="rect">
             <a:avLst/>
@@ -3721,35 +3767,59 @@
           <a:bodyPr wrap="square" lIns="0" tIns="0" rIns="0" bIns="0" rtlCol="0" anchor="t"/>
           <a:lstStyle/>
           <a:p>
-            <a:pPr marL="342900" indent="-342900">
-              <a:buSzPct val="100000"/>
-              <a:buChar char="•"/>
-            </a:pPr>
-            <a:r>
-              <a:rPr lang="en-US" sz="1300" dirty="0">
-                <a:solidFill>
-                  <a:srgbClr val="E3E7EB"/>
+            <a:pPr indent="0" marL="0">
+              <a:buNone/>
+            </a:pPr>
+            <a:r>
+              <a:rPr lang="en-US" sz="1400" dirty="0">
+                <a:solidFill>
+                  <a:srgbClr val="4A525C"/>
                 </a:solidFill>
                 <a:latin typeface="Calibri" pitchFamily="34" charset="0"/>
                 <a:ea typeface="Calibri" pitchFamily="34" charset="-122"/>
                 <a:cs typeface="Calibri" pitchFamily="34" charset="-120"/>
               </a:rPr>
-              <a:t>Anyone the tenant tells can log a report, with the same questions</a:t>
-            </a:r>
-            <a:endParaRPr lang="en-US" sz="1300" dirty="0"/>
-          </a:p>
-        </p:txBody>
-      </p:sp>
-      <p:sp>
-        <p:nvSpPr>
-          <p:cNvPr id="11" name="feat-1"/>
-          <p:cNvSpPr txBox="1"/>
-          <p:nvPr/>
-        </p:nvSpPr>
-        <p:spPr>
-          <a:xfrm>
-            <a:off x="7818120" y="5001768"/>
-            <a:ext cx="3840480" cy="548640"/>
+              <a:t>Plumber, electrician, carpenter and maintenance share the vehicle or the plane</a:t>
+            </a:r>
+            <a:endParaRPr lang="en-US" sz="1400" dirty="0"/>
+          </a:p>
+        </p:txBody>
+      </p:sp>
+      <p:sp>
+        <p:nvSpPr>
+          <p:cNvPr id="9" name="resp-hex-2"/>
+          <p:cNvSpPr/>
+          <p:nvPr/>
+        </p:nvSpPr>
+        <p:spPr>
+          <a:xfrm>
+            <a:off x="548640" y="3447288"/>
+            <a:ext cx="512064" cy="450616"/>
+          </a:xfrm>
+          <a:prstGeom prst="hexagon">
+            <a:avLst/>
+          </a:prstGeom>
+          <a:solidFill>
+            <a:srgbClr val="6E56CF"/>
+          </a:solidFill>
+          <a:ln w="12700">
+            <a:solidFill>
+              <a:srgbClr val="6E56CF"/>
+            </a:solidFill>
+            <a:prstDash val="solid"/>
+          </a:ln>
+        </p:spPr>
+      </p:sp>
+      <p:sp>
+        <p:nvSpPr>
+          <p:cNvPr id="10" name="resp-h-2"/>
+          <p:cNvSpPr txBox="1"/>
+          <p:nvPr/>
+        </p:nvSpPr>
+        <p:spPr>
+          <a:xfrm>
+            <a:off x="1280160" y="3392424"/>
+            <a:ext cx="5669280" cy="347472"/>
           </a:xfrm>
           <a:prstGeom prst="rect">
             <a:avLst/>
@@ -3761,35 +3831,34 @@
           <a:bodyPr wrap="square" lIns="0" tIns="0" rIns="0" bIns="0" rtlCol="0" anchor="t"/>
           <a:lstStyle/>
           <a:p>
-            <a:pPr marL="342900" indent="-342900">
-              <a:buSzPct val="100000"/>
-              <a:buChar char="•"/>
-            </a:pPr>
-            <a:r>
-              <a:rPr lang="en-US" sz="1300" dirty="0">
-                <a:solidFill>
-                  <a:srgbClr val="E3E7EB"/>
+            <a:pPr indent="0" marL="0">
+              <a:buNone/>
+            </a:pPr>
+            <a:r>
+              <a:rPr lang="en-US" sz="1700" b="1" dirty="0">
+                <a:solidFill>
+                  <a:srgbClr val="14181D"/>
                 </a:solidFill>
                 <a:latin typeface="Calibri" pitchFamily="34" charset="0"/>
                 <a:ea typeface="Calibri" pitchFamily="34" charset="-122"/>
                 <a:cs typeface="Calibri" pitchFamily="34" charset="-120"/>
               </a:rPr>
-              <a:t>Works without signal: updates are saved on the phone and sent later</a:t>
-            </a:r>
-            <a:endParaRPr lang="en-US" sz="1300" dirty="0"/>
-          </a:p>
-        </p:txBody>
-      </p:sp>
-      <p:sp>
-        <p:nvSpPr>
-          <p:cNvPr id="12" name="feat-2"/>
-          <p:cNvSpPr txBox="1"/>
-          <p:nvPr/>
-        </p:nvSpPr>
-        <p:spPr>
-          <a:xfrm>
-            <a:off x="7818120" y="5568696"/>
-            <a:ext cx="3840480" cy="548640"/>
+              <a:t>Surge crews from the contractor panel</a:t>
+            </a:r>
+            <a:endParaRPr lang="en-US" sz="1700" dirty="0"/>
+          </a:p>
+        </p:txBody>
+      </p:sp>
+      <p:sp>
+        <p:nvSpPr>
+          <p:cNvPr id="11" name="resp-b-2"/>
+          <p:cNvSpPr txBox="1"/>
+          <p:nvPr/>
+        </p:nvSpPr>
+        <p:spPr>
+          <a:xfrm>
+            <a:off x="1280160" y="3758184"/>
+            <a:ext cx="5669280" cy="457200"/>
           </a:xfrm>
           <a:prstGeom prst="rect">
             <a:avLst/>
@@ -3801,35 +3870,59 @@
           <a:bodyPr wrap="square" lIns="0" tIns="0" rIns="0" bIns="0" rtlCol="0" anchor="t"/>
           <a:lstStyle/>
           <a:p>
-            <a:pPr marL="342900" indent="-342900">
-              <a:buSzPct val="100000"/>
-              <a:buChar char="•"/>
-            </a:pPr>
-            <a:r>
-              <a:rPr lang="en-US" sz="1300" dirty="0">
-                <a:solidFill>
-                  <a:srgbClr val="E3E7EB"/>
+            <a:pPr indent="0" marL="0">
+              <a:buNone/>
+            </a:pPr>
+            <a:r>
+              <a:rPr lang="en-US" sz="1400" dirty="0">
+                <a:solidFill>
+                  <a:srgbClr val="4A525C"/>
                 </a:solidFill>
                 <a:latin typeface="Calibri" pitchFamily="34" charset="0"/>
                 <a:ea typeface="Calibri" pitchFamily="34" charset="-122"/>
                 <a:cs typeface="Calibri" pitchFamily="34" charset="-120"/>
               </a:rPr>
-              <a:t>Plain words, WCAG 2.2 AA checked, PDFs, no confidence percentages</a:t>
-            </a:r>
-            <a:endParaRPr lang="en-US" sz="1300" dirty="0"/>
-          </a:p>
-        </p:txBody>
-      </p:sp>
-      <p:sp>
-        <p:nvSpPr>
-          <p:cNvPr id="13" name="shot-url"/>
-          <p:cNvSpPr txBox="1"/>
-          <p:nvPr/>
-        </p:nvSpPr>
-        <p:spPr>
-          <a:xfrm>
-            <a:off x="548640" y="5760720"/>
-            <a:ext cx="6949440" cy="365760"/>
+              <a:t>Local Aboriginal Business Enterprises first; a named person signs the request</a:t>
+            </a:r>
+            <a:endParaRPr lang="en-US" sz="1400" dirty="0"/>
+          </a:p>
+        </p:txBody>
+      </p:sp>
+      <p:sp>
+        <p:nvSpPr>
+          <p:cNvPr id="12" name="resp-hex-3"/>
+          <p:cNvSpPr/>
+          <p:nvPr/>
+        </p:nvSpPr>
+        <p:spPr>
+          <a:xfrm>
+            <a:off x="548640" y="4434840"/>
+            <a:ext cx="512064" cy="450616"/>
+          </a:xfrm>
+          <a:prstGeom prst="hexagon">
+            <a:avLst/>
+          </a:prstGeom>
+          <a:solidFill>
+            <a:srgbClr val="1F9D4C"/>
+          </a:solidFill>
+          <a:ln w="12700">
+            <a:solidFill>
+              <a:srgbClr val="1F9D4C"/>
+            </a:solidFill>
+            <a:prstDash val="solid"/>
+          </a:ln>
+        </p:spPr>
+      </p:sp>
+      <p:sp>
+        <p:nvSpPr>
+          <p:cNvPr id="13" name="resp-h-3"/>
+          <p:cNvSpPr txBox="1"/>
+          <p:nvPr/>
+        </p:nvSpPr>
+        <p:spPr>
+          <a:xfrm>
+            <a:off x="1280160" y="4379976"/>
+            <a:ext cx="5669280" cy="347472"/>
           </a:xfrm>
           <a:prstGeom prst="rect">
             <a:avLst/>
@@ -3845,17 +3938,629 @@
               <a:buNone/>
             </a:pPr>
             <a:r>
-              <a:rPr lang="en-US" sz="1600" b="1" dirty="0">
-                <a:solidFill>
-                  <a:srgbClr val="64D2FF"/>
+              <a:rPr lang="en-US" sz="1700" b="1" dirty="0">
+                <a:solidFill>
+                  <a:srgbClr val="14181D"/>
                 </a:solidFill>
                 <a:latin typeface="Calibri" pitchFamily="34" charset="0"/>
                 <a:ea typeface="Calibri" pitchFamily="34" charset="-122"/>
                 <a:cs typeface="Calibri" pitchFamily="34" charset="-120"/>
               </a:rPr>
-              <a:t>reachnt.vercel.app</a:t>
-            </a:r>
-            <a:endParaRPr lang="en-US" sz="1600" dirty="0"/>
+              <a:t>Tell every household</a:t>
+            </a:r>
+            <a:endParaRPr lang="en-US" sz="1700" dirty="0"/>
+          </a:p>
+        </p:txBody>
+      </p:sp>
+      <p:sp>
+        <p:nvSpPr>
+          <p:cNvPr id="14" name="resp-b-3"/>
+          <p:cNvSpPr txBox="1"/>
+          <p:nvPr/>
+        </p:nvSpPr>
+        <p:spPr>
+          <a:xfrm>
+            <a:off x="1280160" y="4745736"/>
+            <a:ext cx="5669280" cy="457200"/>
+          </a:xfrm>
+          <a:prstGeom prst="rect">
+            <a:avLst/>
+          </a:prstGeom>
+          <a:noFill/>
+          <a:ln/>
+        </p:spPr>
+        <p:txBody>
+          <a:bodyPr wrap="square" lIns="0" tIns="0" rIns="0" bIns="0" rtlCol="0" anchor="t"/>
+          <a:lstStyle/>
+          <a:p>
+            <a:pPr indent="0" marL="0">
+              <a:buNone/>
+            </a:pPr>
+            <a:r>
+              <a:rPr lang="en-US" sz="1400" dirty="0">
+                <a:solidFill>
+                  <a:srgbClr val="4A525C"/>
+                </a:solidFill>
+                <a:latin typeface="Calibri" pitchFamily="34" charset="0"/>
+                <a:ea typeface="Calibri" pitchFamily="34" charset="-122"/>
+                <a:cs typeface="Calibri" pitchFamily="34" charset="-120"/>
+              </a:rPr>
+              <a:t>Hotline, housing officer, free interpreters; every report tagged to the event</a:t>
+            </a:r>
+            <a:endParaRPr lang="en-US" sz="1400" dirty="0"/>
+          </a:p>
+        </p:txBody>
+      </p:sp>
+      <p:sp>
+        <p:nvSpPr>
+          <p:cNvPr id="15" name="flood-card"/>
+          <p:cNvSpPr/>
+          <p:nvPr/>
+        </p:nvSpPr>
+        <p:spPr>
+          <a:xfrm>
+            <a:off x="7223760" y="1417320"/>
+            <a:ext cx="4389120" cy="4343400"/>
+          </a:xfrm>
+          <a:prstGeom prst="roundRect">
+            <a:avLst>
+              <a:gd name="adj" fmla="val 2105"/>
+            </a:avLst>
+          </a:prstGeom>
+          <a:solidFill>
+            <a:srgbClr val="F1F3F5"/>
+          </a:solidFill>
+          <a:ln w="12700">
+            <a:solidFill>
+              <a:srgbClr val="F1F3F5"/>
+            </a:solidFill>
+            <a:prstDash val="solid"/>
+          </a:ln>
+        </p:spPr>
+      </p:sp>
+      <p:sp>
+        <p:nvSpPr>
+          <p:cNvPr id="16" name="flood-h"/>
+          <p:cNvSpPr txBox="1"/>
+          <p:nvPr/>
+        </p:nvSpPr>
+        <p:spPr>
+          <a:xfrm>
+            <a:off x="7452360" y="1554480"/>
+            <a:ext cx="3931920" cy="365760"/>
+          </a:xfrm>
+          <a:prstGeom prst="rect">
+            <a:avLst/>
+          </a:prstGeom>
+          <a:noFill/>
+          <a:ln/>
+        </p:spPr>
+        <p:txBody>
+          <a:bodyPr wrap="square" lIns="0" tIns="0" rIns="0" bIns="0" rtlCol="0" anchor="t"/>
+          <a:lstStyle/>
+          <a:p>
+            <a:pPr indent="0" marL="0">
+              <a:buNone/>
+            </a:pPr>
+            <a:r>
+              <a:rPr lang="en-US" sz="1400" b="1" dirty="0">
+                <a:solidFill>
+                  <a:srgbClr val="14181D"/>
+                </a:solidFill>
+                <a:latin typeface="Calibri" pitchFamily="34" charset="0"/>
+                <a:ea typeface="Calibri" pitchFamily="34" charset="-122"/>
+                <a:cs typeface="Calibri" pitchFamily="34" charset="-120"/>
+              </a:rPr>
+              <a:t>Modelled flood: Kalkarindji, Daguragu, Pigeon Hole</a:t>
+            </a:r>
+            <a:endParaRPr lang="en-US" sz="1400" dirty="0"/>
+          </a:p>
+        </p:txBody>
+      </p:sp>
+      <p:sp>
+        <p:nvSpPr>
+          <p:cNvPr id="17" name="flood-sub"/>
+          <p:cNvSpPr txBox="1"/>
+          <p:nvPr/>
+        </p:nvSpPr>
+        <p:spPr>
+          <a:xfrm>
+            <a:off x="7452360" y="1920240"/>
+            <a:ext cx="3931920" cy="640080"/>
+          </a:xfrm>
+          <a:prstGeom prst="rect">
+            <a:avLst/>
+          </a:prstGeom>
+          <a:noFill/>
+          <a:ln/>
+        </p:spPr>
+        <p:txBody>
+          <a:bodyPr wrap="square" lIns="0" tIns="0" rIns="0" bIns="0" rtlCol="0" anchor="t"/>
+          <a:lstStyle/>
+          <a:p>
+            <a:pPr indent="0" marL="0">
+              <a:buNone/>
+            </a:pPr>
+            <a:r>
+              <a:rPr lang="en-US" sz="1300" dirty="0">
+                <a:solidFill>
+                  <a:srgbClr val="4A525C"/>
+                </a:solidFill>
+                <a:latin typeface="Calibri" pitchFamily="34" charset="0"/>
+                <a:ea typeface="Calibri" pitchFamily="34" charset="-122"/>
+                <a:cs typeface="Calibri" pitchFamily="34" charset="-120"/>
+              </a:rPr>
+              <a:t>94 repairs, roads cut for 4 weeks (like January 2023). 9 in 10 urgent repairs fixed within:</a:t>
+            </a:r>
+            <a:endParaRPr lang="en-US" sz="1300" dirty="0"/>
+          </a:p>
+        </p:txBody>
+      </p:sp>
+      <p:sp>
+        <p:nvSpPr>
+          <p:cNvPr id="18" name="fl-event-l"/>
+          <p:cNvSpPr txBox="1"/>
+          <p:nvPr/>
+        </p:nvSpPr>
+        <p:spPr>
+          <a:xfrm>
+            <a:off x="7452360" y="2606040"/>
+            <a:ext cx="3931920" cy="320040"/>
+          </a:xfrm>
+          <a:prstGeom prst="rect">
+            <a:avLst/>
+          </a:prstGeom>
+          <a:noFill/>
+          <a:ln/>
+        </p:spPr>
+        <p:txBody>
+          <a:bodyPr wrap="square" lIns="0" tIns="0" rIns="0" bIns="0" rtlCol="0" anchor="t"/>
+          <a:lstStyle/>
+          <a:p>
+            <a:pPr indent="0" marL="0">
+              <a:buNone/>
+            </a:pPr>
+            <a:r>
+              <a:rPr lang="en-US" sz="1400" b="1" dirty="0">
+                <a:solidFill>
+                  <a:srgbClr val="14181D"/>
+                </a:solidFill>
+                <a:latin typeface="Calibri" pitchFamily="34" charset="0"/>
+                <a:ea typeface="Calibri" pitchFamily="34" charset="-122"/>
+                <a:cs typeface="Calibri" pitchFamily="34" charset="-120"/>
+              </a:rPr>
+              <a:t>In the flooded communities</a:t>
+            </a:r>
+            <a:endParaRPr lang="en-US" sz="1400" dirty="0"/>
+          </a:p>
+        </p:txBody>
+      </p:sp>
+      <p:sp>
+        <p:nvSpPr>
+          <p:cNvPr id="19" name="fl-event-n0"/>
+          <p:cNvSpPr txBox="1"/>
+          <p:nvPr/>
+        </p:nvSpPr>
+        <p:spPr>
+          <a:xfrm>
+            <a:off x="7452360" y="2935224"/>
+            <a:ext cx="1920240" cy="457200"/>
+          </a:xfrm>
+          <a:prstGeom prst="rect">
+            <a:avLst/>
+          </a:prstGeom>
+          <a:noFill/>
+          <a:ln/>
+        </p:spPr>
+        <p:txBody>
+          <a:bodyPr wrap="square" lIns="0" tIns="0" rIns="0" bIns="0" rtlCol="0" anchor="t"/>
+          <a:lstStyle/>
+          <a:p>
+            <a:pPr indent="0" marL="0">
+              <a:buNone/>
+            </a:pPr>
+            <a:r>
+              <a:rPr lang="en-US" sz="2600" b="1" dirty="0">
+                <a:solidFill>
+                  <a:srgbClr val="D97706"/>
+                </a:solidFill>
+                <a:latin typeface="Arial" pitchFamily="34" charset="0"/>
+                <a:ea typeface="Arial" pitchFamily="34" charset="-122"/>
+                <a:cs typeface="Arial" pitchFamily="34" charset="-120"/>
+              </a:rPr>
+              <a:t>15 days</a:t>
+            </a:r>
+            <a:endParaRPr lang="en-US" sz="2600" dirty="0"/>
+          </a:p>
+        </p:txBody>
+      </p:sp>
+      <p:sp>
+        <p:nvSpPr>
+          <p:cNvPr id="20" name="fl-event-u0"/>
+          <p:cNvSpPr txBox="1"/>
+          <p:nvPr/>
+        </p:nvSpPr>
+        <p:spPr>
+          <a:xfrm>
+            <a:off x="7452360" y="3374136"/>
+            <a:ext cx="1920240" cy="274320"/>
+          </a:xfrm>
+          <a:prstGeom prst="rect">
+            <a:avLst/>
+          </a:prstGeom>
+          <a:noFill/>
+          <a:ln/>
+        </p:spPr>
+        <p:txBody>
+          <a:bodyPr wrap="square" lIns="0" tIns="0" rIns="0" bIns="0" rtlCol="0" anchor="t"/>
+          <a:lstStyle/>
+          <a:p>
+            <a:pPr indent="0" marL="0">
+              <a:buNone/>
+            </a:pPr>
+            <a:r>
+              <a:rPr lang="en-US" sz="1200" dirty="0">
+                <a:solidFill>
+                  <a:srgbClr val="6B7480"/>
+                </a:solidFill>
+                <a:latin typeface="Calibri" pitchFamily="34" charset="0"/>
+                <a:ea typeface="Calibri" pitchFamily="34" charset="-122"/>
+                <a:cs typeface="Calibri" pitchFamily="34" charset="-120"/>
+              </a:rPr>
+              <a:t>usual crews</a:t>
+            </a:r>
+            <a:endParaRPr lang="en-US" sz="1200" dirty="0"/>
+          </a:p>
+        </p:txBody>
+      </p:sp>
+      <p:sp>
+        <p:nvSpPr>
+          <p:cNvPr id="21" name="fl-event-n1"/>
+          <p:cNvSpPr txBox="1"/>
+          <p:nvPr/>
+        </p:nvSpPr>
+        <p:spPr>
+          <a:xfrm>
+            <a:off x="9464040" y="2935224"/>
+            <a:ext cx="1920240" cy="457200"/>
+          </a:xfrm>
+          <a:prstGeom prst="rect">
+            <a:avLst/>
+          </a:prstGeom>
+          <a:noFill/>
+          <a:ln/>
+        </p:spPr>
+        <p:txBody>
+          <a:bodyPr wrap="square" lIns="0" tIns="0" rIns="0" bIns="0" rtlCol="0" anchor="t"/>
+          <a:lstStyle/>
+          <a:p>
+            <a:pPr indent="0" marL="0">
+              <a:buNone/>
+            </a:pPr>
+            <a:r>
+              <a:rPr lang="en-US" sz="2600" b="1" dirty="0">
+                <a:solidFill>
+                  <a:srgbClr val="1F9D4C"/>
+                </a:solidFill>
+                <a:latin typeface="Arial" pitchFamily="34" charset="0"/>
+                <a:ea typeface="Arial" pitchFamily="34" charset="-122"/>
+                <a:cs typeface="Arial" pitchFamily="34" charset="-120"/>
+              </a:rPr>
+              <a:t>3 days</a:t>
+            </a:r>
+            <a:endParaRPr lang="en-US" sz="2600" dirty="0"/>
+          </a:p>
+        </p:txBody>
+      </p:sp>
+      <p:sp>
+        <p:nvSpPr>
+          <p:cNvPr id="22" name="fl-event-u1"/>
+          <p:cNvSpPr txBox="1"/>
+          <p:nvPr/>
+        </p:nvSpPr>
+        <p:spPr>
+          <a:xfrm>
+            <a:off x="9464040" y="3374136"/>
+            <a:ext cx="1920240" cy="274320"/>
+          </a:xfrm>
+          <a:prstGeom prst="rect">
+            <a:avLst/>
+          </a:prstGeom>
+          <a:noFill/>
+          <a:ln/>
+        </p:spPr>
+        <p:txBody>
+          <a:bodyPr wrap="square" lIns="0" tIns="0" rIns="0" bIns="0" rtlCol="0" anchor="t"/>
+          <a:lstStyle/>
+          <a:p>
+            <a:pPr indent="0" marL="0">
+              <a:buNone/>
+            </a:pPr>
+            <a:r>
+              <a:rPr lang="en-US" sz="1200" dirty="0">
+                <a:solidFill>
+                  <a:srgbClr val="6B7480"/>
+                </a:solidFill>
+                <a:latin typeface="Calibri" pitchFamily="34" charset="0"/>
+                <a:ea typeface="Calibri" pitchFamily="34" charset="-122"/>
+                <a:cs typeface="Calibri" pitchFamily="34" charset="-120"/>
+              </a:rPr>
+              <a:t>surge crews</a:t>
+            </a:r>
+            <a:endParaRPr lang="en-US" sz="1200" dirty="0"/>
+          </a:p>
+        </p:txBody>
+      </p:sp>
+      <p:sp>
+        <p:nvSpPr>
+          <p:cNvPr id="23" name="fl-other-l"/>
+          <p:cNvSpPr txBox="1"/>
+          <p:nvPr/>
+        </p:nvSpPr>
+        <p:spPr>
+          <a:xfrm>
+            <a:off x="7452360" y="3749040"/>
+            <a:ext cx="3931920" cy="320040"/>
+          </a:xfrm>
+          <a:prstGeom prst="rect">
+            <a:avLst/>
+          </a:prstGeom>
+          <a:noFill/>
+          <a:ln/>
+        </p:spPr>
+        <p:txBody>
+          <a:bodyPr wrap="square" lIns="0" tIns="0" rIns="0" bIns="0" rtlCol="0" anchor="t"/>
+          <a:lstStyle/>
+          <a:p>
+            <a:pPr indent="0" marL="0">
+              <a:buNone/>
+            </a:pPr>
+            <a:r>
+              <a:rPr lang="en-US" sz="1400" b="1" dirty="0">
+                <a:solidFill>
+                  <a:srgbClr val="14181D"/>
+                </a:solidFill>
+                <a:latin typeface="Calibri" pitchFamily="34" charset="0"/>
+                <a:ea typeface="Calibri" pitchFamily="34" charset="-122"/>
+                <a:cs typeface="Calibri" pitchFamily="34" charset="-120"/>
+              </a:rPr>
+              <a:t>Everywhere else in the hub (3 with no flood)</a:t>
+            </a:r>
+            <a:endParaRPr lang="en-US" sz="1400" dirty="0"/>
+          </a:p>
+        </p:txBody>
+      </p:sp>
+      <p:sp>
+        <p:nvSpPr>
+          <p:cNvPr id="24" name="fl-other-n0"/>
+          <p:cNvSpPr txBox="1"/>
+          <p:nvPr/>
+        </p:nvSpPr>
+        <p:spPr>
+          <a:xfrm>
+            <a:off x="7452360" y="4078224"/>
+            <a:ext cx="1920240" cy="457200"/>
+          </a:xfrm>
+          <a:prstGeom prst="rect">
+            <a:avLst/>
+          </a:prstGeom>
+          <a:noFill/>
+          <a:ln/>
+        </p:spPr>
+        <p:txBody>
+          <a:bodyPr wrap="square" lIns="0" tIns="0" rIns="0" bIns="0" rtlCol="0" anchor="t"/>
+          <a:lstStyle/>
+          <a:p>
+            <a:pPr indent="0" marL="0">
+              <a:buNone/>
+            </a:pPr>
+            <a:r>
+              <a:rPr lang="en-US" sz="2600" b="1" dirty="0">
+                <a:solidFill>
+                  <a:srgbClr val="D97706"/>
+                </a:solidFill>
+                <a:latin typeface="Arial" pitchFamily="34" charset="0"/>
+                <a:ea typeface="Arial" pitchFamily="34" charset="-122"/>
+                <a:cs typeface="Arial" pitchFamily="34" charset="-120"/>
+              </a:rPr>
+              <a:t>10 days</a:t>
+            </a:r>
+            <a:endParaRPr lang="en-US" sz="2600" dirty="0"/>
+          </a:p>
+        </p:txBody>
+      </p:sp>
+      <p:sp>
+        <p:nvSpPr>
+          <p:cNvPr id="25" name="fl-other-u0"/>
+          <p:cNvSpPr txBox="1"/>
+          <p:nvPr/>
+        </p:nvSpPr>
+        <p:spPr>
+          <a:xfrm>
+            <a:off x="7452360" y="4517136"/>
+            <a:ext cx="1920240" cy="274320"/>
+          </a:xfrm>
+          <a:prstGeom prst="rect">
+            <a:avLst/>
+          </a:prstGeom>
+          <a:noFill/>
+          <a:ln/>
+        </p:spPr>
+        <p:txBody>
+          <a:bodyPr wrap="square" lIns="0" tIns="0" rIns="0" bIns="0" rtlCol="0" anchor="t"/>
+          <a:lstStyle/>
+          <a:p>
+            <a:pPr indent="0" marL="0">
+              <a:buNone/>
+            </a:pPr>
+            <a:r>
+              <a:rPr lang="en-US" sz="1200" dirty="0">
+                <a:solidFill>
+                  <a:srgbClr val="6B7480"/>
+                </a:solidFill>
+                <a:latin typeface="Calibri" pitchFamily="34" charset="0"/>
+                <a:ea typeface="Calibri" pitchFamily="34" charset="-122"/>
+                <a:cs typeface="Calibri" pitchFamily="34" charset="-120"/>
+              </a:rPr>
+              <a:t>usual crews</a:t>
+            </a:r>
+            <a:endParaRPr lang="en-US" sz="1200" dirty="0"/>
+          </a:p>
+        </p:txBody>
+      </p:sp>
+      <p:sp>
+        <p:nvSpPr>
+          <p:cNvPr id="26" name="fl-other-n1"/>
+          <p:cNvSpPr txBox="1"/>
+          <p:nvPr/>
+        </p:nvSpPr>
+        <p:spPr>
+          <a:xfrm>
+            <a:off x="9464040" y="4078224"/>
+            <a:ext cx="1920240" cy="457200"/>
+          </a:xfrm>
+          <a:prstGeom prst="rect">
+            <a:avLst/>
+          </a:prstGeom>
+          <a:noFill/>
+          <a:ln/>
+        </p:spPr>
+        <p:txBody>
+          <a:bodyPr wrap="square" lIns="0" tIns="0" rIns="0" bIns="0" rtlCol="0" anchor="t"/>
+          <a:lstStyle/>
+          <a:p>
+            <a:pPr indent="0" marL="0">
+              <a:buNone/>
+            </a:pPr>
+            <a:r>
+              <a:rPr lang="en-US" sz="2600" b="1" dirty="0">
+                <a:solidFill>
+                  <a:srgbClr val="1F9D4C"/>
+                </a:solidFill>
+                <a:latin typeface="Arial" pitchFamily="34" charset="0"/>
+                <a:ea typeface="Arial" pitchFamily="34" charset="-122"/>
+                <a:cs typeface="Arial" pitchFamily="34" charset="-120"/>
+              </a:rPr>
+              <a:t>3 days</a:t>
+            </a:r>
+            <a:endParaRPr lang="en-US" sz="2600" dirty="0"/>
+          </a:p>
+        </p:txBody>
+      </p:sp>
+      <p:sp>
+        <p:nvSpPr>
+          <p:cNvPr id="27" name="fl-other-u1"/>
+          <p:cNvSpPr txBox="1"/>
+          <p:nvPr/>
+        </p:nvSpPr>
+        <p:spPr>
+          <a:xfrm>
+            <a:off x="9464040" y="4517136"/>
+            <a:ext cx="1920240" cy="274320"/>
+          </a:xfrm>
+          <a:prstGeom prst="rect">
+            <a:avLst/>
+          </a:prstGeom>
+          <a:noFill/>
+          <a:ln/>
+        </p:spPr>
+        <p:txBody>
+          <a:bodyPr wrap="square" lIns="0" tIns="0" rIns="0" bIns="0" rtlCol="0" anchor="t"/>
+          <a:lstStyle/>
+          <a:p>
+            <a:pPr indent="0" marL="0">
+              <a:buNone/>
+            </a:pPr>
+            <a:r>
+              <a:rPr lang="en-US" sz="1200" dirty="0">
+                <a:solidFill>
+                  <a:srgbClr val="6B7480"/>
+                </a:solidFill>
+                <a:latin typeface="Calibri" pitchFamily="34" charset="0"/>
+                <a:ea typeface="Calibri" pitchFamily="34" charset="-122"/>
+                <a:cs typeface="Calibri" pitchFamily="34" charset="-120"/>
+              </a:rPr>
+              <a:t>surge crews</a:t>
+            </a:r>
+            <a:endParaRPr lang="en-US" sz="1200" dirty="0"/>
+          </a:p>
+        </p:txBody>
+      </p:sp>
+      <p:sp>
+        <p:nvSpPr>
+          <p:cNvPr id="28" name="fl-safe"/>
+          <p:cNvSpPr txBox="1"/>
+          <p:nvPr/>
+        </p:nvSpPr>
+        <p:spPr>
+          <a:xfrm>
+            <a:off x="7452360" y="5029200"/>
+            <a:ext cx="3931920" cy="640080"/>
+          </a:xfrm>
+          <a:prstGeom prst="rect">
+            <a:avLst/>
+          </a:prstGeom>
+          <a:noFill/>
+          <a:ln/>
+        </p:spPr>
+        <p:txBody>
+          <a:bodyPr wrap="square" lIns="0" tIns="0" rIns="0" bIns="0" rtlCol="0" anchor="t"/>
+          <a:lstStyle/>
+          <a:p>
+            <a:pPr indent="0" marL="0">
+              <a:buNone/>
+            </a:pPr>
+            <a:r>
+              <a:rPr lang="en-US" sz="1300" i="1" dirty="0">
+                <a:solidFill>
+                  <a:srgbClr val="4A525C"/>
+                </a:solidFill>
+                <a:latin typeface="Calibri" pitchFamily="34" charset="0"/>
+                <a:ea typeface="Calibri" pitchFamily="34" charset="-122"/>
+                <a:cs typeface="Calibri" pitchFamily="34" charset="-120"/>
+              </a:rPr>
+              <a:t>Every dangerous fault was made safe the day it was reported.</a:t>
+            </a:r>
+            <a:endParaRPr lang="en-US" sz="1300" dirty="0"/>
+          </a:p>
+        </p:txBody>
+      </p:sp>
+      <p:sp>
+        <p:nvSpPr>
+          <p:cNvPr id="29" name="fl-foot"/>
+          <p:cNvSpPr txBox="1"/>
+          <p:nvPr/>
+        </p:nvSpPr>
+        <p:spPr>
+          <a:xfrm>
+            <a:off x="548640" y="5532120"/>
+            <a:ext cx="6400800" cy="685800"/>
+          </a:xfrm>
+          <a:prstGeom prst="rect">
+            <a:avLst/>
+          </a:prstGeom>
+          <a:noFill/>
+          <a:ln/>
+        </p:spPr>
+        <p:txBody>
+          <a:bodyPr wrap="square" lIns="0" tIns="0" rIns="0" bIns="0" rtlCol="0" anchor="t"/>
+          <a:lstStyle/>
+          <a:p>
+            <a:pPr indent="0" marL="0">
+              <a:buNone/>
+            </a:pPr>
+            <a:r>
+              <a:rPr lang="en-US" sz="1350" i="1" dirty="0">
+                <a:solidFill>
+                  <a:srgbClr val="4A525C"/>
+                </a:solidFill>
+                <a:latin typeface="Calibri" pitchFamily="34" charset="0"/>
+                <a:ea typeface="Calibri" pitchFamily="34" charset="-122"/>
+                <a:cs typeface="Calibri" pitchFamily="34" charset="-120"/>
+              </a:rPr>
+              <a:t>Need still sets the order inside the flooded area. The question for fairness is everyone else: without surge crews, the flood quietly takes their trades.</a:t>
+            </a:r>
+            <a:endParaRPr lang="en-US" sz="1350" dirty="0"/>
           </a:p>
         </p:txBody>
       </p:sp>
@@ -3889,7 +4594,7 @@
             <a:lvl1pPr>
               <a:defRPr sz="1000">
                 <a:solidFill>
-                  <a:srgbClr val="9AA3AD"/>
+                  <a:srgbClr val="6B7480"/>
                 </a:solidFill>
               </a:defRPr>
             </a:lvl1pPr>
@@ -3940,7 +4645,7 @@
         <p:spPr>
           <a:xfrm>
             <a:off x="548640" y="365760"/>
-            <a:ext cx="11064240" cy="868680"/>
+            <a:ext cx="11064240" cy="777240"/>
           </a:xfrm>
           <a:prstGeom prst="rect">
             <a:avLst/>
@@ -3956,23 +4661,23 @@
               <a:buNone/>
             </a:pPr>
             <a:r>
-              <a:rPr lang="en-US" sz="2800" b="1" dirty="0">
-                <a:solidFill>
-                  <a:schemeClr val="tx1"/>
+              <a:rPr lang="en-US" sz="3000" b="1" dirty="0">
+                <a:solidFill>
+                  <a:schemeClr val="bg1"/>
                 </a:solidFill>
                 <a:latin typeface="Arial" pitchFamily="34" charset="0"/>
                 <a:ea typeface="Arial" pitchFamily="34" charset="-122"/>
                 <a:cs typeface="Arial" pitchFamily="34" charset="-120"/>
               </a:rPr>
-              <a:t>People stay in charge, and tenants can push back</a:t>
-            </a:r>
-            <a:endParaRPr lang="en-US" sz="2800" dirty="0"/>
+              <a:t>Live now, on a real satellite map, and on any phone</a:t>
+            </a:r>
+            <a:endParaRPr lang="en-US" sz="3000" dirty="0"/>
           </a:p>
         </p:txBody>
       </p:sp>
       <p:pic>
         <p:nvPicPr>
-          <p:cNvPr id="3" name="trust-phone" descr="trust-phone">    </p:cNvPr>
+          <p:cNvPr id="3" name="shot-coord" descr="shot-coord">    </p:cNvPr>
           <p:cNvPicPr>
             <a:picLocks noChangeAspect="1"/>
           </p:cNvPicPr>
@@ -3986,49 +4691,48 @@
         </p:blipFill>
         <p:spPr>
           <a:xfrm>
-            <a:off x="548640" y="1325880"/>
-            <a:ext cx="2194560" cy="4754880"/>
+            <a:off x="548640" y="1280160"/>
+            <a:ext cx="6949440" cy="4343400"/>
           </a:xfrm>
           <a:prstGeom prst="rect">
             <a:avLst/>
           </a:prstGeom>
         </p:spPr>
       </p:pic>
-      <p:sp>
-        <p:nvSpPr>
-          <p:cNvPr id="4" name="trust-hex-0"/>
-          <p:cNvSpPr/>
-          <p:nvPr/>
-        </p:nvSpPr>
-        <p:spPr>
-          <a:xfrm>
-            <a:off x="3108960" y="1335024"/>
-            <a:ext cx="512064" cy="450616"/>
-          </a:xfrm>
-          <a:prstGeom prst="hexagon">
-            <a:avLst/>
-          </a:prstGeom>
-          <a:solidFill>
-            <a:srgbClr val="D97706"/>
-          </a:solidFill>
-          <a:ln w="12700">
-            <a:solidFill>
-              <a:srgbClr val="D97706"/>
-            </a:solidFill>
-            <a:prstDash val="solid"/>
-          </a:ln>
-        </p:spPr>
-      </p:sp>
-      <p:sp>
-        <p:nvSpPr>
-          <p:cNvPr id="5" name="trust-h-0"/>
-          <p:cNvSpPr txBox="1"/>
-          <p:nvPr/>
-        </p:nvSpPr>
-        <p:spPr>
-          <a:xfrm>
-            <a:off x="3840480" y="1280160"/>
-            <a:ext cx="7772400" cy="347472"/>
+      <p:pic>
+        <p:nvPicPr>
+          <p:cNvPr id="4" name="shot-coord_phone" descr="shot-coord_phone">    </p:cNvPr>
+          <p:cNvPicPr>
+            <a:picLocks noChangeAspect="1"/>
+          </p:cNvPicPr>
+          <p:nvPr/>
+        </p:nvPicPr>
+        <p:blipFill>
+          <a:blip r:embed="rId2"/>
+          <a:stretch>
+            <a:fillRect/>
+          </a:stretch>
+        </p:blipFill>
+        <p:spPr>
+          <a:xfrm>
+            <a:off x="7818120" y="1280160"/>
+            <a:ext cx="1188720" cy="2569464"/>
+          </a:xfrm>
+          <a:prstGeom prst="rect">
+            <a:avLst/>
+          </a:prstGeom>
+        </p:spPr>
+      </p:pic>
+      <p:sp>
+        <p:nvSpPr>
+          <p:cNvPr id="5" name="shot-l-0"/>
+          <p:cNvSpPr txBox="1"/>
+          <p:nvPr/>
+        </p:nvSpPr>
+        <p:spPr>
+          <a:xfrm>
+            <a:off x="7726680" y="3931920"/>
+            <a:ext cx="1371600" cy="274320"/>
           </a:xfrm>
           <a:prstGeom prst="rect">
             <a:avLst/>
@@ -4040,34 +4744,58 @@
           <a:bodyPr wrap="square" lIns="0" tIns="0" rIns="0" bIns="0" rtlCol="0" anchor="t"/>
           <a:lstStyle/>
           <a:p>
-            <a:pPr indent="0" marL="0">
-              <a:buNone/>
-            </a:pPr>
-            <a:r>
-              <a:rPr lang="en-US" sz="1700" b="1" dirty="0">
-                <a:solidFill>
-                  <a:srgbClr val="14181D"/>
+            <a:pPr algn="ctr" indent="0" marL="0">
+              <a:buNone/>
+            </a:pPr>
+            <a:r>
+              <a:rPr lang="en-US" sz="1200" dirty="0">
+                <a:solidFill>
+                  <a:srgbClr val="C9CFD6"/>
                 </a:solidFill>
                 <a:latin typeface="Calibri" pitchFamily="34" charset="0"/>
                 <a:ea typeface="Calibri" pitchFamily="34" charset="-122"/>
                 <a:cs typeface="Calibri" pitchFamily="34" charset="-120"/>
               </a:rPr>
-              <a:t>A named person signs the trade-off</a:t>
-            </a:r>
-            <a:endParaRPr lang="en-US" sz="1700" dirty="0"/>
-          </a:p>
-        </p:txBody>
-      </p:sp>
-      <p:sp>
-        <p:nvSpPr>
-          <p:cNvPr id="6" name="trust-b-0"/>
-          <p:cNvSpPr txBox="1"/>
-          <p:nvPr/>
-        </p:nvSpPr>
-        <p:spPr>
-          <a:xfrm>
-            <a:off x="3840480" y="1636776"/>
-            <a:ext cx="7772400" cy="411480"/>
+              <a:t>Coordinator</a:t>
+            </a:r>
+            <a:endParaRPr lang="en-US" sz="1200" dirty="0"/>
+          </a:p>
+        </p:txBody>
+      </p:sp>
+      <p:pic>
+        <p:nvPicPr>
+          <p:cNvPr id="6" name="shot-field_phone" descr="shot-field_phone">    </p:cNvPr>
+          <p:cNvPicPr>
+            <a:picLocks noChangeAspect="1"/>
+          </p:cNvPicPr>
+          <p:nvPr/>
+        </p:nvPicPr>
+        <p:blipFill>
+          <a:blip r:embed="rId3"/>
+          <a:stretch>
+            <a:fillRect/>
+          </a:stretch>
+        </p:blipFill>
+        <p:spPr>
+          <a:xfrm>
+            <a:off x="9116568" y="1280160"/>
+            <a:ext cx="1188720" cy="2569464"/>
+          </a:xfrm>
+          <a:prstGeom prst="rect">
+            <a:avLst/>
+          </a:prstGeom>
+        </p:spPr>
+      </p:pic>
+      <p:sp>
+        <p:nvSpPr>
+          <p:cNvPr id="7" name="shot-l-1"/>
+          <p:cNvSpPr txBox="1"/>
+          <p:nvPr/>
+        </p:nvSpPr>
+        <p:spPr>
+          <a:xfrm>
+            <a:off x="9025128" y="3931920"/>
+            <a:ext cx="1371600" cy="274320"/>
           </a:xfrm>
           <a:prstGeom prst="rect">
             <a:avLst/>
@@ -4079,59 +4807,58 @@
           <a:bodyPr wrap="square" lIns="0" tIns="0" rIns="0" bIns="0" rtlCol="0" anchor="t"/>
           <a:lstStyle/>
           <a:p>
-            <a:pPr indent="0" marL="0">
-              <a:buNone/>
-            </a:pPr>
-            <a:r>
-              <a:rPr lang="en-US" sz="1400" dirty="0">
-                <a:solidFill>
-                  <a:srgbClr val="4A525C"/>
+            <a:pPr algn="ctr" indent="0" marL="0">
+              <a:buNone/>
+            </a:pPr>
+            <a:r>
+              <a:rPr lang="en-US" sz="1200" dirty="0">
+                <a:solidFill>
+                  <a:srgbClr val="C9CFD6"/>
                 </a:solidFill>
                 <a:latin typeface="Calibri" pitchFamily="34" charset="0"/>
                 <a:ea typeface="Calibri" pitchFamily="34" charset="-122"/>
                 <a:cs typeface="Calibri" pitchFamily="34" charset="-120"/>
               </a:rPr>
-              <a:t>How much cost may count is a signed decision, kept in a tamper-evident record</a:t>
-            </a:r>
-            <a:endParaRPr lang="en-US" sz="1400" dirty="0"/>
-          </a:p>
-        </p:txBody>
-      </p:sp>
-      <p:sp>
-        <p:nvSpPr>
-          <p:cNvPr id="7" name="trust-hex-1"/>
-          <p:cNvSpPr/>
-          <p:nvPr/>
-        </p:nvSpPr>
-        <p:spPr>
-          <a:xfrm>
-            <a:off x="3108960" y="2148840"/>
-            <a:ext cx="512064" cy="450616"/>
-          </a:xfrm>
-          <a:prstGeom prst="hexagon">
-            <a:avLst/>
-          </a:prstGeom>
-          <a:solidFill>
-            <a:srgbClr val="E5352B"/>
-          </a:solidFill>
-          <a:ln w="12700">
-            <a:solidFill>
-              <a:srgbClr val="E5352B"/>
-            </a:solidFill>
-            <a:prstDash val="solid"/>
-          </a:ln>
-        </p:spPr>
-      </p:sp>
-      <p:sp>
-        <p:nvSpPr>
-          <p:cNvPr id="8" name="trust-h-1"/>
-          <p:cNvSpPr txBox="1"/>
-          <p:nvPr/>
-        </p:nvSpPr>
-        <p:spPr>
-          <a:xfrm>
-            <a:off x="3840480" y="2093976"/>
-            <a:ext cx="7772400" cy="347472"/>
+              <a:t>Tradesperson</a:t>
+            </a:r>
+            <a:endParaRPr lang="en-US" sz="1200" dirty="0"/>
+          </a:p>
+        </p:txBody>
+      </p:sp>
+      <p:pic>
+        <p:nvPicPr>
+          <p:cNvPr id="8" name="shot-tenant_phone" descr="shot-tenant_phone">    </p:cNvPr>
+          <p:cNvPicPr>
+            <a:picLocks noChangeAspect="1"/>
+          </p:cNvPicPr>
+          <p:nvPr/>
+        </p:nvPicPr>
+        <p:blipFill>
+          <a:blip r:embed="rId4"/>
+          <a:stretch>
+            <a:fillRect/>
+          </a:stretch>
+        </p:blipFill>
+        <p:spPr>
+          <a:xfrm>
+            <a:off x="10415016" y="1280160"/>
+            <a:ext cx="1188720" cy="2569464"/>
+          </a:xfrm>
+          <a:prstGeom prst="rect">
+            <a:avLst/>
+          </a:prstGeom>
+        </p:spPr>
+      </p:pic>
+      <p:sp>
+        <p:nvSpPr>
+          <p:cNvPr id="9" name="shot-l-2"/>
+          <p:cNvSpPr txBox="1"/>
+          <p:nvPr/>
+        </p:nvSpPr>
+        <p:spPr>
+          <a:xfrm>
+            <a:off x="10323576" y="3931920"/>
+            <a:ext cx="1371600" cy="274320"/>
           </a:xfrm>
           <a:prstGeom prst="rect">
             <a:avLst/>
@@ -4143,34 +4870,34 @@
           <a:bodyPr wrap="square" lIns="0" tIns="0" rIns="0" bIns="0" rtlCol="0" anchor="t"/>
           <a:lstStyle/>
           <a:p>
-            <a:pPr indent="0" marL="0">
-              <a:buNone/>
-            </a:pPr>
-            <a:r>
-              <a:rPr lang="en-US" sz="1700" b="1" dirty="0">
-                <a:solidFill>
-                  <a:srgbClr val="14181D"/>
+            <a:pPr algn="ctr" indent="0" marL="0">
+              <a:buNone/>
+            </a:pPr>
+            <a:r>
+              <a:rPr lang="en-US" sz="1200" dirty="0">
+                <a:solidFill>
+                  <a:srgbClr val="C9CFD6"/>
                 </a:solidFill>
                 <a:latin typeface="Calibri" pitchFamily="34" charset="0"/>
                 <a:ea typeface="Calibri" pitchFamily="34" charset="-122"/>
                 <a:cs typeface="Calibri" pitchFamily="34" charset="-120"/>
               </a:rPr>
-              <a:t>A person can change urgency at any time</a:t>
-            </a:r>
-            <a:endParaRPr lang="en-US" sz="1700" dirty="0"/>
-          </a:p>
-        </p:txBody>
-      </p:sp>
-      <p:sp>
-        <p:nvSpPr>
-          <p:cNvPr id="9" name="trust-b-1"/>
-          <p:cNvSpPr txBox="1"/>
-          <p:nvPr/>
-        </p:nvSpPr>
-        <p:spPr>
-          <a:xfrm>
-            <a:off x="3840480" y="2450592"/>
-            <a:ext cx="7772400" cy="411480"/>
+              <a:t>Tenant</a:t>
+            </a:r>
+            <a:endParaRPr lang="en-US" sz="1200" dirty="0"/>
+          </a:p>
+        </p:txBody>
+      </p:sp>
+      <p:sp>
+        <p:nvSpPr>
+          <p:cNvPr id="10" name="feat-0"/>
+          <p:cNvSpPr txBox="1"/>
+          <p:nvPr/>
+        </p:nvSpPr>
+        <p:spPr>
+          <a:xfrm>
+            <a:off x="7818120" y="4434840"/>
+            <a:ext cx="3840480" cy="548640"/>
           </a:xfrm>
           <a:prstGeom prst="rect">
             <a:avLst/>
@@ -4182,59 +4909,35 @@
           <a:bodyPr wrap="square" lIns="0" tIns="0" rIns="0" bIns="0" rtlCol="0" anchor="t"/>
           <a:lstStyle/>
           <a:p>
-            <a:pPr indent="0" marL="0">
-              <a:buNone/>
-            </a:pPr>
-            <a:r>
-              <a:rPr lang="en-US" sz="1400" dirty="0">
-                <a:solidFill>
-                  <a:srgbClr val="4A525C"/>
+            <a:pPr marL="342900" indent="-342900">
+              <a:buSzPct val="100000"/>
+              <a:buChar char="•"/>
+            </a:pPr>
+            <a:r>
+              <a:rPr lang="en-US" sz="1300" dirty="0">
+                <a:solidFill>
+                  <a:srgbClr val="E3E7EB"/>
                 </a:solidFill>
                 <a:latin typeface="Calibri" pitchFamily="34" charset="0"/>
                 <a:ea typeface="Calibri" pitchFamily="34" charset="-122"/>
                 <a:cs typeface="Calibri" pitchFamily="34" charset="-120"/>
               </a:rPr>
-              <a:t>From a call, a visit, a photo or a review. Lowering danger needs someone who spoke to the tenant or saw it</a:t>
-            </a:r>
-            <a:endParaRPr lang="en-US" sz="1400" dirty="0"/>
-          </a:p>
-        </p:txBody>
-      </p:sp>
-      <p:sp>
-        <p:nvSpPr>
-          <p:cNvPr id="10" name="trust-hex-2"/>
-          <p:cNvSpPr/>
-          <p:nvPr/>
-        </p:nvSpPr>
-        <p:spPr>
-          <a:xfrm>
-            <a:off x="3108960" y="2962656"/>
-            <a:ext cx="512064" cy="450616"/>
-          </a:xfrm>
-          <a:prstGeom prst="hexagon">
-            <a:avLst/>
-          </a:prstGeom>
-          <a:solidFill>
-            <a:srgbClr val="1F9D4C"/>
-          </a:solidFill>
-          <a:ln w="12700">
-            <a:solidFill>
-              <a:srgbClr val="1F9D4C"/>
-            </a:solidFill>
-            <a:prstDash val="solid"/>
-          </a:ln>
-        </p:spPr>
-      </p:sp>
-      <p:sp>
-        <p:nvSpPr>
-          <p:cNvPr id="11" name="trust-h-2"/>
-          <p:cNvSpPr txBox="1"/>
-          <p:nvPr/>
-        </p:nvSpPr>
-        <p:spPr>
-          <a:xfrm>
-            <a:off x="3840480" y="2907792"/>
-            <a:ext cx="7772400" cy="347472"/>
+              <a:t>Anyone the tenant tells can log a report, with the same questions</a:t>
+            </a:r>
+            <a:endParaRPr lang="en-US" sz="1300" dirty="0"/>
+          </a:p>
+        </p:txBody>
+      </p:sp>
+      <p:sp>
+        <p:nvSpPr>
+          <p:cNvPr id="11" name="feat-1"/>
+          <p:cNvSpPr txBox="1"/>
+          <p:nvPr/>
+        </p:nvSpPr>
+        <p:spPr>
+          <a:xfrm>
+            <a:off x="7818120" y="5001768"/>
+            <a:ext cx="3840480" cy="548640"/>
           </a:xfrm>
           <a:prstGeom prst="rect">
             <a:avLst/>
@@ -4246,34 +4949,35 @@
           <a:bodyPr wrap="square" lIns="0" tIns="0" rIns="0" bIns="0" rtlCol="0" anchor="t"/>
           <a:lstStyle/>
           <a:p>
-            <a:pPr indent="0" marL="0">
-              <a:buNone/>
-            </a:pPr>
-            <a:r>
-              <a:rPr lang="en-US" sz="1700" b="1" dirty="0">
-                <a:solidFill>
-                  <a:srgbClr val="14181D"/>
+            <a:pPr marL="342900" indent="-342900">
+              <a:buSzPct val="100000"/>
+              <a:buChar char="•"/>
+            </a:pPr>
+            <a:r>
+              <a:rPr lang="en-US" sz="1300" dirty="0">
+                <a:solidFill>
+                  <a:srgbClr val="E3E7EB"/>
                 </a:solidFill>
                 <a:latin typeface="Calibri" pitchFamily="34" charset="0"/>
                 <a:ea typeface="Calibri" pitchFamily="34" charset="-122"/>
                 <a:cs typeface="Calibri" pitchFamily="34" charset="-120"/>
               </a:rPr>
-              <a:t>A missed visit is never closed, and keeps its place</a:t>
-            </a:r>
-            <a:endParaRPr lang="en-US" sz="1700" dirty="0"/>
-          </a:p>
-        </p:txBody>
-      </p:sp>
-      <p:sp>
-        <p:nvSpPr>
-          <p:cNvPr id="12" name="trust-b-2"/>
-          <p:cNvSpPr txBox="1"/>
-          <p:nvPr/>
-        </p:nvSpPr>
-        <p:spPr>
-          <a:xfrm>
-            <a:off x="3840480" y="3264408"/>
-            <a:ext cx="7772400" cy="411480"/>
+              <a:t>Works without signal: updates are saved on the phone and sent later</a:t>
+            </a:r>
+            <a:endParaRPr lang="en-US" sz="1300" dirty="0"/>
+          </a:p>
+        </p:txBody>
+      </p:sp>
+      <p:sp>
+        <p:nvSpPr>
+          <p:cNvPr id="12" name="feat-2"/>
+          <p:cNvSpPr txBox="1"/>
+          <p:nvPr/>
+        </p:nvSpPr>
+        <p:spPr>
+          <a:xfrm>
+            <a:off x="7818120" y="5568696"/>
+            <a:ext cx="3840480" cy="548640"/>
           </a:xfrm>
           <a:prstGeom prst="rect">
             <a:avLst/>
@@ -4285,59 +4989,35 @@
           <a:bodyPr wrap="square" lIns="0" tIns="0" rIns="0" bIns="0" rtlCol="0" anchor="t"/>
           <a:lstStyle/>
           <a:p>
-            <a:pPr indent="0" marL="0">
-              <a:buNone/>
-            </a:pPr>
-            <a:r>
-              <a:rPr lang="en-US" sz="1400" dirty="0">
-                <a:solidFill>
-                  <a:srgbClr val="4A525C"/>
+            <a:pPr marL="342900" indent="-342900">
+              <a:buSzPct val="100000"/>
+              <a:buChar char="•"/>
+            </a:pPr>
+            <a:r>
+              <a:rPr lang="en-US" sz="1300" dirty="0">
+                <a:solidFill>
+                  <a:srgbClr val="E3E7EB"/>
                 </a:solidFill>
                 <a:latin typeface="Calibri" pitchFamily="34" charset="0"/>
                 <a:ea typeface="Calibri" pitchFamily="34" charset="-122"/>
                 <a:cs typeface="Calibri" pitchFamily="34" charset="-120"/>
               </a:rPr>
-              <a:t>Time and what was tried are recorded; then the next trip, another crew, or anyone who can go sooner</a:t>
-            </a:r>
-            <a:endParaRPr lang="en-US" sz="1400" dirty="0"/>
-          </a:p>
-        </p:txBody>
-      </p:sp>
-      <p:sp>
-        <p:nvSpPr>
-          <p:cNvPr id="13" name="trust-hex-3"/>
-          <p:cNvSpPr/>
-          <p:nvPr/>
-        </p:nvSpPr>
-        <p:spPr>
-          <a:xfrm>
-            <a:off x="3108960" y="3776472"/>
-            <a:ext cx="512064" cy="450616"/>
-          </a:xfrm>
-          <a:prstGeom prst="hexagon">
-            <a:avLst/>
-          </a:prstGeom>
-          <a:solidFill>
-            <a:srgbClr val="6E56CF"/>
-          </a:solidFill>
-          <a:ln w="12700">
-            <a:solidFill>
-              <a:srgbClr val="6E56CF"/>
-            </a:solidFill>
-            <a:prstDash val="solid"/>
-          </a:ln>
-        </p:spPr>
-      </p:sp>
-      <p:sp>
-        <p:nvSpPr>
-          <p:cNvPr id="14" name="trust-h-3"/>
-          <p:cNvSpPr txBox="1"/>
-          <p:nvPr/>
-        </p:nvSpPr>
-        <p:spPr>
-          <a:xfrm>
-            <a:off x="3840480" y="3721608"/>
-            <a:ext cx="7772400" cy="347472"/>
+              <a:t>Plain words, WCAG 2.2 AA checked, PDFs, no confidence percentages</a:t>
+            </a:r>
+            <a:endParaRPr lang="en-US" sz="1300" dirty="0"/>
+          </a:p>
+        </p:txBody>
+      </p:sp>
+      <p:sp>
+        <p:nvSpPr>
+          <p:cNvPr id="13" name="shot-url"/>
+          <p:cNvSpPr txBox="1"/>
+          <p:nvPr/>
+        </p:nvSpPr>
+        <p:spPr>
+          <a:xfrm>
+            <a:off x="548640" y="5760720"/>
+            <a:ext cx="6949440" cy="365760"/>
           </a:xfrm>
           <a:prstGeom prst="rect">
             <a:avLst/>
@@ -4353,262 +5033,17 @@
               <a:buNone/>
             </a:pPr>
             <a:r>
-              <a:rPr lang="en-US" sz="1700" b="1" dirty="0">
-                <a:solidFill>
-                  <a:srgbClr val="14181D"/>
+              <a:rPr lang="en-US" sz="1600" b="1" dirty="0">
+                <a:solidFill>
+                  <a:srgbClr val="64D2FF"/>
                 </a:solidFill>
                 <a:latin typeface="Calibri" pitchFamily="34" charset="0"/>
                 <a:ea typeface="Calibri" pitchFamily="34" charset="-122"/>
                 <a:cs typeface="Calibri" pitchFamily="34" charset="-120"/>
               </a:rPr>
-              <a:t>Tenants can ask for a review, or say it got worse</a:t>
-            </a:r>
-            <a:endParaRPr lang="en-US" sz="1700" dirty="0"/>
-          </a:p>
-        </p:txBody>
-      </p:sp>
-      <p:sp>
-        <p:nvSpPr>
-          <p:cNvPr id="15" name="trust-b-3"/>
-          <p:cNvSpPr txBox="1"/>
-          <p:nvPr/>
-        </p:nvSpPr>
-        <p:spPr>
-          <a:xfrm>
-            <a:off x="3840480" y="4078224"/>
-            <a:ext cx="7772400" cy="411480"/>
-          </a:xfrm>
-          <a:prstGeom prst="rect">
-            <a:avLst/>
-          </a:prstGeom>
-          <a:noFill/>
-          <a:ln/>
-        </p:spPr>
-        <p:txBody>
-          <a:bodyPr wrap="square" lIns="0" tIns="0" rIns="0" bIns="0" rtlCol="0" anchor="t"/>
-          <a:lstStyle/>
-          <a:p>
-            <a:pPr indent="0" marL="0">
-              <a:buNone/>
-            </a:pPr>
-            <a:r>
-              <a:rPr lang="en-US" sz="1400" dirty="0">
-                <a:solidFill>
-                  <a:srgbClr val="4A525C"/>
-                </a:solidFill>
-                <a:latin typeface="Calibri" pitchFamily="34" charset="0"/>
-                <a:ea typeface="Calibri" pitchFamily="34" charset="-122"/>
-                <a:cs typeface="Calibri" pitchFamily="34" charset="-120"/>
-              </a:rPr>
-              <a:t>A person answers a review within 10 working days, and calls back the same day if it got worse</a:t>
-            </a:r>
-            <a:endParaRPr lang="en-US" sz="1400" dirty="0"/>
-          </a:p>
-        </p:txBody>
-      </p:sp>
-      <p:sp>
-        <p:nvSpPr>
-          <p:cNvPr id="16" name="trust-hex-4"/>
-          <p:cNvSpPr/>
-          <p:nvPr/>
-        </p:nvSpPr>
-        <p:spPr>
-          <a:xfrm>
-            <a:off x="3108960" y="4590288"/>
-            <a:ext cx="512064" cy="450616"/>
-          </a:xfrm>
-          <a:prstGeom prst="hexagon">
-            <a:avLst/>
-          </a:prstGeom>
-          <a:solidFill>
-            <a:srgbClr val="0E8FB8"/>
-          </a:solidFill>
-          <a:ln w="12700">
-            <a:solidFill>
-              <a:srgbClr val="0E8FB8"/>
-            </a:solidFill>
-            <a:prstDash val="solid"/>
-          </a:ln>
-        </p:spPr>
-      </p:sp>
-      <p:sp>
-        <p:nvSpPr>
-          <p:cNvPr id="17" name="trust-h-4"/>
-          <p:cNvSpPr txBox="1"/>
-          <p:nvPr/>
-        </p:nvSpPr>
-        <p:spPr>
-          <a:xfrm>
-            <a:off x="3840480" y="4535424"/>
-            <a:ext cx="7772400" cy="347472"/>
-          </a:xfrm>
-          <a:prstGeom prst="rect">
-            <a:avLst/>
-          </a:prstGeom>
-          <a:noFill/>
-          <a:ln/>
-        </p:spPr>
-        <p:txBody>
-          <a:bodyPr wrap="square" lIns="0" tIns="0" rIns="0" bIns="0" rtlCol="0" anchor="t"/>
-          <a:lstStyle/>
-          <a:p>
-            <a:pPr indent="0" marL="0">
-              <a:buNone/>
-            </a:pPr>
-            <a:r>
-              <a:rPr lang="en-US" sz="1700" b="1" dirty="0">
-                <a:solidFill>
-                  <a:srgbClr val="14181D"/>
-                </a:solidFill>
-                <a:latin typeface="Calibri" pitchFamily="34" charset="0"/>
-                <a:ea typeface="Calibri" pitchFamily="34" charset="-122"/>
-                <a:cs typeface="Calibri" pitchFamily="34" charset="-120"/>
-              </a:rPr>
-              <a:t>People check the AI every week</a:t>
-            </a:r>
-            <a:endParaRPr lang="en-US" sz="1700" dirty="0"/>
-          </a:p>
-        </p:txBody>
-      </p:sp>
-      <p:sp>
-        <p:nvSpPr>
-          <p:cNvPr id="18" name="trust-b-4"/>
-          <p:cNvSpPr txBox="1"/>
-          <p:nvPr/>
-        </p:nvSpPr>
-        <p:spPr>
-          <a:xfrm>
-            <a:off x="3840480" y="4892040"/>
-            <a:ext cx="7772400" cy="411480"/>
-          </a:xfrm>
-          <a:prstGeom prst="rect">
-            <a:avLst/>
-          </a:prstGeom>
-          <a:noFill/>
-          <a:ln/>
-        </p:spPr>
-        <p:txBody>
-          <a:bodyPr wrap="square" lIns="0" tIns="0" rIns="0" bIns="0" rtlCol="0" anchor="t"/>
-          <a:lstStyle/>
-          <a:p>
-            <a:pPr indent="0" marL="0">
-              <a:buNone/>
-            </a:pPr>
-            <a:r>
-              <a:rPr lang="en-US" sz="1400" dirty="0">
-                <a:solidFill>
-                  <a:srgbClr val="4A525C"/>
-                </a:solidFill>
-                <a:latin typeface="Calibri" pitchFamily="34" charset="0"/>
-                <a:ea typeface="Calibri" pitchFamily="34" charset="-122"/>
-                <a:cs typeface="Calibri" pitchFamily="34" charset="-120"/>
-              </a:rPr>
-              <a:t>1 in 20 reports the computer read alone is re-read by a person</a:t>
-            </a:r>
-            <a:endParaRPr lang="en-US" sz="1400" dirty="0"/>
-          </a:p>
-        </p:txBody>
-      </p:sp>
-      <p:sp>
-        <p:nvSpPr>
-          <p:cNvPr id="19" name="trust-hex-5"/>
-          <p:cNvSpPr/>
-          <p:nvPr/>
-        </p:nvSpPr>
-        <p:spPr>
-          <a:xfrm>
-            <a:off x="3108960" y="5404104"/>
-            <a:ext cx="512064" cy="450616"/>
-          </a:xfrm>
-          <a:prstGeom prst="hexagon">
-            <a:avLst/>
-          </a:prstGeom>
-          <a:solidFill>
-            <a:srgbClr val="14181D"/>
-          </a:solidFill>
-          <a:ln w="12700">
-            <a:solidFill>
-              <a:srgbClr val="14181D"/>
-            </a:solidFill>
-            <a:prstDash val="solid"/>
-          </a:ln>
-        </p:spPr>
-      </p:sp>
-      <p:sp>
-        <p:nvSpPr>
-          <p:cNvPr id="20" name="trust-h-5"/>
-          <p:cNvSpPr txBox="1"/>
-          <p:nvPr/>
-        </p:nvSpPr>
-        <p:spPr>
-          <a:xfrm>
-            <a:off x="3840480" y="5349240"/>
-            <a:ext cx="7772400" cy="347472"/>
-          </a:xfrm>
-          <a:prstGeom prst="rect">
-            <a:avLst/>
-          </a:prstGeom>
-          <a:noFill/>
-          <a:ln/>
-        </p:spPr>
-        <p:txBody>
-          <a:bodyPr wrap="square" lIns="0" tIns="0" rIns="0" bIns="0" rtlCol="0" anchor="t"/>
-          <a:lstStyle/>
-          <a:p>
-            <a:pPr indent="0" marL="0">
-              <a:buNone/>
-            </a:pPr>
-            <a:r>
-              <a:rPr lang="en-US" sz="1700" b="1" dirty="0">
-                <a:solidFill>
-                  <a:srgbClr val="14181D"/>
-                </a:solidFill>
-                <a:latin typeface="Calibri" pitchFamily="34" charset="0"/>
-                <a:ea typeface="Calibri" pitchFamily="34" charset="-122"/>
-                <a:cs typeface="Calibri" pitchFamily="34" charset="-120"/>
-              </a:rPr>
-              <a:t>Personal details locked away</a:t>
-            </a:r>
-            <a:endParaRPr lang="en-US" sz="1700" dirty="0"/>
-          </a:p>
-        </p:txBody>
-      </p:sp>
-      <p:sp>
-        <p:nvSpPr>
-          <p:cNvPr id="21" name="trust-b-5"/>
-          <p:cNvSpPr txBox="1"/>
-          <p:nvPr/>
-        </p:nvSpPr>
-        <p:spPr>
-          <a:xfrm>
-            <a:off x="3840480" y="5705856"/>
-            <a:ext cx="7772400" cy="411480"/>
-          </a:xfrm>
-          <a:prstGeom prst="rect">
-            <a:avLst/>
-          </a:prstGeom>
-          <a:noFill/>
-          <a:ln/>
-        </p:spPr>
-        <p:txBody>
-          <a:bodyPr wrap="square" lIns="0" tIns="0" rIns="0" bIns="0" rtlCol="0" anchor="t"/>
-          <a:lstStyle/>
-          <a:p>
-            <a:pPr indent="0" marL="0">
-              <a:buNone/>
-            </a:pPr>
-            <a:r>
-              <a:rPr lang="en-US" sz="1400" dirty="0">
-                <a:solidFill>
-                  <a:srgbClr val="4A525C"/>
-                </a:solidFill>
-                <a:latin typeface="Calibri" pitchFamily="34" charset="0"/>
-                <a:ea typeface="Calibri" pitchFamily="34" charset="-122"/>
-                <a:cs typeface="Calibri" pitchFamily="34" charset="-120"/>
-              </a:rPr>
-              <a:t>Names, phones and addresses in an encrypted vault; the house is just a hexagon</a:t>
-            </a:r>
-            <a:endParaRPr lang="en-US" sz="1400" dirty="0"/>
+              <a:t>reachnt.vercel.app</a:t>
+            </a:r>
+            <a:endParaRPr lang="en-US" sz="1600" dirty="0"/>
           </a:p>
         </p:txBody>
       </p:sp>
@@ -4642,7 +5077,7 @@
             <a:lvl1pPr>
               <a:defRPr sz="1000">
                 <a:solidFill>
-                  <a:srgbClr val="6B7480"/>
+                  <a:srgbClr val="9AA3AD"/>
                 </a:solidFill>
               </a:defRPr>
             </a:lvl1pPr>
@@ -4717,34 +5152,56 @@
                 <a:ea typeface="Arial" pitchFamily="34" charset="-122"/>
                 <a:cs typeface="Arial" pitchFamily="34" charset="-120"/>
               </a:rPr>
-              <a:t>What we tested, and what we can't claim yet</a:t>
+              <a:t>People stay in charge, and tenants can push back</a:t>
             </a:r>
             <a:endParaRPr lang="en-US" sz="2800" dirty="0"/>
           </a:p>
         </p:txBody>
       </p:sp>
-      <p:sp>
-        <p:nvSpPr>
-          <p:cNvPr id="3" name="tested-card"/>
+      <p:pic>
+        <p:nvPicPr>
+          <p:cNvPr id="3" name="trust-phone" descr="trust-phone">    </p:cNvPr>
+          <p:cNvPicPr>
+            <a:picLocks noChangeAspect="1"/>
+          </p:cNvPicPr>
+          <p:nvPr/>
+        </p:nvPicPr>
+        <p:blipFill>
+          <a:blip r:embed="rId1"/>
+          <a:stretch>
+            <a:fillRect/>
+          </a:stretch>
+        </p:blipFill>
+        <p:spPr>
+          <a:xfrm>
+            <a:off x="548640" y="1325880"/>
+            <a:ext cx="2194560" cy="4754880"/>
+          </a:xfrm>
+          <a:prstGeom prst="rect">
+            <a:avLst/>
+          </a:prstGeom>
+        </p:spPr>
+      </p:pic>
+      <p:sp>
+        <p:nvSpPr>
+          <p:cNvPr id="4" name="trust-hex-0"/>
           <p:cNvSpPr/>
           <p:nvPr/>
         </p:nvSpPr>
         <p:spPr>
           <a:xfrm>
-            <a:off x="548640" y="1417320"/>
-            <a:ext cx="5349240" cy="4663440"/>
-          </a:xfrm>
-          <a:prstGeom prst="roundRect">
-            <a:avLst>
-              <a:gd name="adj" fmla="val 1961"/>
-            </a:avLst>
+            <a:off x="3108960" y="1335024"/>
+            <a:ext cx="512064" cy="450616"/>
+          </a:xfrm>
+          <a:prstGeom prst="hexagon">
+            <a:avLst/>
           </a:prstGeom>
           <a:solidFill>
-            <a:srgbClr val="E3F4E8"/>
+            <a:srgbClr val="D97706"/>
           </a:solidFill>
           <a:ln w="12700">
             <a:solidFill>
-              <a:srgbClr val="E3F4E8"/>
+              <a:srgbClr val="D97706"/>
             </a:solidFill>
             <a:prstDash val="solid"/>
           </a:ln>
@@ -4752,14 +5209,14 @@
       </p:sp>
       <p:sp>
         <p:nvSpPr>
-          <p:cNvPr id="4" name="tested-h"/>
-          <p:cNvSpPr txBox="1"/>
-          <p:nvPr/>
-        </p:nvSpPr>
-        <p:spPr>
-          <a:xfrm>
-            <a:off x="822960" y="1645920"/>
-            <a:ext cx="4846320" cy="457200"/>
+          <p:cNvPr id="5" name="trust-h-0"/>
+          <p:cNvSpPr txBox="1"/>
+          <p:nvPr/>
+        </p:nvSpPr>
+        <p:spPr>
+          <a:xfrm>
+            <a:off x="3840480" y="1280160"/>
+            <a:ext cx="7772400" cy="347472"/>
           </a:xfrm>
           <a:prstGeom prst="rect">
             <a:avLst/>
@@ -4775,47 +5232,7 @@
               <a:buNone/>
             </a:pPr>
             <a:r>
-              <a:rPr lang="en-US" sz="2200" b="1" dirty="0">
-                <a:solidFill>
-                  <a:srgbClr val="1F9D4C"/>
-                </a:solidFill>
-                <a:latin typeface="Arial" pitchFamily="34" charset="0"/>
-                <a:ea typeface="Arial" pitchFamily="34" charset="-122"/>
-                <a:cs typeface="Arial" pitchFamily="34" charset="-120"/>
-              </a:rPr>
-              <a:t>Tested</a:t>
-            </a:r>
-            <a:endParaRPr lang="en-US" sz="2200" dirty="0"/>
-          </a:p>
-        </p:txBody>
-      </p:sp>
-      <p:sp>
-        <p:nvSpPr>
-          <p:cNvPr id="5" name="tested-0"/>
-          <p:cNvSpPr txBox="1"/>
-          <p:nvPr/>
-        </p:nvSpPr>
-        <p:spPr>
-          <a:xfrm>
-            <a:off x="822960" y="2240280"/>
-            <a:ext cx="4846320" cy="685800"/>
-          </a:xfrm>
-          <a:prstGeom prst="rect">
-            <a:avLst/>
-          </a:prstGeom>
-          <a:noFill/>
-          <a:ln/>
-        </p:spPr>
-        <p:txBody>
-          <a:bodyPr wrap="square" lIns="0" tIns="0" rIns="0" bIns="0" rtlCol="0" anchor="t"/>
-          <a:lstStyle/>
-          <a:p>
-            <a:pPr marL="342900" indent="-342900">
-              <a:buSzPct val="100000"/>
-              <a:buChar char="•"/>
-            </a:pPr>
-            <a:r>
-              <a:rPr lang="en-US" sz="1500" dirty="0">
+              <a:rPr lang="en-US" sz="1700" b="1" dirty="0">
                 <a:solidFill>
                   <a:srgbClr val="14181D"/>
                 </a:solidFill>
@@ -4823,22 +5240,22 @@
                 <a:ea typeface="Calibri" pitchFamily="34" charset="-122"/>
                 <a:cs typeface="Calibri" pitchFamily="34" charset="-120"/>
               </a:rPr>
-              <a:t>92 automated checks on every code change: data, the reader, fair intake, the planner, the server</a:t>
-            </a:r>
-            <a:endParaRPr lang="en-US" sz="1500" dirty="0"/>
-          </a:p>
-        </p:txBody>
-      </p:sp>
-      <p:sp>
-        <p:nvSpPr>
-          <p:cNvPr id="6" name="tested-1"/>
-          <p:cNvSpPr txBox="1"/>
-          <p:nvPr/>
-        </p:nvSpPr>
-        <p:spPr>
-          <a:xfrm>
-            <a:off x="822960" y="2990088"/>
-            <a:ext cx="4846320" cy="685800"/>
+              <a:t>A named person signs the trade-off</a:t>
+            </a:r>
+            <a:endParaRPr lang="en-US" sz="1700" dirty="0"/>
+          </a:p>
+        </p:txBody>
+      </p:sp>
+      <p:sp>
+        <p:nvSpPr>
+          <p:cNvPr id="6" name="trust-b-0"/>
+          <p:cNvSpPr txBox="1"/>
+          <p:nvPr/>
+        </p:nvSpPr>
+        <p:spPr>
+          <a:xfrm>
+            <a:off x="3840480" y="1636776"/>
+            <a:ext cx="7772400" cy="411480"/>
           </a:xfrm>
           <a:prstGeom prst="rect">
             <a:avLst/>
@@ -4850,35 +5267,59 @@
           <a:bodyPr wrap="square" lIns="0" tIns="0" rIns="0" bIns="0" rtlCol="0" anchor="t"/>
           <a:lstStyle/>
           <a:p>
-            <a:pPr marL="342900" indent="-342900">
-              <a:buSzPct val="100000"/>
-              <a:buChar char="•"/>
-            </a:pPr>
-            <a:r>
-              <a:rPr lang="en-US" sz="1500" dirty="0">
-                <a:solidFill>
-                  <a:srgbClr val="14181D"/>
+            <a:pPr indent="0" marL="0">
+              <a:buNone/>
+            </a:pPr>
+            <a:r>
+              <a:rPr lang="en-US" sz="1400" dirty="0">
+                <a:solidFill>
+                  <a:srgbClr val="4A525C"/>
                 </a:solidFill>
                 <a:latin typeface="Calibri" pitchFamily="34" charset="0"/>
                 <a:ea typeface="Calibri" pitchFamily="34" charset="-122"/>
                 <a:cs typeface="Calibri" pitchFamily="34" charset="-120"/>
               </a:rPr>
-              <a:t>Five random years of requests; the result held in all five</a:t>
-            </a:r>
-            <a:endParaRPr lang="en-US" sz="1500" dirty="0"/>
-          </a:p>
-        </p:txBody>
-      </p:sp>
-      <p:sp>
-        <p:nvSpPr>
-          <p:cNvPr id="7" name="tested-2"/>
-          <p:cNvSpPr txBox="1"/>
-          <p:nvPr/>
-        </p:nvSpPr>
-        <p:spPr>
-          <a:xfrm>
-            <a:off x="822960" y="3739896"/>
-            <a:ext cx="4846320" cy="685800"/>
+              <a:t>How much cost may count is a signed decision, kept in a tamper-evident record</a:t>
+            </a:r>
+            <a:endParaRPr lang="en-US" sz="1400" dirty="0"/>
+          </a:p>
+        </p:txBody>
+      </p:sp>
+      <p:sp>
+        <p:nvSpPr>
+          <p:cNvPr id="7" name="trust-hex-1"/>
+          <p:cNvSpPr/>
+          <p:nvPr/>
+        </p:nvSpPr>
+        <p:spPr>
+          <a:xfrm>
+            <a:off x="3108960" y="2148840"/>
+            <a:ext cx="512064" cy="450616"/>
+          </a:xfrm>
+          <a:prstGeom prst="hexagon">
+            <a:avLst/>
+          </a:prstGeom>
+          <a:solidFill>
+            <a:srgbClr val="E5352B"/>
+          </a:solidFill>
+          <a:ln w="12700">
+            <a:solidFill>
+              <a:srgbClr val="E5352B"/>
+            </a:solidFill>
+            <a:prstDash val="solid"/>
+          </a:ln>
+        </p:spPr>
+      </p:sp>
+      <p:sp>
+        <p:nvSpPr>
+          <p:cNvPr id="8" name="trust-h-1"/>
+          <p:cNvSpPr txBox="1"/>
+          <p:nvPr/>
+        </p:nvSpPr>
+        <p:spPr>
+          <a:xfrm>
+            <a:off x="3840480" y="2093976"/>
+            <a:ext cx="7772400" cy="347472"/>
           </a:xfrm>
           <a:prstGeom prst="rect">
             <a:avLst/>
@@ -4890,12 +5331,11 @@
           <a:bodyPr wrap="square" lIns="0" tIns="0" rIns="0" bIns="0" rtlCol="0" anchor="t"/>
           <a:lstStyle/>
           <a:p>
-            <a:pPr marL="342900" indent="-342900">
-              <a:buSzPct val="100000"/>
-              <a:buChar char="•"/>
-            </a:pPr>
-            <a:r>
-              <a:rPr lang="en-US" sz="1500" dirty="0">
+            <a:pPr indent="0" marL="0">
+              <a:buNone/>
+            </a:pPr>
+            <a:r>
+              <a:rPr lang="en-US" sz="1700" b="1" dirty="0">
                 <a:solidFill>
                   <a:srgbClr val="14181D"/>
                 </a:solidFill>
@@ -4903,22 +5343,22 @@
                 <a:ea typeface="Calibri" pitchFamily="34" charset="-122"/>
                 <a:cs typeface="Calibri" pitchFamily="34" charset="-120"/>
               </a:rPr>
-              <a:t>Every community's position checked against satellite photos</a:t>
-            </a:r>
-            <a:endParaRPr lang="en-US" sz="1500" dirty="0"/>
-          </a:p>
-        </p:txBody>
-      </p:sp>
-      <p:sp>
-        <p:nvSpPr>
-          <p:cNvPr id="8" name="tested-3"/>
-          <p:cNvSpPr txBox="1"/>
-          <p:nvPr/>
-        </p:nvSpPr>
-        <p:spPr>
-          <a:xfrm>
-            <a:off x="822960" y="4489704"/>
-            <a:ext cx="4846320" cy="685800"/>
+              <a:t>A person can change urgency at any time</a:t>
+            </a:r>
+            <a:endParaRPr lang="en-US" sz="1700" dirty="0"/>
+          </a:p>
+        </p:txBody>
+      </p:sp>
+      <p:sp>
+        <p:nvSpPr>
+          <p:cNvPr id="9" name="trust-b-1"/>
+          <p:cNvSpPr txBox="1"/>
+          <p:nvPr/>
+        </p:nvSpPr>
+        <p:spPr>
+          <a:xfrm>
+            <a:off x="3840480" y="2450592"/>
+            <a:ext cx="7772400" cy="411480"/>
           </a:xfrm>
           <a:prstGeom prst="rect">
             <a:avLst/>
@@ -4930,35 +5370,59 @@
           <a:bodyPr wrap="square" lIns="0" tIns="0" rIns="0" bIns="0" rtlCol="0" anchor="t"/>
           <a:lstStyle/>
           <a:p>
-            <a:pPr marL="342900" indent="-342900">
-              <a:buSzPct val="100000"/>
-              <a:buChar char="•"/>
-            </a:pPr>
-            <a:r>
-              <a:rPr lang="en-US" sz="1500" dirty="0">
-                <a:solidFill>
-                  <a:srgbClr val="14181D"/>
+            <a:pPr indent="0" marL="0">
+              <a:buNone/>
+            </a:pPr>
+            <a:r>
+              <a:rPr lang="en-US" sz="1400" dirty="0">
+                <a:solidFill>
+                  <a:srgbClr val="4A525C"/>
                 </a:solidFill>
                 <a:latin typeface="Calibri" pitchFamily="34" charset="0"/>
                 <a:ea typeface="Calibri" pitchFamily="34" charset="-122"/>
                 <a:cs typeface="Calibri" pitchFamily="34" charset="-120"/>
               </a:rPr>
-              <a:t>Accessibility: 0 WCAG 2.2 AA issues in every view</a:t>
-            </a:r>
-            <a:endParaRPr lang="en-US" sz="1500" dirty="0"/>
-          </a:p>
-        </p:txBody>
-      </p:sp>
-      <p:sp>
-        <p:nvSpPr>
-          <p:cNvPr id="9" name="tested-4"/>
-          <p:cNvSpPr txBox="1"/>
-          <p:nvPr/>
-        </p:nvSpPr>
-        <p:spPr>
-          <a:xfrm>
-            <a:off x="822960" y="5239512"/>
-            <a:ext cx="4846320" cy="685800"/>
+              <a:t>From a call, a visit, a photo or a review. Lowering danger needs someone who spoke to the tenant or saw it</a:t>
+            </a:r>
+            <a:endParaRPr lang="en-US" sz="1400" dirty="0"/>
+          </a:p>
+        </p:txBody>
+      </p:sp>
+      <p:sp>
+        <p:nvSpPr>
+          <p:cNvPr id="10" name="trust-hex-2"/>
+          <p:cNvSpPr/>
+          <p:nvPr/>
+        </p:nvSpPr>
+        <p:spPr>
+          <a:xfrm>
+            <a:off x="3108960" y="2962656"/>
+            <a:ext cx="512064" cy="450616"/>
+          </a:xfrm>
+          <a:prstGeom prst="hexagon">
+            <a:avLst/>
+          </a:prstGeom>
+          <a:solidFill>
+            <a:srgbClr val="1F9D4C"/>
+          </a:solidFill>
+          <a:ln w="12700">
+            <a:solidFill>
+              <a:srgbClr val="1F9D4C"/>
+            </a:solidFill>
+            <a:prstDash val="solid"/>
+          </a:ln>
+        </p:spPr>
+      </p:sp>
+      <p:sp>
+        <p:nvSpPr>
+          <p:cNvPr id="11" name="trust-h-2"/>
+          <p:cNvSpPr txBox="1"/>
+          <p:nvPr/>
+        </p:nvSpPr>
+        <p:spPr>
+          <a:xfrm>
+            <a:off x="3840480" y="2907792"/>
+            <a:ext cx="7772400" cy="347472"/>
           </a:xfrm>
           <a:prstGeom prst="rect">
             <a:avLst/>
@@ -4970,12 +5434,11 @@
           <a:bodyPr wrap="square" lIns="0" tIns="0" rIns="0" bIns="0" rtlCol="0" anchor="t"/>
           <a:lstStyle/>
           <a:p>
-            <a:pPr marL="342900" indent="-342900">
-              <a:buSzPct val="100000"/>
-              <a:buChar char="•"/>
-            </a:pPr>
-            <a:r>
-              <a:rPr lang="en-US" sz="1500" dirty="0">
+            <a:pPr indent="0" marL="0">
+              <a:buNone/>
+            </a:pPr>
+            <a:r>
+              <a:rPr lang="en-US" sz="1700" b="1" dirty="0">
                 <a:solidFill>
                   <a:srgbClr val="14181D"/>
                 </a:solidFill>
@@ -4983,34 +5446,71 @@
                 <a:ea typeface="Calibri" pitchFamily="34" charset="-122"/>
                 <a:cs typeface="Calibri" pitchFamily="34" charset="-120"/>
               </a:rPr>
-              <a:t>Security: locked-down site, validated inputs, sign-in rules ready</a:t>
-            </a:r>
-            <a:endParaRPr lang="en-US" sz="1500" dirty="0"/>
-          </a:p>
-        </p:txBody>
-      </p:sp>
-      <p:sp>
-        <p:nvSpPr>
-          <p:cNvPr id="10" name="limits-card"/>
+              <a:t>A missed visit is never closed, and keeps its place</a:t>
+            </a:r>
+            <a:endParaRPr lang="en-US" sz="1700" dirty="0"/>
+          </a:p>
+        </p:txBody>
+      </p:sp>
+      <p:sp>
+        <p:nvSpPr>
+          <p:cNvPr id="12" name="trust-b-2"/>
+          <p:cNvSpPr txBox="1"/>
+          <p:nvPr/>
+        </p:nvSpPr>
+        <p:spPr>
+          <a:xfrm>
+            <a:off x="3840480" y="3264408"/>
+            <a:ext cx="7772400" cy="411480"/>
+          </a:xfrm>
+          <a:prstGeom prst="rect">
+            <a:avLst/>
+          </a:prstGeom>
+          <a:noFill/>
+          <a:ln/>
+        </p:spPr>
+        <p:txBody>
+          <a:bodyPr wrap="square" lIns="0" tIns="0" rIns="0" bIns="0" rtlCol="0" anchor="t"/>
+          <a:lstStyle/>
+          <a:p>
+            <a:pPr indent="0" marL="0">
+              <a:buNone/>
+            </a:pPr>
+            <a:r>
+              <a:rPr lang="en-US" sz="1400" dirty="0">
+                <a:solidFill>
+                  <a:srgbClr val="4A525C"/>
+                </a:solidFill>
+                <a:latin typeface="Calibri" pitchFamily="34" charset="0"/>
+                <a:ea typeface="Calibri" pitchFamily="34" charset="-122"/>
+                <a:cs typeface="Calibri" pitchFamily="34" charset="-120"/>
+              </a:rPr>
+              <a:t>Time and what was tried are recorded; then the next trip, another crew, or anyone who can go sooner</a:t>
+            </a:r>
+            <a:endParaRPr lang="en-US" sz="1400" dirty="0"/>
+          </a:p>
+        </p:txBody>
+      </p:sp>
+      <p:sp>
+        <p:nvSpPr>
+          <p:cNvPr id="13" name="trust-hex-3"/>
           <p:cNvSpPr/>
           <p:nvPr/>
         </p:nvSpPr>
         <p:spPr>
           <a:xfrm>
-            <a:off x="6263640" y="1417320"/>
-            <a:ext cx="5349240" cy="4663440"/>
-          </a:xfrm>
-          <a:prstGeom prst="roundRect">
-            <a:avLst>
-              <a:gd name="adj" fmla="val 1961"/>
-            </a:avLst>
+            <a:off x="3108960" y="3776472"/>
+            <a:ext cx="512064" cy="450616"/>
+          </a:xfrm>
+          <a:prstGeom prst="hexagon">
+            <a:avLst/>
           </a:prstGeom>
           <a:solidFill>
-            <a:srgbClr val="FBEEDD"/>
+            <a:srgbClr val="6E56CF"/>
           </a:solidFill>
           <a:ln w="12700">
             <a:solidFill>
-              <a:srgbClr val="FBEEDD"/>
+              <a:srgbClr val="6E56CF"/>
             </a:solidFill>
             <a:prstDash val="solid"/>
           </a:ln>
@@ -5018,14 +5518,14 @@
       </p:sp>
       <p:sp>
         <p:nvSpPr>
-          <p:cNvPr id="11" name="limits-h"/>
-          <p:cNvSpPr txBox="1"/>
-          <p:nvPr/>
-        </p:nvSpPr>
-        <p:spPr>
-          <a:xfrm>
-            <a:off x="6537960" y="1645920"/>
-            <a:ext cx="4846320" cy="457200"/>
+          <p:cNvPr id="14" name="trust-h-3"/>
+          <p:cNvSpPr txBox="1"/>
+          <p:nvPr/>
+        </p:nvSpPr>
+        <p:spPr>
+          <a:xfrm>
+            <a:off x="3840480" y="3721608"/>
+            <a:ext cx="7772400" cy="347472"/>
           </a:xfrm>
           <a:prstGeom prst="rect">
             <a:avLst/>
@@ -5041,47 +5541,7 @@
               <a:buNone/>
             </a:pPr>
             <a:r>
-              <a:rPr lang="en-US" sz="2200" b="1" dirty="0">
-                <a:solidFill>
-                  <a:srgbClr val="D97706"/>
-                </a:solidFill>
-                <a:latin typeface="Arial" pitchFamily="34" charset="0"/>
-                <a:ea typeface="Arial" pitchFamily="34" charset="-122"/>
-                <a:cs typeface="Arial" pitchFamily="34" charset="-120"/>
-              </a:rPr>
-              <a:t>Not yet</a:t>
-            </a:r>
-            <a:endParaRPr lang="en-US" sz="2200" dirty="0"/>
-          </a:p>
-        </p:txBody>
-      </p:sp>
-      <p:sp>
-        <p:nvSpPr>
-          <p:cNvPr id="12" name="limit-0"/>
-          <p:cNvSpPr txBox="1"/>
-          <p:nvPr/>
-        </p:nvSpPr>
-        <p:spPr>
-          <a:xfrm>
-            <a:off x="6537960" y="2240280"/>
-            <a:ext cx="4846320" cy="868680"/>
-          </a:xfrm>
-          <a:prstGeom prst="rect">
-            <a:avLst/>
-          </a:prstGeom>
-          <a:noFill/>
-          <a:ln/>
-        </p:spPr>
-        <p:txBody>
-          <a:bodyPr wrap="square" lIns="0" tIns="0" rIns="0" bIns="0" rtlCol="0" anchor="t"/>
-          <a:lstStyle/>
-          <a:p>
-            <a:pPr marL="342900" indent="-342900">
-              <a:buSzPct val="100000"/>
-              <a:buChar char="•"/>
-            </a:pPr>
-            <a:r>
-              <a:rPr lang="en-US" sz="1500" dirty="0">
+              <a:rPr lang="en-US" sz="1700" b="1" dirty="0">
                 <a:solidFill>
                   <a:srgbClr val="14181D"/>
                 </a:solidFill>
@@ -5089,22 +5549,22 @@
                 <a:ea typeface="Calibri" pitchFamily="34" charset="-122"/>
                 <a:cs typeface="Calibri" pitchFamily="34" charset="-120"/>
               </a:rPr>
-              <a:t>The repair requests and households are synthetic: no public NT repair data exists</a:t>
-            </a:r>
-            <a:endParaRPr lang="en-US" sz="1500" dirty="0"/>
-          </a:p>
-        </p:txBody>
-      </p:sp>
-      <p:sp>
-        <p:nvSpPr>
-          <p:cNvPr id="13" name="limit-1"/>
-          <p:cNvSpPr txBox="1"/>
-          <p:nvPr/>
-        </p:nvSpPr>
-        <p:spPr>
-          <a:xfrm>
-            <a:off x="6537960" y="3154680"/>
-            <a:ext cx="4846320" cy="868680"/>
+              <a:t>No app needed: the housing officer acts for the tenant</a:t>
+            </a:r>
+            <a:endParaRPr lang="en-US" sz="1700" dirty="0"/>
+          </a:p>
+        </p:txBody>
+      </p:sp>
+      <p:sp>
+        <p:nvSpPr>
+          <p:cNvPr id="15" name="trust-b-3"/>
+          <p:cNvSpPr txBox="1"/>
+          <p:nvPr/>
+        </p:nvSpPr>
+        <p:spPr>
+          <a:xfrm>
+            <a:off x="3840480" y="4078224"/>
+            <a:ext cx="7772400" cy="411480"/>
           </a:xfrm>
           <a:prstGeom prst="rect">
             <a:avLst/>
@@ -5116,35 +5576,59 @@
           <a:bodyPr wrap="square" lIns="0" tIns="0" rIns="0" bIns="0" rtlCol="0" anchor="t"/>
           <a:lstStyle/>
           <a:p>
-            <a:pPr marL="342900" indent="-342900">
-              <a:buSzPct val="100000"/>
-              <a:buChar char="•"/>
-            </a:pPr>
-            <a:r>
-              <a:rPr lang="en-US" sz="1500" dirty="0">
-                <a:solidFill>
-                  <a:srgbClr val="14181D"/>
+            <a:pPr indent="0" marL="0">
+              <a:buNone/>
+            </a:pPr>
+            <a:r>
+              <a:rPr lang="en-US" sz="1400" dirty="0">
+                <a:solidFill>
+                  <a:srgbClr val="4A525C"/>
                 </a:solidFill>
                 <a:latin typeface="Calibri" pitchFamily="34" charset="0"/>
                 <a:ea typeface="Calibri" pitchFamily="34" charset="-122"/>
                 <a:cs typeface="Calibri" pitchFamily="34" charset="-120"/>
               </a:rPr>
-              <a:t>The reader is tested in English only. Tenants speak Kriol, Aboriginal English and many languages</a:t>
-            </a:r>
-            <a:endParaRPr lang="en-US" sz="1500" dirty="0"/>
-          </a:p>
-        </p:txBody>
-      </p:sp>
-      <p:sp>
-        <p:nvSpPr>
-          <p:cNvPr id="14" name="limit-2"/>
-          <p:cNvSpPr txBox="1"/>
-          <p:nvPr/>
-        </p:nvSpPr>
-        <p:spPr>
-          <a:xfrm>
-            <a:off x="6537960" y="4069080"/>
-            <a:ext cx="4846320" cy="868680"/>
+              <a:t>Fixed, still broken, got worse or a review. A fix that didn't hold moves up the line</a:t>
+            </a:r>
+            <a:endParaRPr lang="en-US" sz="1400" dirty="0"/>
+          </a:p>
+        </p:txBody>
+      </p:sp>
+      <p:sp>
+        <p:nvSpPr>
+          <p:cNvPr id="16" name="trust-hex-4"/>
+          <p:cNvSpPr/>
+          <p:nvPr/>
+        </p:nvSpPr>
+        <p:spPr>
+          <a:xfrm>
+            <a:off x="3108960" y="4590288"/>
+            <a:ext cx="512064" cy="450616"/>
+          </a:xfrm>
+          <a:prstGeom prst="hexagon">
+            <a:avLst/>
+          </a:prstGeom>
+          <a:solidFill>
+            <a:srgbClr val="0E8FB8"/>
+          </a:solidFill>
+          <a:ln w="12700">
+            <a:solidFill>
+              <a:srgbClr val="0E8FB8"/>
+            </a:solidFill>
+            <a:prstDash val="solid"/>
+          </a:ln>
+        </p:spPr>
+      </p:sp>
+      <p:sp>
+        <p:nvSpPr>
+          <p:cNvPr id="17" name="trust-h-4"/>
+          <p:cNvSpPr txBox="1"/>
+          <p:nvPr/>
+        </p:nvSpPr>
+        <p:spPr>
+          <a:xfrm>
+            <a:off x="3840480" y="4535424"/>
+            <a:ext cx="7772400" cy="347472"/>
           </a:xfrm>
           <a:prstGeom prst="rect">
             <a:avLst/>
@@ -5156,12 +5640,11 @@
           <a:bodyPr wrap="square" lIns="0" tIns="0" rIns="0" bIns="0" rtlCol="0" anchor="t"/>
           <a:lstStyle/>
           <a:p>
-            <a:pPr marL="342900" indent="-342900">
-              <a:buSzPct val="100000"/>
-              <a:buChar char="•"/>
-            </a:pPr>
-            <a:r>
-              <a:rPr lang="en-US" sz="1500" dirty="0">
+            <a:pPr indent="0" marL="0">
+              <a:buNone/>
+            </a:pPr>
+            <a:r>
+              <a:rPr lang="en-US" sz="1700" b="1" dirty="0">
                 <a:solidFill>
                   <a:srgbClr val="14181D"/>
                 </a:solidFill>
@@ -5169,22 +5652,22 @@
                 <a:ea typeface="Calibri" pitchFamily="34" charset="-122"/>
                 <a:cs typeface="Calibri" pitchFamily="34" charset="-120"/>
               </a:rPr>
-              <a:t>No community has reviewed it yet. That comes first, not last</a:t>
-            </a:r>
-            <a:endParaRPr lang="en-US" sz="1500" dirty="0"/>
-          </a:p>
-        </p:txBody>
-      </p:sp>
-      <p:sp>
-        <p:nvSpPr>
-          <p:cNvPr id="15" name="limit-3"/>
-          <p:cNvSpPr txBox="1"/>
-          <p:nvPr/>
-        </p:nvSpPr>
-        <p:spPr>
-          <a:xfrm>
-            <a:off x="6537960" y="4983480"/>
-            <a:ext cx="4846320" cy="868680"/>
+              <a:t>People check the AI every week</a:t>
+            </a:r>
+            <a:endParaRPr lang="en-US" sz="1700" dirty="0"/>
+          </a:p>
+        </p:txBody>
+      </p:sp>
+      <p:sp>
+        <p:nvSpPr>
+          <p:cNvPr id="18" name="trust-b-4"/>
+          <p:cNvSpPr txBox="1"/>
+          <p:nvPr/>
+        </p:nvSpPr>
+        <p:spPr>
+          <a:xfrm>
+            <a:off x="3840480" y="4892040"/>
+            <a:ext cx="7772400" cy="411480"/>
           </a:xfrm>
           <a:prstGeom prst="rect">
             <a:avLst/>
@@ -5196,22 +5679,124 @@
           <a:bodyPr wrap="square" lIns="0" tIns="0" rIns="0" bIns="0" rtlCol="0" anchor="t"/>
           <a:lstStyle/>
           <a:p>
-            <a:pPr marL="342900" indent="-342900">
-              <a:buSzPct val="100000"/>
-              <a:buChar char="•"/>
-            </a:pPr>
-            <a:r>
-              <a:rPr lang="en-US" sz="1500" dirty="0">
-                <a:solidFill>
-                  <a:srgbClr val="14181D"/>
+            <a:pPr indent="0" marL="0">
+              <a:buNone/>
+            </a:pPr>
+            <a:r>
+              <a:rPr lang="en-US" sz="1400" dirty="0">
+                <a:solidFill>
+                  <a:srgbClr val="4A525C"/>
                 </a:solidFill>
                 <a:latin typeface="Calibri" pitchFamily="34" charset="0"/>
                 <a:ea typeface="Calibri" pitchFamily="34" charset="-122"/>
                 <a:cs typeface="Calibri" pitchFamily="34" charset="-120"/>
               </a:rPr>
-              <a:t>Our test kit is ready the day real reports arrive, labelled with the Aboriginal Interpreter Service</a:t>
-            </a:r>
-            <a:endParaRPr lang="en-US" sz="1500" dirty="0"/>
+              <a:t>1 in 20 reports the computer read alone is re-read by a person</a:t>
+            </a:r>
+            <a:endParaRPr lang="en-US" sz="1400" dirty="0"/>
+          </a:p>
+        </p:txBody>
+      </p:sp>
+      <p:sp>
+        <p:nvSpPr>
+          <p:cNvPr id="19" name="trust-hex-5"/>
+          <p:cNvSpPr/>
+          <p:nvPr/>
+        </p:nvSpPr>
+        <p:spPr>
+          <a:xfrm>
+            <a:off x="3108960" y="5404104"/>
+            <a:ext cx="512064" cy="450616"/>
+          </a:xfrm>
+          <a:prstGeom prst="hexagon">
+            <a:avLst/>
+          </a:prstGeom>
+          <a:solidFill>
+            <a:srgbClr val="14181D"/>
+          </a:solidFill>
+          <a:ln w="12700">
+            <a:solidFill>
+              <a:srgbClr val="14181D"/>
+            </a:solidFill>
+            <a:prstDash val="solid"/>
+          </a:ln>
+        </p:spPr>
+      </p:sp>
+      <p:sp>
+        <p:nvSpPr>
+          <p:cNvPr id="20" name="trust-h-5"/>
+          <p:cNvSpPr txBox="1"/>
+          <p:nvPr/>
+        </p:nvSpPr>
+        <p:spPr>
+          <a:xfrm>
+            <a:off x="3840480" y="5349240"/>
+            <a:ext cx="7772400" cy="347472"/>
+          </a:xfrm>
+          <a:prstGeom prst="rect">
+            <a:avLst/>
+          </a:prstGeom>
+          <a:noFill/>
+          <a:ln/>
+        </p:spPr>
+        <p:txBody>
+          <a:bodyPr wrap="square" lIns="0" tIns="0" rIns="0" bIns="0" rtlCol="0" anchor="t"/>
+          <a:lstStyle/>
+          <a:p>
+            <a:pPr indent="0" marL="0">
+              <a:buNone/>
+            </a:pPr>
+            <a:r>
+              <a:rPr lang="en-US" sz="1700" b="1" dirty="0">
+                <a:solidFill>
+                  <a:srgbClr val="14181D"/>
+                </a:solidFill>
+                <a:latin typeface="Calibri" pitchFamily="34" charset="0"/>
+                <a:ea typeface="Calibri" pitchFamily="34" charset="-122"/>
+                <a:cs typeface="Calibri" pitchFamily="34" charset="-120"/>
+              </a:rPr>
+              <a:t>Personal details locked away</a:t>
+            </a:r>
+            <a:endParaRPr lang="en-US" sz="1700" dirty="0"/>
+          </a:p>
+        </p:txBody>
+      </p:sp>
+      <p:sp>
+        <p:nvSpPr>
+          <p:cNvPr id="21" name="trust-b-5"/>
+          <p:cNvSpPr txBox="1"/>
+          <p:nvPr/>
+        </p:nvSpPr>
+        <p:spPr>
+          <a:xfrm>
+            <a:off x="3840480" y="5705856"/>
+            <a:ext cx="7772400" cy="411480"/>
+          </a:xfrm>
+          <a:prstGeom prst="rect">
+            <a:avLst/>
+          </a:prstGeom>
+          <a:noFill/>
+          <a:ln/>
+        </p:spPr>
+        <p:txBody>
+          <a:bodyPr wrap="square" lIns="0" tIns="0" rIns="0" bIns="0" rtlCol="0" anchor="t"/>
+          <a:lstStyle/>
+          <a:p>
+            <a:pPr indent="0" marL="0">
+              <a:buNone/>
+            </a:pPr>
+            <a:r>
+              <a:rPr lang="en-US" sz="1400" dirty="0">
+                <a:solidFill>
+                  <a:srgbClr val="4A525C"/>
+                </a:solidFill>
+                <a:latin typeface="Calibri" pitchFamily="34" charset="0"/>
+                <a:ea typeface="Calibri" pitchFamily="34" charset="-122"/>
+                <a:cs typeface="Calibri" pitchFamily="34" charset="-120"/>
+              </a:rPr>
+              <a:t>Names, phones and addresses in an encrypted vault; the house is just a hexagon</a:t>
+            </a:r>
+            <a:endParaRPr lang="en-US" sz="1400" dirty="0"/>
           </a:p>
         </p:txBody>
       </p:sp>
@@ -5320,7 +5905,7 @@
                 <a:ea typeface="Arial" pitchFamily="34" charset="-122"/>
                 <a:cs typeface="Arial" pitchFamily="34" charset="-120"/>
               </a:rPr>
-              <a:t>What we recommend</a:t>
+              <a:t>What we tested, and what we can't claim yet</a:t>
             </a:r>
             <a:endParaRPr lang="en-US" sz="2800" dirty="0"/>
           </a:p>
@@ -5328,26 +5913,26 @@
       </p:sp>
       <p:sp>
         <p:nvSpPr>
-          <p:cNvPr id="3" name="rec-1"/>
+          <p:cNvPr id="3" name="tested-card"/>
           <p:cNvSpPr/>
           <p:nvPr/>
         </p:nvSpPr>
         <p:spPr>
           <a:xfrm>
-            <a:off x="548640" y="1463040"/>
-            <a:ext cx="11064240" cy="1371600"/>
+            <a:off x="548640" y="1417320"/>
+            <a:ext cx="5349240" cy="4663440"/>
           </a:xfrm>
           <a:prstGeom prst="roundRect">
             <a:avLst>
-              <a:gd name="adj" fmla="val 6667"/>
+              <a:gd name="adj" fmla="val 1961"/>
             </a:avLst>
           </a:prstGeom>
           <a:solidFill>
-            <a:srgbClr val="F1F3F5"/>
+            <a:srgbClr val="E3F4E8"/>
           </a:solidFill>
           <a:ln w="12700">
             <a:solidFill>
-              <a:srgbClr val="F1F3F5"/>
+              <a:srgbClr val="E3F4E8"/>
             </a:solidFill>
             <a:prstDash val="solid"/>
           </a:ln>
@@ -5355,24 +5940,265 @@
       </p:sp>
       <p:sp>
         <p:nvSpPr>
-          <p:cNvPr id="4" name="rec-hex-1"/>
+          <p:cNvPr id="4" name="tested-h"/>
+          <p:cNvSpPr txBox="1"/>
+          <p:nvPr/>
+        </p:nvSpPr>
+        <p:spPr>
+          <a:xfrm>
+            <a:off x="822960" y="1645920"/>
+            <a:ext cx="4846320" cy="457200"/>
+          </a:xfrm>
+          <a:prstGeom prst="rect">
+            <a:avLst/>
+          </a:prstGeom>
+          <a:noFill/>
+          <a:ln/>
+        </p:spPr>
+        <p:txBody>
+          <a:bodyPr wrap="square" lIns="0" tIns="0" rIns="0" bIns="0" rtlCol="0" anchor="t"/>
+          <a:lstStyle/>
+          <a:p>
+            <a:pPr indent="0" marL="0">
+              <a:buNone/>
+            </a:pPr>
+            <a:r>
+              <a:rPr lang="en-US" sz="2200" b="1" dirty="0">
+                <a:solidFill>
+                  <a:srgbClr val="1F9D4C"/>
+                </a:solidFill>
+                <a:latin typeface="Arial" pitchFamily="34" charset="0"/>
+                <a:ea typeface="Arial" pitchFamily="34" charset="-122"/>
+                <a:cs typeface="Arial" pitchFamily="34" charset="-120"/>
+              </a:rPr>
+              <a:t>Tested</a:t>
+            </a:r>
+            <a:endParaRPr lang="en-US" sz="2200" dirty="0"/>
+          </a:p>
+        </p:txBody>
+      </p:sp>
+      <p:sp>
+        <p:nvSpPr>
+          <p:cNvPr id="5" name="tested-0"/>
+          <p:cNvSpPr txBox="1"/>
+          <p:nvPr/>
+        </p:nvSpPr>
+        <p:spPr>
+          <a:xfrm>
+            <a:off x="822960" y="2240280"/>
+            <a:ext cx="4846320" cy="685800"/>
+          </a:xfrm>
+          <a:prstGeom prst="rect">
+            <a:avLst/>
+          </a:prstGeom>
+          <a:noFill/>
+          <a:ln/>
+        </p:spPr>
+        <p:txBody>
+          <a:bodyPr wrap="square" lIns="0" tIns="0" rIns="0" bIns="0" rtlCol="0" anchor="t"/>
+          <a:lstStyle/>
+          <a:p>
+            <a:pPr marL="342900" indent="-342900">
+              <a:buSzPct val="100000"/>
+              <a:buChar char="•"/>
+            </a:pPr>
+            <a:r>
+              <a:rPr lang="en-US" sz="1500" dirty="0">
+                <a:solidFill>
+                  <a:srgbClr val="14181D"/>
+                </a:solidFill>
+                <a:latin typeface="Calibri" pitchFamily="34" charset="0"/>
+                <a:ea typeface="Calibri" pitchFamily="34" charset="-122"/>
+                <a:cs typeface="Calibri" pitchFamily="34" charset="-120"/>
+              </a:rPr>
+              <a:t>98 automated checks on every code change: data, the reader, fair intake, the planner, the server</a:t>
+            </a:r>
+            <a:endParaRPr lang="en-US" sz="1500" dirty="0"/>
+          </a:p>
+        </p:txBody>
+      </p:sp>
+      <p:sp>
+        <p:nvSpPr>
+          <p:cNvPr id="6" name="tested-1"/>
+          <p:cNvSpPr txBox="1"/>
+          <p:nvPr/>
+        </p:nvSpPr>
+        <p:spPr>
+          <a:xfrm>
+            <a:off x="822960" y="2990088"/>
+            <a:ext cx="4846320" cy="685800"/>
+          </a:xfrm>
+          <a:prstGeom prst="rect">
+            <a:avLst/>
+          </a:prstGeom>
+          <a:noFill/>
+          <a:ln/>
+        </p:spPr>
+        <p:txBody>
+          <a:bodyPr wrap="square" lIns="0" tIns="0" rIns="0" bIns="0" rtlCol="0" anchor="t"/>
+          <a:lstStyle/>
+          <a:p>
+            <a:pPr marL="342900" indent="-342900">
+              <a:buSzPct val="100000"/>
+              <a:buChar char="•"/>
+            </a:pPr>
+            <a:r>
+              <a:rPr lang="en-US" sz="1500" dirty="0">
+                <a:solidFill>
+                  <a:srgbClr val="14181D"/>
+                </a:solidFill>
+                <a:latin typeface="Calibri" pitchFamily="34" charset="0"/>
+                <a:ea typeface="Calibri" pitchFamily="34" charset="-122"/>
+                <a:cs typeface="Calibri" pitchFamily="34" charset="-120"/>
+              </a:rPr>
+              <a:t>Five random years of requests; the result held in all five</a:t>
+            </a:r>
+            <a:endParaRPr lang="en-US" sz="1500" dirty="0"/>
+          </a:p>
+        </p:txBody>
+      </p:sp>
+      <p:sp>
+        <p:nvSpPr>
+          <p:cNvPr id="7" name="tested-2"/>
+          <p:cNvSpPr txBox="1"/>
+          <p:nvPr/>
+        </p:nvSpPr>
+        <p:spPr>
+          <a:xfrm>
+            <a:off x="822960" y="3739896"/>
+            <a:ext cx="4846320" cy="685800"/>
+          </a:xfrm>
+          <a:prstGeom prst="rect">
+            <a:avLst/>
+          </a:prstGeom>
+          <a:noFill/>
+          <a:ln/>
+        </p:spPr>
+        <p:txBody>
+          <a:bodyPr wrap="square" lIns="0" tIns="0" rIns="0" bIns="0" rtlCol="0" anchor="t"/>
+          <a:lstStyle/>
+          <a:p>
+            <a:pPr marL="342900" indent="-342900">
+              <a:buSzPct val="100000"/>
+              <a:buChar char="•"/>
+            </a:pPr>
+            <a:r>
+              <a:rPr lang="en-US" sz="1500" dirty="0">
+                <a:solidFill>
+                  <a:srgbClr val="14181D"/>
+                </a:solidFill>
+                <a:latin typeface="Calibri" pitchFamily="34" charset="0"/>
+                <a:ea typeface="Calibri" pitchFamily="34" charset="-122"/>
+                <a:cs typeface="Calibri" pitchFamily="34" charset="-120"/>
+              </a:rPr>
+              <a:t>Every community's position checked against satellite photos</a:t>
+            </a:r>
+            <a:endParaRPr lang="en-US" sz="1500" dirty="0"/>
+          </a:p>
+        </p:txBody>
+      </p:sp>
+      <p:sp>
+        <p:nvSpPr>
+          <p:cNvPr id="8" name="tested-3"/>
+          <p:cNvSpPr txBox="1"/>
+          <p:nvPr/>
+        </p:nvSpPr>
+        <p:spPr>
+          <a:xfrm>
+            <a:off x="822960" y="4489704"/>
+            <a:ext cx="4846320" cy="685800"/>
+          </a:xfrm>
+          <a:prstGeom prst="rect">
+            <a:avLst/>
+          </a:prstGeom>
+          <a:noFill/>
+          <a:ln/>
+        </p:spPr>
+        <p:txBody>
+          <a:bodyPr wrap="square" lIns="0" tIns="0" rIns="0" bIns="0" rtlCol="0" anchor="t"/>
+          <a:lstStyle/>
+          <a:p>
+            <a:pPr marL="342900" indent="-342900">
+              <a:buSzPct val="100000"/>
+              <a:buChar char="•"/>
+            </a:pPr>
+            <a:r>
+              <a:rPr lang="en-US" sz="1500" dirty="0">
+                <a:solidFill>
+                  <a:srgbClr val="14181D"/>
+                </a:solidFill>
+                <a:latin typeface="Calibri" pitchFamily="34" charset="0"/>
+                <a:ea typeface="Calibri" pitchFamily="34" charset="-122"/>
+                <a:cs typeface="Calibri" pitchFamily="34" charset="-120"/>
+              </a:rPr>
+              <a:t>Accessibility: 0 WCAG 2.2 AA issues in every view</a:t>
+            </a:r>
+            <a:endParaRPr lang="en-US" sz="1500" dirty="0"/>
+          </a:p>
+        </p:txBody>
+      </p:sp>
+      <p:sp>
+        <p:nvSpPr>
+          <p:cNvPr id="9" name="tested-4"/>
+          <p:cNvSpPr txBox="1"/>
+          <p:nvPr/>
+        </p:nvSpPr>
+        <p:spPr>
+          <a:xfrm>
+            <a:off x="822960" y="5239512"/>
+            <a:ext cx="4846320" cy="685800"/>
+          </a:xfrm>
+          <a:prstGeom prst="rect">
+            <a:avLst/>
+          </a:prstGeom>
+          <a:noFill/>
+          <a:ln/>
+        </p:spPr>
+        <p:txBody>
+          <a:bodyPr wrap="square" lIns="0" tIns="0" rIns="0" bIns="0" rtlCol="0" anchor="t"/>
+          <a:lstStyle/>
+          <a:p>
+            <a:pPr marL="342900" indent="-342900">
+              <a:buSzPct val="100000"/>
+              <a:buChar char="•"/>
+            </a:pPr>
+            <a:r>
+              <a:rPr lang="en-US" sz="1500" dirty="0">
+                <a:solidFill>
+                  <a:srgbClr val="14181D"/>
+                </a:solidFill>
+                <a:latin typeface="Calibri" pitchFamily="34" charset="0"/>
+                <a:ea typeface="Calibri" pitchFamily="34" charset="-122"/>
+                <a:cs typeface="Calibri" pitchFamily="34" charset="-120"/>
+              </a:rPr>
+              <a:t>Security: locked-down site, validated inputs, sign-in rules ready</a:t>
+            </a:r>
+            <a:endParaRPr lang="en-US" sz="1500" dirty="0"/>
+          </a:p>
+        </p:txBody>
+      </p:sp>
+      <p:sp>
+        <p:nvSpPr>
+          <p:cNvPr id="10" name="limits-card"/>
           <p:cNvSpPr/>
           <p:nvPr/>
         </p:nvSpPr>
         <p:spPr>
           <a:xfrm>
-            <a:off x="868680" y="1737360"/>
-            <a:ext cx="868680" cy="764438"/>
-          </a:xfrm>
-          <a:prstGeom prst="hexagon">
-            <a:avLst/>
+            <a:off x="6263640" y="1417320"/>
+            <a:ext cx="5349240" cy="4663440"/>
+          </a:xfrm>
+          <a:prstGeom prst="roundRect">
+            <a:avLst>
+              <a:gd name="adj" fmla="val 1961"/>
+            </a:avLst>
           </a:prstGeom>
           <a:solidFill>
-            <a:srgbClr val="D97706"/>
+            <a:srgbClr val="FBEEDD"/>
           </a:solidFill>
           <a:ln w="12700">
             <a:solidFill>
-              <a:srgbClr val="D97706"/>
+              <a:srgbClr val="FBEEDD"/>
             </a:solidFill>
             <a:prstDash val="solid"/>
           </a:ln>
@@ -5380,53 +6206,53 @@
       </p:sp>
       <p:sp>
         <p:nvSpPr>
-          <p:cNvPr id="5" name="rec-hex-1-t"/>
-          <p:cNvSpPr txBox="1"/>
-          <p:nvPr/>
-        </p:nvSpPr>
-        <p:spPr>
-          <a:xfrm>
-            <a:off x="868680" y="1737360"/>
-            <a:ext cx="868680" cy="764438"/>
-          </a:xfrm>
-          <a:prstGeom prst="rect">
-            <a:avLst/>
-          </a:prstGeom>
-          <a:noFill/>
-          <a:ln/>
-        </p:spPr>
-        <p:txBody>
-          <a:bodyPr wrap="square" lIns="0" tIns="0" rIns="0" bIns="0" rtlCol="0" anchor="ctr"/>
-          <a:lstStyle/>
-          <a:p>
-            <a:pPr algn="ctr" indent="0" marL="0">
-              <a:buNone/>
-            </a:pPr>
-            <a:r>
-              <a:rPr lang="en-US" sz="2400" b="1" dirty="0">
-                <a:solidFill>
-                  <a:srgbClr val="FFFFFF"/>
+          <p:cNvPr id="11" name="limits-h"/>
+          <p:cNvSpPr txBox="1"/>
+          <p:nvPr/>
+        </p:nvSpPr>
+        <p:spPr>
+          <a:xfrm>
+            <a:off x="6537960" y="1645920"/>
+            <a:ext cx="4846320" cy="457200"/>
+          </a:xfrm>
+          <a:prstGeom prst="rect">
+            <a:avLst/>
+          </a:prstGeom>
+          <a:noFill/>
+          <a:ln/>
+        </p:spPr>
+        <p:txBody>
+          <a:bodyPr wrap="square" lIns="0" tIns="0" rIns="0" bIns="0" rtlCol="0" anchor="t"/>
+          <a:lstStyle/>
+          <a:p>
+            <a:pPr indent="0" marL="0">
+              <a:buNone/>
+            </a:pPr>
+            <a:r>
+              <a:rPr lang="en-US" sz="2200" b="1" dirty="0">
+                <a:solidFill>
+                  <a:srgbClr val="D97706"/>
                 </a:solidFill>
                 <a:latin typeface="Arial" pitchFamily="34" charset="0"/>
                 <a:ea typeface="Arial" pitchFamily="34" charset="-122"/>
                 <a:cs typeface="Arial" pitchFamily="34" charset="-120"/>
               </a:rPr>
-              <a:t>1</a:t>
-            </a:r>
-            <a:endParaRPr lang="en-US" sz="2400" dirty="0"/>
-          </a:p>
-        </p:txBody>
-      </p:sp>
-      <p:sp>
-        <p:nvSpPr>
-          <p:cNvPr id="6" name="rec-h-1"/>
-          <p:cNvSpPr txBox="1"/>
-          <p:nvPr/>
-        </p:nvSpPr>
-        <p:spPr>
-          <a:xfrm>
-            <a:off x="2057400" y="1664208"/>
-            <a:ext cx="9326880" cy="411480"/>
+              <a:t>Not yet</a:t>
+            </a:r>
+            <a:endParaRPr lang="en-US" sz="2200" dirty="0"/>
+          </a:p>
+        </p:txBody>
+      </p:sp>
+      <p:sp>
+        <p:nvSpPr>
+          <p:cNvPr id="12" name="limit-0"/>
+          <p:cNvSpPr txBox="1"/>
+          <p:nvPr/>
+        </p:nvSpPr>
+        <p:spPr>
+          <a:xfrm>
+            <a:off x="6537960" y="2240280"/>
+            <a:ext cx="4846320" cy="868680"/>
           </a:xfrm>
           <a:prstGeom prst="rect">
             <a:avLst/>
@@ -5438,164 +6264,35 @@
           <a:bodyPr wrap="square" lIns="0" tIns="0" rIns="0" bIns="0" rtlCol="0" anchor="t"/>
           <a:lstStyle/>
           <a:p>
-            <a:pPr indent="0" marL="0">
-              <a:buNone/>
-            </a:pPr>
-            <a:r>
-              <a:rPr lang="en-US" sz="2100" b="1" dirty="0">
+            <a:pPr marL="342900" indent="-342900">
+              <a:buSzPct val="100000"/>
+              <a:buChar char="•"/>
+            </a:pPr>
+            <a:r>
+              <a:rPr lang="en-US" sz="1500" dirty="0">
                 <a:solidFill>
                   <a:srgbClr val="14181D"/>
-                </a:solidFill>
-                <a:latin typeface="Arial" pitchFamily="34" charset="0"/>
-                <a:ea typeface="Arial" pitchFamily="34" charset="-122"/>
-                <a:cs typeface="Arial" pitchFamily="34" charset="-120"/>
-              </a:rPr>
-              <a:t>Make the trade-off a signed decision</a:t>
-            </a:r>
-            <a:endParaRPr lang="en-US" sz="2100" dirty="0"/>
-          </a:p>
-        </p:txBody>
-      </p:sp>
-      <p:sp>
-        <p:nvSpPr>
-          <p:cNvPr id="7" name="rec-b-1"/>
-          <p:cNvSpPr txBox="1"/>
-          <p:nvPr/>
-        </p:nvSpPr>
-        <p:spPr>
-          <a:xfrm>
-            <a:off x="2057400" y="2121408"/>
-            <a:ext cx="9326880" cy="640080"/>
-          </a:xfrm>
-          <a:prstGeom prst="rect">
-            <a:avLst/>
-          </a:prstGeom>
-          <a:noFill/>
-          <a:ln/>
-        </p:spPr>
-        <p:txBody>
-          <a:bodyPr wrap="square" lIns="0" tIns="0" rIns="0" bIns="0" rtlCol="0" anchor="t"/>
-          <a:lstStyle/>
-          <a:p>
-            <a:pPr indent="0" marL="0">
-              <a:buNone/>
-            </a:pPr>
-            <a:r>
-              <a:rPr lang="en-US" sz="1600" dirty="0">
-                <a:solidFill>
-                  <a:srgbClr val="4A525C"/>
                 </a:solidFill>
                 <a:latin typeface="Calibri" pitchFamily="34" charset="0"/>
                 <a:ea typeface="Calibri" pitchFamily="34" charset="-122"/>
                 <a:cs typeface="Calibri" pitchFamily="34" charset="-120"/>
               </a:rPr>
-              <a:t>Publish the triage rules, ask every tenant the same questions however they report, and record who decides how much cost may count.</a:t>
-            </a:r>
-            <a:endParaRPr lang="en-US" sz="1600" dirty="0"/>
-          </a:p>
-        </p:txBody>
-      </p:sp>
-      <p:sp>
-        <p:nvSpPr>
-          <p:cNvPr id="8" name="rec-2"/>
-          <p:cNvSpPr/>
-          <p:nvPr/>
-        </p:nvSpPr>
-        <p:spPr>
-          <a:xfrm>
-            <a:off x="548640" y="3017520"/>
-            <a:ext cx="11064240" cy="1371600"/>
-          </a:xfrm>
-          <a:prstGeom prst="roundRect">
-            <a:avLst>
-              <a:gd name="adj" fmla="val 6667"/>
-            </a:avLst>
-          </a:prstGeom>
-          <a:solidFill>
-            <a:srgbClr val="F1F3F5"/>
-          </a:solidFill>
-          <a:ln w="12700">
-            <a:solidFill>
-              <a:srgbClr val="F1F3F5"/>
-            </a:solidFill>
-            <a:prstDash val="solid"/>
-          </a:ln>
-        </p:spPr>
-      </p:sp>
-      <p:sp>
-        <p:nvSpPr>
-          <p:cNvPr id="9" name="rec-hex-2"/>
-          <p:cNvSpPr/>
-          <p:nvPr/>
-        </p:nvSpPr>
-        <p:spPr>
-          <a:xfrm>
-            <a:off x="868680" y="3291840"/>
-            <a:ext cx="868680" cy="764438"/>
-          </a:xfrm>
-          <a:prstGeom prst="hexagon">
-            <a:avLst/>
-          </a:prstGeom>
-          <a:solidFill>
-            <a:srgbClr val="0E8FB8"/>
-          </a:solidFill>
-          <a:ln w="12700">
-            <a:solidFill>
-              <a:srgbClr val="0E8FB8"/>
-            </a:solidFill>
-            <a:prstDash val="solid"/>
-          </a:ln>
-        </p:spPr>
-      </p:sp>
-      <p:sp>
-        <p:nvSpPr>
-          <p:cNvPr id="10" name="rec-hex-2-t"/>
-          <p:cNvSpPr txBox="1"/>
-          <p:nvPr/>
-        </p:nvSpPr>
-        <p:spPr>
-          <a:xfrm>
-            <a:off x="868680" y="3291840"/>
-            <a:ext cx="868680" cy="764438"/>
-          </a:xfrm>
-          <a:prstGeom prst="rect">
-            <a:avLst/>
-          </a:prstGeom>
-          <a:noFill/>
-          <a:ln/>
-        </p:spPr>
-        <p:txBody>
-          <a:bodyPr wrap="square" lIns="0" tIns="0" rIns="0" bIns="0" rtlCol="0" anchor="ctr"/>
-          <a:lstStyle/>
-          <a:p>
-            <a:pPr algn="ctr" indent="0" marL="0">
-              <a:buNone/>
-            </a:pPr>
-            <a:r>
-              <a:rPr lang="en-US" sz="2400" b="1" dirty="0">
-                <a:solidFill>
-                  <a:srgbClr val="FFFFFF"/>
-                </a:solidFill>
-                <a:latin typeface="Arial" pitchFamily="34" charset="0"/>
-                <a:ea typeface="Arial" pitchFamily="34" charset="-122"/>
-                <a:cs typeface="Arial" pitchFamily="34" charset="-120"/>
-              </a:rPr>
-              <a:t>2</a:t>
-            </a:r>
-            <a:endParaRPr lang="en-US" sz="2400" dirty="0"/>
-          </a:p>
-        </p:txBody>
-      </p:sp>
-      <p:sp>
-        <p:nvSpPr>
-          <p:cNvPr id="11" name="rec-h-2"/>
-          <p:cNvSpPr txBox="1"/>
-          <p:nvPr/>
-        </p:nvSpPr>
-        <p:spPr>
-          <a:xfrm>
-            <a:off x="2057400" y="3218688"/>
-            <a:ext cx="9326880" cy="411480"/>
+              <a:t>The repair requests and households are synthetic: no public NT repair data exists</a:t>
+            </a:r>
+            <a:endParaRPr lang="en-US" sz="1500" dirty="0"/>
+          </a:p>
+        </p:txBody>
+      </p:sp>
+      <p:sp>
+        <p:nvSpPr>
+          <p:cNvPr id="13" name="limit-1"/>
+          <p:cNvSpPr txBox="1"/>
+          <p:nvPr/>
+        </p:nvSpPr>
+        <p:spPr>
+          <a:xfrm>
+            <a:off x="6537960" y="3154680"/>
+            <a:ext cx="4846320" cy="868680"/>
           </a:xfrm>
           <a:prstGeom prst="rect">
             <a:avLst/>
@@ -5607,164 +6304,35 @@
           <a:bodyPr wrap="square" lIns="0" tIns="0" rIns="0" bIns="0" rtlCol="0" anchor="t"/>
           <a:lstStyle/>
           <a:p>
-            <a:pPr indent="0" marL="0">
-              <a:buNone/>
-            </a:pPr>
-            <a:r>
-              <a:rPr lang="en-US" sz="2100" b="1" dirty="0">
+            <a:pPr marL="342900" indent="-342900">
+              <a:buSzPct val="100000"/>
+              <a:buChar char="•"/>
+            </a:pPr>
+            <a:r>
+              <a:rPr lang="en-US" sz="1500" dirty="0">
                 <a:solidFill>
                   <a:srgbClr val="14181D"/>
-                </a:solidFill>
-                <a:latin typeface="Arial" pitchFamily="34" charset="0"/>
-                <a:ea typeface="Arial" pitchFamily="34" charset="-122"/>
-                <a:cs typeface="Arial" pitchFamily="34" charset="-120"/>
-              </a:rPr>
-              <a:t>Pilot in one region, with communities</a:t>
-            </a:r>
-            <a:endParaRPr lang="en-US" sz="2100" dirty="0"/>
-          </a:p>
-        </p:txBody>
-      </p:sp>
-      <p:sp>
-        <p:nvSpPr>
-          <p:cNvPr id="12" name="rec-b-2"/>
-          <p:cNvSpPr txBox="1"/>
-          <p:nvPr/>
-        </p:nvSpPr>
-        <p:spPr>
-          <a:xfrm>
-            <a:off x="2057400" y="3675888"/>
-            <a:ext cx="9326880" cy="640080"/>
-          </a:xfrm>
-          <a:prstGeom prst="rect">
-            <a:avLst/>
-          </a:prstGeom>
-          <a:noFill/>
-          <a:ln/>
-        </p:spPr>
-        <p:txBody>
-          <a:bodyPr wrap="square" lIns="0" tIns="0" rIns="0" bIns="0" rtlCol="0" anchor="t"/>
-          <a:lstStyle/>
-          <a:p>
-            <a:pPr indent="0" marL="0">
-              <a:buNone/>
-            </a:pPr>
-            <a:r>
-              <a:rPr lang="en-US" sz="1600" dirty="0">
-                <a:solidFill>
-                  <a:srgbClr val="4A525C"/>
                 </a:solidFill>
                 <a:latin typeface="Calibri" pitchFamily="34" charset="0"/>
                 <a:ea typeface="Calibri" pitchFamily="34" charset="-122"/>
                 <a:cs typeface="Calibri" pitchFamily="34" charset="-120"/>
               </a:rPr>
-              <a:t>Start with the Katherine hub's 16 communities, co-designed with tenants, Aboriginal Housing NT, land councils and the Interpreter Service.</a:t>
-            </a:r>
-            <a:endParaRPr lang="en-US" sz="1600" dirty="0"/>
-          </a:p>
-        </p:txBody>
-      </p:sp>
-      <p:sp>
-        <p:nvSpPr>
-          <p:cNvPr id="13" name="rec-3"/>
-          <p:cNvSpPr/>
-          <p:nvPr/>
-        </p:nvSpPr>
-        <p:spPr>
-          <a:xfrm>
-            <a:off x="548640" y="4572000"/>
-            <a:ext cx="11064240" cy="1371600"/>
-          </a:xfrm>
-          <a:prstGeom prst="roundRect">
-            <a:avLst>
-              <a:gd name="adj" fmla="val 6667"/>
-            </a:avLst>
-          </a:prstGeom>
-          <a:solidFill>
-            <a:srgbClr val="F1F3F5"/>
-          </a:solidFill>
-          <a:ln w="12700">
-            <a:solidFill>
-              <a:srgbClr val="F1F3F5"/>
-            </a:solidFill>
-            <a:prstDash val="solid"/>
-          </a:ln>
-        </p:spPr>
-      </p:sp>
-      <p:sp>
-        <p:nvSpPr>
-          <p:cNvPr id="14" name="rec-hex-3"/>
-          <p:cNvSpPr/>
-          <p:nvPr/>
-        </p:nvSpPr>
-        <p:spPr>
-          <a:xfrm>
-            <a:off x="868680" y="4846320"/>
-            <a:ext cx="868680" cy="764438"/>
-          </a:xfrm>
-          <a:prstGeom prst="hexagon">
-            <a:avLst/>
-          </a:prstGeom>
-          <a:solidFill>
-            <a:srgbClr val="6E56CF"/>
-          </a:solidFill>
-          <a:ln w="12700">
-            <a:solidFill>
-              <a:srgbClr val="6E56CF"/>
-            </a:solidFill>
-            <a:prstDash val="solid"/>
-          </a:ln>
-        </p:spPr>
-      </p:sp>
-      <p:sp>
-        <p:nvSpPr>
-          <p:cNvPr id="15" name="rec-hex-3-t"/>
-          <p:cNvSpPr txBox="1"/>
-          <p:nvPr/>
-        </p:nvSpPr>
-        <p:spPr>
-          <a:xfrm>
-            <a:off x="868680" y="4846320"/>
-            <a:ext cx="868680" cy="764438"/>
-          </a:xfrm>
-          <a:prstGeom prst="rect">
-            <a:avLst/>
-          </a:prstGeom>
-          <a:noFill/>
-          <a:ln/>
-        </p:spPr>
-        <p:txBody>
-          <a:bodyPr wrap="square" lIns="0" tIns="0" rIns="0" bIns="0" rtlCol="0" anchor="ctr"/>
-          <a:lstStyle/>
-          <a:p>
-            <a:pPr algn="ctr" indent="0" marL="0">
-              <a:buNone/>
-            </a:pPr>
-            <a:r>
-              <a:rPr lang="en-US" sz="2400" b="1" dirty="0">
-                <a:solidFill>
-                  <a:srgbClr val="FFFFFF"/>
-                </a:solidFill>
-                <a:latin typeface="Arial" pitchFamily="34" charset="0"/>
-                <a:ea typeface="Arial" pitchFamily="34" charset="-122"/>
-                <a:cs typeface="Arial" pitchFamily="34" charset="-120"/>
-              </a:rPr>
-              <a:t>3</a:t>
-            </a:r>
-            <a:endParaRPr lang="en-US" sz="2400" dirty="0"/>
-          </a:p>
-        </p:txBody>
-      </p:sp>
-      <p:sp>
-        <p:nvSpPr>
-          <p:cNvPr id="16" name="rec-h-3"/>
-          <p:cNvSpPr txBox="1"/>
-          <p:nvPr/>
-        </p:nvSpPr>
-        <p:spPr>
-          <a:xfrm>
-            <a:off x="2057400" y="4773168"/>
-            <a:ext cx="9326880" cy="411480"/>
+              <a:t>The reader is tested in English only. Tenants speak Kriol, Aboriginal English and many languages</a:t>
+            </a:r>
+            <a:endParaRPr lang="en-US" sz="1500" dirty="0"/>
+          </a:p>
+        </p:txBody>
+      </p:sp>
+      <p:sp>
+        <p:nvSpPr>
+          <p:cNvPr id="14" name="limit-2"/>
+          <p:cNvSpPr txBox="1"/>
+          <p:nvPr/>
+        </p:nvSpPr>
+        <p:spPr>
+          <a:xfrm>
+            <a:off x="6537960" y="4069080"/>
+            <a:ext cx="4846320" cy="868680"/>
           </a:xfrm>
           <a:prstGeom prst="rect">
             <a:avLst/>
@@ -5776,60 +6344,62 @@
           <a:bodyPr wrap="square" lIns="0" tIns="0" rIns="0" bIns="0" rtlCol="0" anchor="t"/>
           <a:lstStyle/>
           <a:p>
-            <a:pPr indent="0" marL="0">
-              <a:buNone/>
-            </a:pPr>
-            <a:r>
-              <a:rPr lang="en-US" sz="2100" b="1" dirty="0">
+            <a:pPr marL="342900" indent="-342900">
+              <a:buSzPct val="100000"/>
+              <a:buChar char="•"/>
+            </a:pPr>
+            <a:r>
+              <a:rPr lang="en-US" sz="1500" dirty="0">
                 <a:solidFill>
                   <a:srgbClr val="14181D"/>
-                </a:solidFill>
-                <a:latin typeface="Arial" pitchFamily="34" charset="0"/>
-                <a:ea typeface="Arial" pitchFamily="34" charset="-122"/>
-                <a:cs typeface="Arial" pitchFamily="34" charset="-120"/>
-              </a:rPr>
-              <a:t>Test the AI on real words first</a:t>
-            </a:r>
-            <a:endParaRPr lang="en-US" sz="2100" dirty="0"/>
-          </a:p>
-        </p:txBody>
-      </p:sp>
-      <p:sp>
-        <p:nvSpPr>
-          <p:cNvPr id="17" name="rec-b-3"/>
-          <p:cNvSpPr txBox="1"/>
-          <p:nvPr/>
-        </p:nvSpPr>
-        <p:spPr>
-          <a:xfrm>
-            <a:off x="2057400" y="5230368"/>
-            <a:ext cx="9326880" cy="640080"/>
-          </a:xfrm>
-          <a:prstGeom prst="rect">
-            <a:avLst/>
-          </a:prstGeom>
-          <a:noFill/>
-          <a:ln/>
-        </p:spPr>
-        <p:txBody>
-          <a:bodyPr wrap="square" lIns="0" tIns="0" rIns="0" bIns="0" rtlCol="0" anchor="t"/>
-          <a:lstStyle/>
-          <a:p>
-            <a:pPr indent="0" marL="0">
-              <a:buNone/>
-            </a:pPr>
-            <a:r>
-              <a:rPr lang="en-US" sz="1600" dirty="0">
-                <a:solidFill>
-                  <a:srgbClr val="4A525C"/>
                 </a:solidFill>
                 <a:latin typeface="Calibri" pitchFamily="34" charset="0"/>
                 <a:ea typeface="Calibri" pitchFamily="34" charset="-122"/>
                 <a:cs typeface="Calibri" pitchFamily="34" charset="-120"/>
               </a:rPr>
-              <a:t>Score the reader on real reports in Kriol and Aboriginal English before it reads a single one on its own.</a:t>
-            </a:r>
-            <a:endParaRPr lang="en-US" sz="1600" dirty="0"/>
+              <a:t>No community has reviewed it yet. That comes first, not last</a:t>
+            </a:r>
+            <a:endParaRPr lang="en-US" sz="1500" dirty="0"/>
+          </a:p>
+        </p:txBody>
+      </p:sp>
+      <p:sp>
+        <p:nvSpPr>
+          <p:cNvPr id="15" name="limit-3"/>
+          <p:cNvSpPr txBox="1"/>
+          <p:nvPr/>
+        </p:nvSpPr>
+        <p:spPr>
+          <a:xfrm>
+            <a:off x="6537960" y="4983480"/>
+            <a:ext cx="4846320" cy="868680"/>
+          </a:xfrm>
+          <a:prstGeom prst="rect">
+            <a:avLst/>
+          </a:prstGeom>
+          <a:noFill/>
+          <a:ln/>
+        </p:spPr>
+        <p:txBody>
+          <a:bodyPr wrap="square" lIns="0" tIns="0" rIns="0" bIns="0" rtlCol="0" anchor="t"/>
+          <a:lstStyle/>
+          <a:p>
+            <a:pPr marL="342900" indent="-342900">
+              <a:buSzPct val="100000"/>
+              <a:buChar char="•"/>
+            </a:pPr>
+            <a:r>
+              <a:rPr lang="en-US" sz="1500" dirty="0">
+                <a:solidFill>
+                  <a:srgbClr val="14181D"/>
+                </a:solidFill>
+                <a:latin typeface="Calibri" pitchFamily="34" charset="0"/>
+                <a:ea typeface="Calibri" pitchFamily="34" charset="-122"/>
+                <a:cs typeface="Calibri" pitchFamily="34" charset="-120"/>
+              </a:rPr>
+              <a:t>Our test kit is ready the day real reports arrive, labelled with the Aboriginal Interpreter Service</a:t>
+            </a:r>
+            <a:endParaRPr lang="en-US" sz="1500" dirty="0"/>
           </a:p>
         </p:txBody>
       </p:sp>
@@ -5903,6 +6473,624 @@
           <a:chExt cx="0" cy="0"/>
         </a:xfrm>
       </p:grpSpPr>
+      <p:sp>
+        <p:nvSpPr>
+          <p:cNvPr id="2" name="Text 0"/>
+          <p:cNvSpPr/>
+          <p:nvPr>
+            <p:ph idx="100" type="title" hasCustomPrompt="1"/>
+          </p:nvPr>
+        </p:nvSpPr>
+        <p:spPr>
+          <a:xfrm>
+            <a:off x="548640" y="365760"/>
+            <a:ext cx="11064240" cy="868680"/>
+          </a:xfrm>
+          <a:prstGeom prst="rect">
+            <a:avLst/>
+          </a:prstGeom>
+          <a:noFill/>
+          <a:ln/>
+        </p:spPr>
+        <p:txBody>
+          <a:bodyPr wrap="square" rtlCol="0" anchor="t"/>
+          <a:lstStyle/>
+          <a:p>
+            <a:pPr algn="l" indent="0" marL="0">
+              <a:buNone/>
+            </a:pPr>
+            <a:r>
+              <a:rPr lang="en-US" sz="2800" b="1" dirty="0">
+                <a:solidFill>
+                  <a:schemeClr val="tx1"/>
+                </a:solidFill>
+                <a:latin typeface="Arial" pitchFamily="34" charset="0"/>
+                <a:ea typeface="Arial" pitchFamily="34" charset="-122"/>
+                <a:cs typeface="Arial" pitchFamily="34" charset="-120"/>
+              </a:rPr>
+              <a:t>What we recommend</a:t>
+            </a:r>
+            <a:endParaRPr lang="en-US" sz="2800" dirty="0"/>
+          </a:p>
+        </p:txBody>
+      </p:sp>
+      <p:sp>
+        <p:nvSpPr>
+          <p:cNvPr id="3" name="rec-1"/>
+          <p:cNvSpPr/>
+          <p:nvPr/>
+        </p:nvSpPr>
+        <p:spPr>
+          <a:xfrm>
+            <a:off x="548640" y="1463040"/>
+            <a:ext cx="11064240" cy="1371600"/>
+          </a:xfrm>
+          <a:prstGeom prst="roundRect">
+            <a:avLst>
+              <a:gd name="adj" fmla="val 6667"/>
+            </a:avLst>
+          </a:prstGeom>
+          <a:solidFill>
+            <a:srgbClr val="F1F3F5"/>
+          </a:solidFill>
+          <a:ln w="12700">
+            <a:solidFill>
+              <a:srgbClr val="F1F3F5"/>
+            </a:solidFill>
+            <a:prstDash val="solid"/>
+          </a:ln>
+        </p:spPr>
+      </p:sp>
+      <p:sp>
+        <p:nvSpPr>
+          <p:cNvPr id="4" name="rec-hex-1"/>
+          <p:cNvSpPr/>
+          <p:nvPr/>
+        </p:nvSpPr>
+        <p:spPr>
+          <a:xfrm>
+            <a:off x="868680" y="1737360"/>
+            <a:ext cx="868680" cy="764438"/>
+          </a:xfrm>
+          <a:prstGeom prst="hexagon">
+            <a:avLst/>
+          </a:prstGeom>
+          <a:solidFill>
+            <a:srgbClr val="D97706"/>
+          </a:solidFill>
+          <a:ln w="12700">
+            <a:solidFill>
+              <a:srgbClr val="D97706"/>
+            </a:solidFill>
+            <a:prstDash val="solid"/>
+          </a:ln>
+        </p:spPr>
+      </p:sp>
+      <p:sp>
+        <p:nvSpPr>
+          <p:cNvPr id="5" name="rec-hex-1-t"/>
+          <p:cNvSpPr txBox="1"/>
+          <p:nvPr/>
+        </p:nvSpPr>
+        <p:spPr>
+          <a:xfrm>
+            <a:off x="868680" y="1737360"/>
+            <a:ext cx="868680" cy="764438"/>
+          </a:xfrm>
+          <a:prstGeom prst="rect">
+            <a:avLst/>
+          </a:prstGeom>
+          <a:noFill/>
+          <a:ln/>
+        </p:spPr>
+        <p:txBody>
+          <a:bodyPr wrap="square" lIns="0" tIns="0" rIns="0" bIns="0" rtlCol="0" anchor="ctr"/>
+          <a:lstStyle/>
+          <a:p>
+            <a:pPr algn="ctr" indent="0" marL="0">
+              <a:buNone/>
+            </a:pPr>
+            <a:r>
+              <a:rPr lang="en-US" sz="2400" b="1" dirty="0">
+                <a:solidFill>
+                  <a:srgbClr val="FFFFFF"/>
+                </a:solidFill>
+                <a:latin typeface="Arial" pitchFamily="34" charset="0"/>
+                <a:ea typeface="Arial" pitchFamily="34" charset="-122"/>
+                <a:cs typeface="Arial" pitchFamily="34" charset="-120"/>
+              </a:rPr>
+              <a:t>1</a:t>
+            </a:r>
+            <a:endParaRPr lang="en-US" sz="2400" dirty="0"/>
+          </a:p>
+        </p:txBody>
+      </p:sp>
+      <p:sp>
+        <p:nvSpPr>
+          <p:cNvPr id="6" name="rec-h-1"/>
+          <p:cNvSpPr txBox="1"/>
+          <p:nvPr/>
+        </p:nvSpPr>
+        <p:spPr>
+          <a:xfrm>
+            <a:off x="2057400" y="1664208"/>
+            <a:ext cx="9326880" cy="411480"/>
+          </a:xfrm>
+          <a:prstGeom prst="rect">
+            <a:avLst/>
+          </a:prstGeom>
+          <a:noFill/>
+          <a:ln/>
+        </p:spPr>
+        <p:txBody>
+          <a:bodyPr wrap="square" lIns="0" tIns="0" rIns="0" bIns="0" rtlCol="0" anchor="t"/>
+          <a:lstStyle/>
+          <a:p>
+            <a:pPr indent="0" marL="0">
+              <a:buNone/>
+            </a:pPr>
+            <a:r>
+              <a:rPr lang="en-US" sz="2100" b="1" dirty="0">
+                <a:solidFill>
+                  <a:srgbClr val="14181D"/>
+                </a:solidFill>
+                <a:latin typeface="Arial" pitchFamily="34" charset="0"/>
+                <a:ea typeface="Arial" pitchFamily="34" charset="-122"/>
+                <a:cs typeface="Arial" pitchFamily="34" charset="-120"/>
+              </a:rPr>
+              <a:t>Make the trade-off a signed decision</a:t>
+            </a:r>
+            <a:endParaRPr lang="en-US" sz="2100" dirty="0"/>
+          </a:p>
+        </p:txBody>
+      </p:sp>
+      <p:sp>
+        <p:nvSpPr>
+          <p:cNvPr id="7" name="rec-b-1"/>
+          <p:cNvSpPr txBox="1"/>
+          <p:nvPr/>
+        </p:nvSpPr>
+        <p:spPr>
+          <a:xfrm>
+            <a:off x="2057400" y="2121408"/>
+            <a:ext cx="9326880" cy="640080"/>
+          </a:xfrm>
+          <a:prstGeom prst="rect">
+            <a:avLst/>
+          </a:prstGeom>
+          <a:noFill/>
+          <a:ln/>
+        </p:spPr>
+        <p:txBody>
+          <a:bodyPr wrap="square" lIns="0" tIns="0" rIns="0" bIns="0" rtlCol="0" anchor="t"/>
+          <a:lstStyle/>
+          <a:p>
+            <a:pPr indent="0" marL="0">
+              <a:buNone/>
+            </a:pPr>
+            <a:r>
+              <a:rPr lang="en-US" sz="1600" dirty="0">
+                <a:solidFill>
+                  <a:srgbClr val="4A525C"/>
+                </a:solidFill>
+                <a:latin typeface="Calibri" pitchFamily="34" charset="0"/>
+                <a:ea typeface="Calibri" pitchFamily="34" charset="-122"/>
+                <a:cs typeface="Calibri" pitchFamily="34" charset="-120"/>
+              </a:rPr>
+              <a:t>Publish the triage rules, ask every tenant the same questions however they report, and record who decides how much cost may count.</a:t>
+            </a:r>
+            <a:endParaRPr lang="en-US" sz="1600" dirty="0"/>
+          </a:p>
+        </p:txBody>
+      </p:sp>
+      <p:sp>
+        <p:nvSpPr>
+          <p:cNvPr id="8" name="rec-2"/>
+          <p:cNvSpPr/>
+          <p:nvPr/>
+        </p:nvSpPr>
+        <p:spPr>
+          <a:xfrm>
+            <a:off x="548640" y="3017520"/>
+            <a:ext cx="11064240" cy="1371600"/>
+          </a:xfrm>
+          <a:prstGeom prst="roundRect">
+            <a:avLst>
+              <a:gd name="adj" fmla="val 6667"/>
+            </a:avLst>
+          </a:prstGeom>
+          <a:solidFill>
+            <a:srgbClr val="F1F3F5"/>
+          </a:solidFill>
+          <a:ln w="12700">
+            <a:solidFill>
+              <a:srgbClr val="F1F3F5"/>
+            </a:solidFill>
+            <a:prstDash val="solid"/>
+          </a:ln>
+        </p:spPr>
+      </p:sp>
+      <p:sp>
+        <p:nvSpPr>
+          <p:cNvPr id="9" name="rec-hex-2"/>
+          <p:cNvSpPr/>
+          <p:nvPr/>
+        </p:nvSpPr>
+        <p:spPr>
+          <a:xfrm>
+            <a:off x="868680" y="3291840"/>
+            <a:ext cx="868680" cy="764438"/>
+          </a:xfrm>
+          <a:prstGeom prst="hexagon">
+            <a:avLst/>
+          </a:prstGeom>
+          <a:solidFill>
+            <a:srgbClr val="0E8FB8"/>
+          </a:solidFill>
+          <a:ln w="12700">
+            <a:solidFill>
+              <a:srgbClr val="0E8FB8"/>
+            </a:solidFill>
+            <a:prstDash val="solid"/>
+          </a:ln>
+        </p:spPr>
+      </p:sp>
+      <p:sp>
+        <p:nvSpPr>
+          <p:cNvPr id="10" name="rec-hex-2-t"/>
+          <p:cNvSpPr txBox="1"/>
+          <p:nvPr/>
+        </p:nvSpPr>
+        <p:spPr>
+          <a:xfrm>
+            <a:off x="868680" y="3291840"/>
+            <a:ext cx="868680" cy="764438"/>
+          </a:xfrm>
+          <a:prstGeom prst="rect">
+            <a:avLst/>
+          </a:prstGeom>
+          <a:noFill/>
+          <a:ln/>
+        </p:spPr>
+        <p:txBody>
+          <a:bodyPr wrap="square" lIns="0" tIns="0" rIns="0" bIns="0" rtlCol="0" anchor="ctr"/>
+          <a:lstStyle/>
+          <a:p>
+            <a:pPr algn="ctr" indent="0" marL="0">
+              <a:buNone/>
+            </a:pPr>
+            <a:r>
+              <a:rPr lang="en-US" sz="2400" b="1" dirty="0">
+                <a:solidFill>
+                  <a:srgbClr val="FFFFFF"/>
+                </a:solidFill>
+                <a:latin typeface="Arial" pitchFamily="34" charset="0"/>
+                <a:ea typeface="Arial" pitchFamily="34" charset="-122"/>
+                <a:cs typeface="Arial" pitchFamily="34" charset="-120"/>
+              </a:rPr>
+              <a:t>2</a:t>
+            </a:r>
+            <a:endParaRPr lang="en-US" sz="2400" dirty="0"/>
+          </a:p>
+        </p:txBody>
+      </p:sp>
+      <p:sp>
+        <p:nvSpPr>
+          <p:cNvPr id="11" name="rec-h-2"/>
+          <p:cNvSpPr txBox="1"/>
+          <p:nvPr/>
+        </p:nvSpPr>
+        <p:spPr>
+          <a:xfrm>
+            <a:off x="2057400" y="3218688"/>
+            <a:ext cx="9326880" cy="411480"/>
+          </a:xfrm>
+          <a:prstGeom prst="rect">
+            <a:avLst/>
+          </a:prstGeom>
+          <a:noFill/>
+          <a:ln/>
+        </p:spPr>
+        <p:txBody>
+          <a:bodyPr wrap="square" lIns="0" tIns="0" rIns="0" bIns="0" rtlCol="0" anchor="t"/>
+          <a:lstStyle/>
+          <a:p>
+            <a:pPr indent="0" marL="0">
+              <a:buNone/>
+            </a:pPr>
+            <a:r>
+              <a:rPr lang="en-US" sz="2100" b="1" dirty="0">
+                <a:solidFill>
+                  <a:srgbClr val="14181D"/>
+                </a:solidFill>
+                <a:latin typeface="Arial" pitchFamily="34" charset="0"/>
+                <a:ea typeface="Arial" pitchFamily="34" charset="-122"/>
+                <a:cs typeface="Arial" pitchFamily="34" charset="-120"/>
+              </a:rPr>
+              <a:t>Pilot in one region, with communities</a:t>
+            </a:r>
+            <a:endParaRPr lang="en-US" sz="2100" dirty="0"/>
+          </a:p>
+        </p:txBody>
+      </p:sp>
+      <p:sp>
+        <p:nvSpPr>
+          <p:cNvPr id="12" name="rec-b-2"/>
+          <p:cNvSpPr txBox="1"/>
+          <p:nvPr/>
+        </p:nvSpPr>
+        <p:spPr>
+          <a:xfrm>
+            <a:off x="2057400" y="3675888"/>
+            <a:ext cx="9326880" cy="640080"/>
+          </a:xfrm>
+          <a:prstGeom prst="rect">
+            <a:avLst/>
+          </a:prstGeom>
+          <a:noFill/>
+          <a:ln/>
+        </p:spPr>
+        <p:txBody>
+          <a:bodyPr wrap="square" lIns="0" tIns="0" rIns="0" bIns="0" rtlCol="0" anchor="t"/>
+          <a:lstStyle/>
+          <a:p>
+            <a:pPr indent="0" marL="0">
+              <a:buNone/>
+            </a:pPr>
+            <a:r>
+              <a:rPr lang="en-US" sz="1600" dirty="0">
+                <a:solidFill>
+                  <a:srgbClr val="4A525C"/>
+                </a:solidFill>
+                <a:latin typeface="Calibri" pitchFamily="34" charset="0"/>
+                <a:ea typeface="Calibri" pitchFamily="34" charset="-122"/>
+                <a:cs typeface="Calibri" pitchFamily="34" charset="-120"/>
+              </a:rPr>
+              <a:t>Start with the Katherine hub's 16 communities, co-designed with tenants, Aboriginal Housing NT, land councils and the Interpreter Service.</a:t>
+            </a:r>
+            <a:endParaRPr lang="en-US" sz="1600" dirty="0"/>
+          </a:p>
+        </p:txBody>
+      </p:sp>
+      <p:sp>
+        <p:nvSpPr>
+          <p:cNvPr id="13" name="rec-3"/>
+          <p:cNvSpPr/>
+          <p:nvPr/>
+        </p:nvSpPr>
+        <p:spPr>
+          <a:xfrm>
+            <a:off x="548640" y="4572000"/>
+            <a:ext cx="11064240" cy="1371600"/>
+          </a:xfrm>
+          <a:prstGeom prst="roundRect">
+            <a:avLst>
+              <a:gd name="adj" fmla="val 6667"/>
+            </a:avLst>
+          </a:prstGeom>
+          <a:solidFill>
+            <a:srgbClr val="F1F3F5"/>
+          </a:solidFill>
+          <a:ln w="12700">
+            <a:solidFill>
+              <a:srgbClr val="F1F3F5"/>
+            </a:solidFill>
+            <a:prstDash val="solid"/>
+          </a:ln>
+        </p:spPr>
+      </p:sp>
+      <p:sp>
+        <p:nvSpPr>
+          <p:cNvPr id="14" name="rec-hex-3"/>
+          <p:cNvSpPr/>
+          <p:nvPr/>
+        </p:nvSpPr>
+        <p:spPr>
+          <a:xfrm>
+            <a:off x="868680" y="4846320"/>
+            <a:ext cx="868680" cy="764438"/>
+          </a:xfrm>
+          <a:prstGeom prst="hexagon">
+            <a:avLst/>
+          </a:prstGeom>
+          <a:solidFill>
+            <a:srgbClr val="6E56CF"/>
+          </a:solidFill>
+          <a:ln w="12700">
+            <a:solidFill>
+              <a:srgbClr val="6E56CF"/>
+            </a:solidFill>
+            <a:prstDash val="solid"/>
+          </a:ln>
+        </p:spPr>
+      </p:sp>
+      <p:sp>
+        <p:nvSpPr>
+          <p:cNvPr id="15" name="rec-hex-3-t"/>
+          <p:cNvSpPr txBox="1"/>
+          <p:nvPr/>
+        </p:nvSpPr>
+        <p:spPr>
+          <a:xfrm>
+            <a:off x="868680" y="4846320"/>
+            <a:ext cx="868680" cy="764438"/>
+          </a:xfrm>
+          <a:prstGeom prst="rect">
+            <a:avLst/>
+          </a:prstGeom>
+          <a:noFill/>
+          <a:ln/>
+        </p:spPr>
+        <p:txBody>
+          <a:bodyPr wrap="square" lIns="0" tIns="0" rIns="0" bIns="0" rtlCol="0" anchor="ctr"/>
+          <a:lstStyle/>
+          <a:p>
+            <a:pPr algn="ctr" indent="0" marL="0">
+              <a:buNone/>
+            </a:pPr>
+            <a:r>
+              <a:rPr lang="en-US" sz="2400" b="1" dirty="0">
+                <a:solidFill>
+                  <a:srgbClr val="FFFFFF"/>
+                </a:solidFill>
+                <a:latin typeface="Arial" pitchFamily="34" charset="0"/>
+                <a:ea typeface="Arial" pitchFamily="34" charset="-122"/>
+                <a:cs typeface="Arial" pitchFamily="34" charset="-120"/>
+              </a:rPr>
+              <a:t>3</a:t>
+            </a:r>
+            <a:endParaRPr lang="en-US" sz="2400" dirty="0"/>
+          </a:p>
+        </p:txBody>
+      </p:sp>
+      <p:sp>
+        <p:nvSpPr>
+          <p:cNvPr id="16" name="rec-h-3"/>
+          <p:cNvSpPr txBox="1"/>
+          <p:nvPr/>
+        </p:nvSpPr>
+        <p:spPr>
+          <a:xfrm>
+            <a:off x="2057400" y="4773168"/>
+            <a:ext cx="9326880" cy="411480"/>
+          </a:xfrm>
+          <a:prstGeom prst="rect">
+            <a:avLst/>
+          </a:prstGeom>
+          <a:noFill/>
+          <a:ln/>
+        </p:spPr>
+        <p:txBody>
+          <a:bodyPr wrap="square" lIns="0" tIns="0" rIns="0" bIns="0" rtlCol="0" anchor="t"/>
+          <a:lstStyle/>
+          <a:p>
+            <a:pPr indent="0" marL="0">
+              <a:buNone/>
+            </a:pPr>
+            <a:r>
+              <a:rPr lang="en-US" sz="2100" b="1" dirty="0">
+                <a:solidFill>
+                  <a:srgbClr val="14181D"/>
+                </a:solidFill>
+                <a:latin typeface="Arial" pitchFamily="34" charset="0"/>
+                <a:ea typeface="Arial" pitchFamily="34" charset="-122"/>
+                <a:cs typeface="Arial" pitchFamily="34" charset="-120"/>
+              </a:rPr>
+              <a:t>Test the AI on real words first</a:t>
+            </a:r>
+            <a:endParaRPr lang="en-US" sz="2100" dirty="0"/>
+          </a:p>
+        </p:txBody>
+      </p:sp>
+      <p:sp>
+        <p:nvSpPr>
+          <p:cNvPr id="17" name="rec-b-3"/>
+          <p:cNvSpPr txBox="1"/>
+          <p:nvPr/>
+        </p:nvSpPr>
+        <p:spPr>
+          <a:xfrm>
+            <a:off x="2057400" y="5230368"/>
+            <a:ext cx="9326880" cy="640080"/>
+          </a:xfrm>
+          <a:prstGeom prst="rect">
+            <a:avLst/>
+          </a:prstGeom>
+          <a:noFill/>
+          <a:ln/>
+        </p:spPr>
+        <p:txBody>
+          <a:bodyPr wrap="square" lIns="0" tIns="0" rIns="0" bIns="0" rtlCol="0" anchor="t"/>
+          <a:lstStyle/>
+          <a:p>
+            <a:pPr indent="0" marL="0">
+              <a:buNone/>
+            </a:pPr>
+            <a:r>
+              <a:rPr lang="en-US" sz="1600" dirty="0">
+                <a:solidFill>
+                  <a:srgbClr val="4A525C"/>
+                </a:solidFill>
+                <a:latin typeface="Calibri" pitchFamily="34" charset="0"/>
+                <a:ea typeface="Calibri" pitchFamily="34" charset="-122"/>
+                <a:cs typeface="Calibri" pitchFamily="34" charset="-120"/>
+              </a:rPr>
+              <a:t>Score the reader on real reports in Kriol and Aboriginal English before it reads a single one on its own.</a:t>
+            </a:r>
+            <a:endParaRPr lang="en-US" sz="1600" dirty="0"/>
+          </a:p>
+        </p:txBody>
+      </p:sp>
+      <p:sp>
+        <p:nvSpPr>
+          <p:cNvPr id="25" name="Slide Number Placeholder 0"/>
+          <p:cNvSpPr>
+            <a:spLocks noGrp="1"/>
+          </p:cNvSpPr>
+          <p:nvPr>
+            <p:ph type="sldNum" sz="quarter" idx="4294967295"/>
+          </p:nvPr>
+        </p:nvSpPr>
+        <p:spPr>
+          <a:xfrm>
+            <a:off x="11155680" y="6419088"/>
+            <a:ext cx="457200" cy="274320"/>
+          </a:xfrm>
+          <a:prstGeom prst="rect">
+            <a:avLst/>
+          </a:prstGeom>
+          <a:extLst>
+            <a:ext uri="{C572A759-6A51-4108-AA02-DFA0A04FC94B}">
+              <ma14:wrappingTextBoxFlag xmlns:ma14="http://schemas.microsoft.com/office/mac/drawingml/2011/main" val="0"/>
+            </a:ext>
+          </a:extLst>
+        </p:spPr>
+        <p:txBody>
+          <a:bodyPr/>
+          <a:lstStyle>
+            <a:lvl1pPr>
+              <a:defRPr sz="1000">
+                <a:solidFill>
+                  <a:srgbClr val="6B7480"/>
+                </a:solidFill>
+              </a:defRPr>
+            </a:lvl1pPr>
+          </a:lstStyle>
+          <a:p>
+            <a:pPr algn="l"/>
+            <a:fld id="{F7021451-1387-4CA6-816F-3879F97B5CBC}" type="slidenum">
+              <a:rPr b="0" lang="en-US"/>
+              <a:t>14</a:t>
+            </a:fld>
+            <a:endParaRPr lang="en-US"/>
+          </a:p>
+        </p:txBody>
+      </p:sp>
+    </p:spTree>
+  </p:cSld>
+  <p:clrMapOvr>
+    <a:masterClrMapping/>
+  </p:clrMapOvr>
+</p:sld>
+</file>
+
+<file path=ppt/slides/slide15.xml><?xml version="1.0" encoding="utf-8"?>
+<p:sld xmlns:a="http://schemas.openxmlformats.org/drawingml/2006/main" xmlns:r="http://schemas.openxmlformats.org/officeDocument/2006/relationships" xmlns:p="http://schemas.openxmlformats.org/presentationml/2006/main">
+  <p:cSld name="Slide 15">
+    <p:spTree>
+      <p:nvGrpSpPr>
+        <p:cNvPr id="1" name=""/>
+        <p:cNvGrpSpPr/>
+        <p:nvPr/>
+      </p:nvGrpSpPr>
+      <p:grpSpPr>
+        <a:xfrm>
+          <a:off x="0" y="0"/>
+          <a:ext cx="0" cy="0"/>
+          <a:chOff x="0" y="0"/>
+          <a:chExt cx="0" cy="0"/>
+        </a:xfrm>
+      </p:grpSpPr>
       <p:pic>
         <p:nvPicPr>
           <p:cNvPr id="2" name="close-backdrop" descr="close-backdrop">    </p:cNvPr>
@@ -11374,8 +12562,8 @@
         </p:nvSpPr>
         <p:spPr>
           <a:xfrm>
-            <a:off x="548640" y="5349240"/>
-            <a:ext cx="6766560" cy="777240"/>
+            <a:off x="548640" y="5257800"/>
+            <a:ext cx="6766560" cy="868680"/>
           </a:xfrm>
           <a:prstGeom prst="rect">
             <a:avLst/>
@@ -11399,7 +12587,21 @@
                 <a:ea typeface="Calibri" pitchFamily="34" charset="-122"/>
                 <a:cs typeface="Calibri" pitchFamily="34" charset="-120"/>
               </a:rPr>
-              <a:t>Google OR-Tools (CP-SAT) chooses which communities get a visit and which jobs are done, within each tradesperson's 40 hours, road closures and airstrips.</a:t>
+              <a:t>Google OR-Tools (CP-SAT) chooses which communities get a visit and which jobs are done, within each tradesperson's 40 hours, road closures and airstrips. </a:t>
+            </a:r>
+            <a:pPr indent="0" marL="0">
+              <a:buNone/>
+            </a:pPr>
+            <a:r>
+              <a:rPr lang="en-US" sz="1400" b="1" dirty="0">
+                <a:solidFill>
+                  <a:srgbClr val="14181D"/>
+                </a:solidFill>
+                <a:latin typeface="Calibri" pitchFamily="34" charset="0"/>
+                <a:ea typeface="Calibri" pitchFamily="34" charset="-122"/>
+                <a:cs typeface="Calibri" pitchFamily="34" charset="-120"/>
+              </a:rPr>
+              <a:t>Trades going to the same place travel together: a further $130 off every repair.</a:t>
             </a:r>
             <a:endParaRPr lang="en-US" sz="1400" dirty="0"/>
           </a:p>

</xml_diff>

<commit_message>
Re-run with vulnerability tiers; refresh numbers, report and deck
All results regenerated with Tier 1 / Tier 2 households. ReachNT now
costs $816 per repair (46% more than cheapest-first) and still fixes
9 in 10 urgent remote repairs within 3 days. Saying less costs 43 points
from words alone and 5 with the standard questions.

Roads and weather prompts group communities by road. Report trimmed back
to 8 body pages; deck intake screenshot retaken with the new questions.
</commit_message>
<xml_diff>
--- a/docs/deck/DataChallenge_Team AIC015_Slides.pptx
+++ b/docs/deck/DataChallenge_Team AIC015_Slides.pptx
@@ -121,23 +121,23 @@
   <p:extLst>
     <p:ext uri="{521415D9-36F7-43E2-AB2F-B90AF26B5E84}">
       <p14:sectionLst xmlns:p14="http://schemas.microsoft.com/office/powerpoint/2010/main">
-        <p14:section name="Opening" id="{6a2b5af1-2cf6-02bf-e132-e184b715b762}">
+        <p14:section name="Opening" id="{470ae4fc-89c8-eaa6-1213-e1a7375a1680}">
           <p14:sldIdLst>
             <p14:sldId id="256"/>
           </p14:sldIdLst>
         </p14:section>
-        <p14:section name="Problem" id="{a558f3f2-7a5f-d32c-5dac-81a0d9409602}">
+        <p14:section name="Problem" id="{ce840f2b-fa2a-2708-666b-af9d7776ffce}">
           <p14:sldIdLst>
             <p14:sldId id="257"/>
             <p14:sldId id="258"/>
           </p14:sldIdLst>
         </p14:section>
-        <p14:section name="Solution" id="{d69e74d5-5a23-436b-b725-e7ca1ec29663}">
+        <p14:section name="Solution" id="{8781d8fd-117c-d664-497f-93f6be2bb3bb}">
           <p14:sldIdLst>
             <p14:sldId id="259"/>
           </p14:sldIdLst>
         </p14:section>
-        <p14:section name="Technology" id="{4c097d64-e9c4-9df2-f0f5-a7e866436d4d}">
+        <p14:section name="Technology" id="{2b283a7d-1525-f526-97aa-baac8343a653}">
           <p14:sldIdLst>
             <p14:sldId id="260"/>
             <p14:sldId id="261"/>
@@ -145,24 +145,24 @@
             <p14:sldId id="263"/>
           </p14:sldIdLst>
         </p14:section>
-        <p14:section name="Results" id="{b66a1b54-901b-e064-f42a-f235b5a8d142}">
+        <p14:section name="Results" id="{566927ae-7835-3002-06c2-c205a320a10c}">
           <p14:sldIdLst>
             <p14:sldId id="264"/>
             <p14:sldId id="265"/>
           </p14:sldIdLst>
         </p14:section>
-        <p14:section name="Product" id="{20adb541-6246-695c-6cc0-3adfc2b982dd}">
+        <p14:section name="Product" id="{b796694d-c906-3f4b-8678-17bc6331ec8e}">
           <p14:sldIdLst>
             <p14:sldId id="266"/>
           </p14:sldIdLst>
         </p14:section>
-        <p14:section name="Trust" id="{075291d2-32c7-0c22-3c9f-fa2a9380583d}">
+        <p14:section name="Trust" id="{f5c8eed8-0db3-dcff-1fc7-2e8e1ad1bc2f}">
           <p14:sldIdLst>
             <p14:sldId id="267"/>
             <p14:sldId id="268"/>
           </p14:sldIdLst>
         </p14:section>
-        <p14:section name="Close" id="{7a149782-aade-9fe0-4300-e1c099221b1c}">
+        <p14:section name="Close" id="{86444194-0864-27c5-d47a-8fe8437c273e}">
           <p14:sldIdLst>
             <p14:sldId id="269"/>
             <p14:sldId id="270"/>
@@ -301,19 +301,19 @@
                   <c:v>3</c:v>
                 </c:pt>
                 <c:pt idx="1">
-                  <c:v>7</c:v>
+                  <c:v>6</c:v>
                 </c:pt>
                 <c:pt idx="2">
-                  <c:v>70</c:v>
+                  <c:v>69</c:v>
                 </c:pt>
                 <c:pt idx="3">
-                  <c:v>74</c:v>
+                  <c:v>75</c:v>
                 </c:pt>
                 <c:pt idx="4">
                   <c:v>69</c:v>
                 </c:pt>
                 <c:pt idx="5">
-                  <c:v>73</c:v>
+                  <c:v>71</c:v>
                 </c:pt>
               </c:numCache>
             </c:numRef>
@@ -598,13 +598,13 @@
                 <c:formatCode>General</c:formatCode>
                 <c:ptCount val="3"/>
                 <c:pt idx="0">
-                  <c:v>226</c:v>
+                  <c:v>232</c:v>
                 </c:pt>
                 <c:pt idx="1">
-                  <c:v>74</c:v>
+                  <c:v>76</c:v>
                 </c:pt>
                 <c:pt idx="2">
-                  <c:v>61</c:v>
+                  <c:v>63</c:v>
                 </c:pt>
               </c:numCache>
             </c:numRef>
@@ -1232,8 +1232,9 @@
               <a:rPr lang="en-US" dirty="0"/>
               <a:t>[AASHISH, about 35 seconds]
 Floods and cyclones hit whole communities at once. The coordinator declares an event: every house made safe within 48 hours, one team trip with all the trades, and surge crews from the contractor panel.
-We modelled a flood like January 2023 at Kalkarindji. With the usual crews, flood repairs took 15 days, and everyone else in the region slipped from 3 to 10.
-With surge crews, both stayed at 3 days. A disaster shouldn't quietly take other communities' trades.</a:t>
+We modelled a flood like January 2023 at Kalkarindji. With the usual crews, flood repairs took 14 days, and everyone else in the region slipped from 3 to 10.
+With surge crews, both stayed at 3 days. A disaster shouldn't quietly take other communities' trades.
+The portal also reads the NT Road Report and the Bureau of Meteorology, so heavy rain near a community prompts the coordinator to declare a flood. It prompts; a person decides.</a:t>
             </a:r>
             <a:endParaRPr lang="en-US" dirty="0"/>
           </a:p>
@@ -2155,7 +2156,8 @@
 Thanks Harsh. There's a quieter unfairness too.
 If points come only from what tenants say, "my nana lives here, nine of us, third time I rang" beats "toilet blocked, please come". Same house, same need.
 So whoever the tenant tells asks the same six questions, with a free interpreter, and the tenancy record fills in the rest.
-On three thousand made-up households, saying less cost 19 points from words alone. With the questions, about 2.
+Tier one, like someone on dialysis or a newborn, gets more points, and losing power or water becomes an emergency for them.
+On three thousand made-up households, saying less cost 43 points from words alone. With the questions, about 5.
 And the clock starts when the tenant first told anyone.</a:t>
             </a:r>
             <a:endParaRPr lang="en-US" dirty="0"/>
@@ -2339,8 +2341,8 @@
               <a:t>[HARSH, about 35 seconds]
 Every week Google's OR-Tools plans the trips around crew hours, road closures and airstrips. A job running out of time gets a boost onto the next trip.
 Instead of two trips out and back, one tradesperson does one loop, and H3 tells us which pairs are close enough. And a plumber and an electrician going to the same place share the ute or the plane.
-That saves about $73 on every repair, and because the savings buy more visits, households spend 18% fewer days living with faults.
-And it's fast: the solver proved 99.4 percent of over 25 thousand weekly plans to be the best possible plan.</a:t>
+That saves about $77 on every repair, and because the savings buy more visits, households spend 17% fewer days living with faults.
+And it's fast: the solver proved 99.2 percent of over 25 thousand weekly plans to be the best possible plan.</a:t>
             </a:r>
             <a:endParaRPr lang="en-US" dirty="0"/>
           </a:p>
@@ -2430,7 +2432,7 @@
               <a:rPr lang="en-US" dirty="0"/>
               <a:t>[HARSH, about 50 seconds]
 So what does it buy? A year of 37,508 made-up requests over the real Territory.
-Planning for the cheapest jobs costs $559 a repair. ReachNT costs $803. About 44% more.
+Planning for the cheapest jobs costs $559 a repair. ReachNT costs $816. About 46% more.
 For that, nine in ten urgent remote repairs are fixed within 3 days instead of 62, and households live with faults for 73% fewer days. That's the chart.
 We didn't trust one lucky year, so we ran five. The result held every time.
 We're not saying cost doesn't matter. We're saying the trade-off should be visible, priced, and signed by a person.</a:t>
@@ -4168,7 +4170,7 @@
                 <a:ea typeface="Arial" pitchFamily="34" charset="-122"/>
                 <a:cs typeface="Arial" pitchFamily="34" charset="-120"/>
               </a:rPr>
-              <a:t>15 days</a:t>
+              <a:t>14 days</a:t>
             </a:r>
             <a:endParaRPr lang="en-US" sz="2600" dirty="0"/>
           </a:p>
@@ -4558,7 +4560,7 @@
                 <a:ea typeface="Calibri" pitchFamily="34" charset="-122"/>
                 <a:cs typeface="Calibri" pitchFamily="34" charset="-120"/>
               </a:rPr>
-              <a:t>Need still sets the order inside the flooded area. The question for fairness is everyone else: without surge crews, the flood quietly takes their trades.</a:t>
+              <a:t>Live NT Road Report and Bureau of Meteorology readings prompt the coordinator: a road closure, heavy rain (“Declare a flood?”) or heat for Tier 1 homes. A person decides.</a:t>
             </a:r>
             <a:endParaRPr lang="en-US" sz="1350" dirty="0"/>
           </a:p>
@@ -7212,7 +7214,7 @@
                   <a:srgbClr val="C9CFD6"/>
                 </a:solidFill>
               </a:rPr>
-              <a:t>ReachNT fixes 9 in 10 urgent remote repairs within 3 days instead of 62, for 44% more, and makes someone own that choice.</a:t>
+              <a:t>ReachNT fixes 9 in 10 urgent remote repairs within 3 days instead of 62, for 46% more, and makes someone own that choice.</a:t>
             </a:r>
             <a:endParaRPr lang="en-US" sz="2200" dirty="0"/>
           </a:p>
@@ -10350,7 +10352,7 @@
                 <a:ea typeface="Calibri" pitchFamily="34" charset="-122"/>
                 <a:cs typeface="Calibri" pitchFamily="34" charset="-120"/>
               </a:rPr>
-              <a:t>Anyone in danger now? A baby or young child? An elder? Someone sick, pregnant or with a disability? How many people live there? Told anyone before? The tenancy record and repair history fill in the rest. "Not asked" never takes points away.</a:t>
+              <a:t>Anyone in danger now? Needs power, cooling or medicine; a baby under 1 or a frail elder (Tier 1)? Young children, pregnant, sick or hard to get around (Tier 2)? How many live there? Told anyone before? Records fill in the rest. "Not asked" never costs points.</a:t>
             </a:r>
             <a:endParaRPr lang="en-US" sz="1250" dirty="0"/>
           </a:p>
@@ -10389,7 +10391,7 @@
                 <a:ea typeface="Arial" pitchFamily="34" charset="-122"/>
                 <a:cs typeface="Arial" pitchFamily="34" charset="-120"/>
               </a:rPr>
-              <a:t>19 → 2</a:t>
+              <a:t>43 → 5</a:t>
             </a:r>
             <a:endParaRPr lang="en-US" sz="3600" dirty="0"/>
           </a:p>
@@ -10467,7 +10469,7 @@
                 <a:ea typeface="Arial" pitchFamily="34" charset="-122"/>
                 <a:cs typeface="Arial" pitchFamily="34" charset="-120"/>
               </a:rPr>
-              <a:t>97% → 11%</a:t>
+              <a:t>97% → 12%</a:t>
             </a:r>
             <a:endParaRPr lang="en-US" sz="3600" dirty="0"/>
           </a:p>
@@ -10545,7 +10547,7 @@
                 <a:ea typeface="Arial" pitchFamily="34" charset="-122"/>
                 <a:cs typeface="Arial" pitchFamily="34" charset="-120"/>
               </a:rPr>
-              <a:t>4% → 92%</a:t>
+              <a:t>4% → 91%</a:t>
             </a:r>
             <a:endParaRPr lang="en-US" sz="3600" dirty="0"/>
           </a:p>
@@ -10584,7 +10586,7 @@
                 <a:ea typeface="Calibri" pitchFamily="34" charset="-122"/>
                 <a:cs typeface="Calibri" pitchFamily="34" charset="-120"/>
               </a:rPr>
-              <a:t>of vulnerable households recognised from a few words</a:t>
+              <a:t>of Tier 1 or 2 households recognised from a few words</a:t>
             </a:r>
             <a:endParaRPr lang="en-US" sz="1400" dirty="0"/>
           </a:p>
@@ -11473,7 +11475,7 @@
                 <a:ea typeface="Calibri" pitchFamily="34" charset="-122"/>
                 <a:cs typeface="Calibri" pitchFamily="34" charset="-120"/>
               </a:rPr>
-              <a:t>Communities within 2 hexagons (about 90 km) can share a trip, saving $66–$73 per repair</a:t>
+              <a:t>Communities within 2 hexagons (about 90 km) can share a trip, saving $70–$77 per repair</a:t>
             </a:r>
             <a:endParaRPr lang="en-US" sz="1400" dirty="0"/>
           </a:p>
@@ -12601,7 +12603,7 @@
                 <a:ea typeface="Calibri" pitchFamily="34" charset="-122"/>
                 <a:cs typeface="Calibri" pitchFamily="34" charset="-120"/>
               </a:rPr>
-              <a:t>Trades going to the same place travel together: a further $130 off every repair.</a:t>
+              <a:t>Trades going to the same place travel together: a further $139 off every repair.</a:t>
             </a:r>
             <a:endParaRPr lang="en-US" sz="1400" dirty="0"/>
           </a:p>
@@ -12640,7 +12642,7 @@
                 <a:ea typeface="Arial" pitchFamily="34" charset="-122"/>
                 <a:cs typeface="Arial" pitchFamily="34" charset="-120"/>
               </a:rPr>
-              <a:t>$73</a:t>
+              <a:t>$77</a:t>
             </a:r>
             <a:endParaRPr lang="en-US" sz="4800" dirty="0"/>
           </a:p>
@@ -12718,7 +12720,7 @@
                 <a:ea typeface="Arial" pitchFamily="34" charset="-122"/>
                 <a:cs typeface="Arial" pitchFamily="34" charset="-120"/>
               </a:rPr>
-              <a:t>18%</a:t>
+              <a:t>17%</a:t>
             </a:r>
             <a:endParaRPr lang="en-US" sz="4800" dirty="0"/>
           </a:p>
@@ -12796,7 +12798,7 @@
                 <a:ea typeface="Arial" pitchFamily="34" charset="-122"/>
                 <a:cs typeface="Arial" pitchFamily="34" charset="-120"/>
               </a:rPr>
-              <a:t>99.4%</a:t>
+              <a:t>99.2%</a:t>
             </a:r>
             <a:endParaRPr lang="en-US" sz="4000" dirty="0"/>
           </a:p>
@@ -12835,7 +12837,7 @@
                 <a:ea typeface="Calibri" pitchFamily="34" charset="-122"/>
                 <a:cs typeface="Calibri" pitchFamily="34" charset="-120"/>
               </a:rPr>
-              <a:t>of 25,996 weekly plans proved the best possible, in milliseconds</a:t>
+              <a:t>of 25,972 weekly plans proved the best possible, in milliseconds</a:t>
             </a:r>
             <a:endParaRPr lang="en-US" sz="1500" dirty="0"/>
           </a:p>
@@ -13344,7 +13346,7 @@
                           <a:ea typeface="Calibri" pitchFamily="34" charset="-122"/>
                           <a:cs typeface="Calibri" pitchFamily="34" charset="-120"/>
                         </a:rPr>
-                        <a:t>$803</a:t>
+                        <a:t>$816</a:t>
                       </a:r>
                       <a:endParaRPr lang="en-US" sz="1500" dirty="0">
                         <a:latin typeface="Calibri" charset="0"/>
@@ -13688,7 +13690,7 @@
                           <a:ea typeface="Calibri" pitchFamily="34" charset="-122"/>
                           <a:cs typeface="Calibri" pitchFamily="34" charset="-120"/>
                         </a:rPr>
-                        <a:t>226k</a:t>
+                        <a:t>232k</a:t>
                       </a:r>
                       <a:endParaRPr lang="en-US" sz="1500" dirty="0">
                         <a:latin typeface="Calibri" charset="0"/>
@@ -13756,7 +13758,7 @@
                           <a:ea typeface="Calibri" pitchFamily="34" charset="-122"/>
                           <a:cs typeface="Calibri" pitchFamily="34" charset="-120"/>
                         </a:rPr>
-                        <a:t>61k</a:t>
+                        <a:t>63k</a:t>
                       </a:r>
                       <a:endParaRPr lang="en-US" sz="1500" dirty="0">
                         <a:latin typeface="Calibri" charset="0"/>
@@ -13872,7 +13874,7 @@
                 <a:ea typeface="Calibri" pitchFamily="34" charset="-122"/>
                 <a:cs typeface="Calibri" pitchFamily="34" charset="-120"/>
               </a:rPr>
-              <a:t>+44% cost, 73% fewer days with a fault</a:t>
+              <a:t>+46% cost, 73% fewer days with a fault</a:t>
             </a:r>
             <a:endParaRPr lang="en-US" sz="2000" dirty="0"/>
           </a:p>
@@ -13911,7 +13913,7 @@
                 <a:ea typeface="Calibri" pitchFamily="34" charset="-122"/>
                 <a:cs typeface="Calibri" pitchFamily="34" charset="-120"/>
               </a:rPr>
-              <a:t>It held in all five random years we tested: 73%–75% fewer fault-days, for 42%–46% more per repair.</a:t>
+              <a:t>It held in all five random years we tested: 73%–75% fewer fault-days, for 45%–48% more per repair.</a:t>
             </a:r>
             <a:endParaRPr lang="en-US" sz="1500" dirty="0"/>
           </a:p>
@@ -14010,47 +14012,47 @@
 </file>
 
 <file path=ppt/theme/theme1.xml><?xml version="1.0" encoding="utf-8"?>
-<a:theme xmlns:a="http://schemas.openxmlformats.org/drawingml/2006/main" name="ReachNT">
+<a:theme xmlns:a="http://schemas.openxmlformats.org/drawingml/2006/main" name="Office Theme">
   <a:themeElements>
-    <a:clrScheme name="ReachNT">
+    <a:clrScheme name="Office">
       <a:dk1>
-        <a:srgbClr val="14181D"/>
+        <a:sysClr val="windowText" lastClr="000000"/>
       </a:dk1>
       <a:lt1>
-        <a:srgbClr val="FFFFFF"/>
+        <a:sysClr val="window" lastClr="FFFFFF"/>
       </a:lt1>
       <a:dk2>
-        <a:srgbClr val="4A525C"/>
+        <a:srgbClr val="44546A"/>
       </a:dk2>
       <a:lt2>
-        <a:srgbClr val="F1F3F5"/>
+        <a:srgbClr val="E7E6E6"/>
       </a:lt2>
       <a:accent1>
-        <a:srgbClr val="0E8FB8"/>
+        <a:srgbClr val="4472C4"/>
       </a:accent1>
       <a:accent2>
-        <a:srgbClr val="D97706"/>
+        <a:srgbClr val="ED7D31"/>
       </a:accent2>
       <a:accent3>
-        <a:srgbClr val="1F9D4C"/>
+        <a:srgbClr val="A5A5A5"/>
       </a:accent3>
       <a:accent4>
-        <a:srgbClr val="0A7AFF"/>
+        <a:srgbClr val="FFC000"/>
       </a:accent4>
       <a:accent5>
-        <a:srgbClr val="6E56CF"/>
+        <a:srgbClr val="5B9BD5"/>
       </a:accent5>
       <a:accent6>
-        <a:srgbClr val="E5352B"/>
+        <a:srgbClr val="70AD47"/>
       </a:accent6>
       <a:hlink>
-        <a:srgbClr val="0A7AFF"/>
+        <a:srgbClr val="0563C1"/>
       </a:hlink>
       <a:folHlink>
-        <a:srgbClr val="6E56CF"/>
+        <a:srgbClr val="954F72"/>
       </a:folHlink>
     </a:clrScheme>
-    <a:fontScheme name="ReachNT">
+    <a:fontScheme name="Office">
       <a:majorFont>
         <a:latin typeface="Arial"/>
         <a:ea typeface=""/>

</xml_diff>

<commit_message>
Re-run with the audit fixes; refresh report, deck, pitch script and docs
Results from the corrected engine (deterministic solver, clean
sensitivity runs, honest made-safe and trades-together measures):
ReachNT $821 per repair, 47% more than cheapest-first, 9 in 10 urgent
remote repairs within 3 days, 74% fewer fault-days; against
cheapest-first with the urgent guarantee, 5% more for 29% fewer.

Report discloses the cheapest-first baseline's never-done jobs, the
within-week look-ahead and the made-safe assumption; headings are 14 pt
and the body stays at 8 pages. The pitch script fits 10 minutes with a
40-second demo that works step by step, and the deck's speaker notes
are now read from the script.
</commit_message>
<xml_diff>
--- a/docs/deck/DataChallenge_Team AIC015_Slides.pptx
+++ b/docs/deck/DataChallenge_Team AIC015_Slides.pptx
@@ -121,23 +121,23 @@
   <p:extLst>
     <p:ext uri="{521415D9-36F7-43E2-AB2F-B90AF26B5E84}">
       <p14:sectionLst xmlns:p14="http://schemas.microsoft.com/office/powerpoint/2010/main">
-        <p14:section name="Opening" id="{470ae4fc-89c8-eaa6-1213-e1a7375a1680}">
+        <p14:section name="Opening" id="{27e90edc-0601-c98b-685e-f64a9016f346}">
           <p14:sldIdLst>
             <p14:sldId id="256"/>
           </p14:sldIdLst>
         </p14:section>
-        <p14:section name="Problem" id="{ce840f2b-fa2a-2708-666b-af9d7776ffce}">
+        <p14:section name="Problem" id="{be6f30e2-82e6-c3db-9985-6379069d8e36}">
           <p14:sldIdLst>
             <p14:sldId id="257"/>
             <p14:sldId id="258"/>
           </p14:sldIdLst>
         </p14:section>
-        <p14:section name="Solution" id="{8781d8fd-117c-d664-497f-93f6be2bb3bb}">
+        <p14:section name="Solution" id="{3cbeac2e-656c-dade-007b-602af4751b30}">
           <p14:sldIdLst>
             <p14:sldId id="259"/>
           </p14:sldIdLst>
         </p14:section>
-        <p14:section name="Technology" id="{2b283a7d-1525-f526-97aa-baac8343a653}">
+        <p14:section name="Technology" id="{54aedcee-4b63-83fd-ffc0-961ece5b1b40}">
           <p14:sldIdLst>
             <p14:sldId id="260"/>
             <p14:sldId id="261"/>
@@ -145,24 +145,24 @@
             <p14:sldId id="263"/>
           </p14:sldIdLst>
         </p14:section>
-        <p14:section name="Results" id="{566927ae-7835-3002-06c2-c205a320a10c}">
+        <p14:section name="Results" id="{63e99fde-657d-11e2-bb76-a339faf9e147}">
           <p14:sldIdLst>
             <p14:sldId id="264"/>
             <p14:sldId id="265"/>
           </p14:sldIdLst>
         </p14:section>
-        <p14:section name="Product" id="{b796694d-c906-3f4b-8678-17bc6331ec8e}">
+        <p14:section name="Product" id="{a85cf71c-c120-e517-08a8-916121c75c2b}">
           <p14:sldIdLst>
             <p14:sldId id="266"/>
           </p14:sldIdLst>
         </p14:section>
-        <p14:section name="Trust" id="{f5c8eed8-0db3-dcff-1fc7-2e8e1ad1bc2f}">
+        <p14:section name="Trust" id="{da7e7cf2-83eb-14f8-5129-58b4ab03059b}">
           <p14:sldIdLst>
             <p14:sldId id="267"/>
             <p14:sldId id="268"/>
           </p14:sldIdLst>
         </p14:section>
-        <p14:section name="Close" id="{86444194-0864-27c5-d47a-8fe8437c273e}">
+        <p14:section name="Close" id="{2121a657-4dc3-d692-6016-5269d1a865cf}">
           <p14:sldIdLst>
             <p14:sldId id="269"/>
             <p14:sldId id="270"/>
@@ -304,16 +304,16 @@
                   <c:v>6</c:v>
                 </c:pt>
                 <c:pt idx="2">
-                  <c:v>69</c:v>
+                  <c:v>74</c:v>
                 </c:pt>
                 <c:pt idx="3">
-                  <c:v>75</c:v>
+                  <c:v>74</c:v>
                 </c:pt>
                 <c:pt idx="4">
                   <c:v>69</c:v>
                 </c:pt>
                 <c:pt idx="5">
-                  <c:v>71</c:v>
+                  <c:v>70</c:v>
                 </c:pt>
               </c:numCache>
             </c:numRef>
@@ -598,13 +598,13 @@
                 <c:formatCode>General</c:formatCode>
                 <c:ptCount val="3"/>
                 <c:pt idx="0">
-                  <c:v>232</c:v>
+                  <c:v>233</c:v>
                 </c:pt>
                 <c:pt idx="1">
-                  <c:v>76</c:v>
+                  <c:v>75</c:v>
                 </c:pt>
                 <c:pt idx="2">
-                  <c:v>63</c:v>
+                  <c:v>62</c:v>
                 </c:pt>
               </c:numCache>
             </c:numRef>
@@ -1231,10 +1231,9 @@
             <a:r>
               <a:rPr lang="en-US" dirty="0"/>
               <a:t>[AASHISH, about 35 seconds]
-Floods and cyclones hit whole communities at once. The coordinator declares an event: every house made safe within 48 hours, one team trip with all the trades, and surge crews from the contractor panel.
-We modelled a flood like January 2023 at Kalkarindji. With the usual crews, flood repairs took 14 days, and everyone else in the region slipped from 3 to 10.
-With surge crews, both stayed at 3 days. A disaster shouldn't quietly take other communities' trades.
-The portal also reads the NT Road Report and the Bureau of Meteorology, so heavy rain near a community prompts the coordinator to declare a flood. It prompts; a person decides.</a:t>
+Floods hit whole communities at once. The coordinator declares an event: every house made safe within 48 hours, one team trip, and surge crews from the contractor panel.
+In a flood like January 2023 at Kalkarindji, the usual crews took 14 days, and the rest of the region slipped from 3 to 10. With surge crews, both stayed at 3.
+The portal reads the NT Road Report and the Bureau of Meteorology, so heavy rain prompts the coordinator. It prompts; a person decides.</a:t>
             </a:r>
             <a:endParaRPr lang="en-US" dirty="0"/>
           </a:p>
@@ -1322,11 +1321,10 @@
           <a:p>
             <a:r>
               <a:rPr lang="en-US" dirty="0"/>
-              <a:t>[HARSH, about 65 seconds, including a short live demo if there's time]
-This is the working prototype, live at reachnt dot vercel dot app.
-On the left is the coordinator's week: each hexagon is a community, the number is repairs waiting, green means a tradesperson goes this week, and the blue lines are shared trips.
-[Live demo, keep it short: Housing officer view, record "still broken" for a tenant; Coordinator, Checks, send it to another crew; Tenant timeline.]
-On the phone, tradespeople get a run sheet that works with no signal, and tenants see every week their repair waited, and why.</a:t>
+              <a:t>[HARSH, about 60 seconds, including a 40-second live demo]
+This is the working prototype, live at reachnt dot vercel dot app. Each hexagon is a community, the number is repairs waiting, and the blue lines are shared trips.
+[Live demo, 40 seconds, practised beforehand: Tradesperson, tap Done on the first card. Housing officer, Ngukurr, the same house: "Still broken", Record. Coordinator, Checks, "Choose a crew", Send. Tenant: it opens on that repair, showing the reopened timeline.]
+Tradespeople get a run sheet that works with no signal, and tenants see every week their repair waited, and why.</a:t>
             </a:r>
             <a:endParaRPr lang="en-US" dirty="0"/>
           </a:p>
@@ -1414,12 +1412,10 @@
           <a:p>
             <a:r>
               <a:rPr lang="en-US" dirty="0"/>
-              <a:t>[AASHISH, about 45 seconds]
+              <a:t>[AASHISH, about 35 seconds]
 Because this affects people's homes, people stay in charge.
-A named coordinator signs how much cost counts.
-Urgency can change any time, so a person can change it: on a call, on site, from a photo. The computer never makes danger less urgent.
-If a tradesperson couldn't do a job, it's never closed. The coordinator sends it to the next trip, another crew, or anyone who can go sooner, and it keeps its waiting time.
-No app is needed: the housing officer can record anything for a tenant, and a fix that didn't hold moves up the line.</a:t>
+A named coordinator signs how much cost counts. A person can change urgency any time, on a call, on site or from a photo, and lowering a dangerous repair needs someone who spoke to the tenant or saw it.
+A missed visit is never closed: it goes to the next trip or another crew, keeping its waiting time. And no app is needed: the housing officer can record anything for a tenant.</a:t>
             </a:r>
             <a:endParaRPr lang="en-US" dirty="0"/>
           </a:p>
@@ -1507,11 +1503,10 @@
           <a:p>
             <a:r>
               <a:rPr lang="en-US" dirty="0"/>
-              <a:t>[HARSH, about 50 seconds]
+              <a:t>[HARSH, about 40 seconds]
 We want to be straight about what we've proven and what we haven't.
-On the left: we have ninety-eight automated checks that run on every change, we tested five random years, we checked every community's location against satellite photos, and the site passes accessibility checks.
-On the right: the repair requests are synthetic, because no public repair data exists. The reader is tested in English only, and many tenants speak Kriol or Aboriginal English. And no community has reviewed this yet.
-That's why our first recommendation is about people, not code.</a:t>
+We have 148 automated checks on every change, five random years, every community's location checked against satellite photos, and an independent audit whose findings we fixed.
+But the requests are synthetic, because no public repair data exists. The reader is tested in English only. And no community has reviewed this yet. That's why our first recommendation is about people, not code.</a:t>
             </a:r>
             <a:endParaRPr lang="en-US" dirty="0"/>
           </a:p>
@@ -1599,10 +1594,10 @@
           <a:p>
             <a:r>
               <a:rPr lang="en-US" dirty="0"/>
-              <a:t>[AASHISH, about 40 seconds]
+              <a:t>[AASHISH, about 30 seconds]
 Three recommendations.
 One: make the trade-off a signed decision. Publish the rules, ask every tenant the same questions, and record who decides how much cost counts.
-Two: pilot it in one region, the Katherine hub's sixteen communities, and design it with tenants, Aboriginal Housing NT, land councils and interpreters.
+Two: pilot it in the Katherine hub's sixteen communities, designed with tenants, Aboriginal Housing NT, land councils and interpreters.
 Three: test the AI on real words before it reads anything on its own.</a:t>
             </a:r>
             <a:endParaRPr lang="en-US" dirty="0"/>
@@ -1782,11 +1777,11 @@
           <a:p>
             <a:r>
               <a:rPr lang="en-US" dirty="0"/>
-              <a:t>[AASHISH, about 40 seconds]
+              <a:t>[AASHISH, about 35 seconds]
 Here's the problem in four numbers.
 There are 70 remote communities in our model, with about 4,500 public houses.
 Emergency repairs in very remote communities cost eight and a half times as much, and travel can be almost the whole bill. Katherine's tradespeople drive up to six hours.
-So here is the kind of message a tenant gets from our simulation: no water to the house, waited 57 days, held up by travel cost. Notice the last line: nobody signed off on that. It just happened.</a:t>
+And this is the kind of message a tenant gets in our simulation. Notice the last line: nobody signed off on that wait. It just happened.</a:t>
             </a:r>
             <a:endParaRPr lang="en-US" dirty="0"/>
           </a:p>
@@ -1874,11 +1869,10 @@
           <a:p>
             <a:r>
               <a:rPr lang="en-US" dirty="0"/>
-              <a:t>[AASHISH, about 50 seconds]
-Why does this happen? Because the obvious way to plan repairs is to fix the most jobs for your money.
-We simulated a whole year of repairs across the Territory. When you plan for the cheapest jobs, town tenants get urgent repairs in 3 days. Remote tenants wait up to 62. That's the orange bars.
-The important part is on the right. No one decided this. Nobody wrote a rule saying remote families wait. It's a side effect of chasing efficiency, and nobody is accountable for it.
-That's the gap we set out to close.</a:t>
+              <a:t>[AASHISH, about 35 seconds]
+Why? Because the obvious way to plan repairs is to fix the most jobs for your money.
+We simulated a whole year across the Territory. Planning for the cheapest jobs, town tenants get urgent repairs in 3 days. Remote tenants wait up to 62.
+Nobody wrote a rule saying remote families wait. It's a side effect of chasing efficiency, and nobody is accountable for it. That's the gap we set out to close.</a:t>
             </a:r>
             <a:endParaRPr lang="en-US" dirty="0"/>
           </a:p>
@@ -1966,7 +1960,7 @@
           <a:p>
             <a:r>
               <a:rPr lang="en-US" dirty="0"/>
-              <a:t>[HARSH, about 40 seconds]
+              <a:t>[HARSH, about 35 seconds]
 Thanks Aashish. ReachNT does four things.
 One: it reads the report the way the tenant said it. If it isn't sure, a person calls back.
 Two: it ranks repairs by need alone. Where you live is never part of your score.
@@ -2059,12 +2053,10 @@
           <a:p>
             <a:r>
               <a:rPr lang="en-US" dirty="0"/>
-              <a:t>[HARSH, about 50 seconds]
-Now the AI. Tenants don't fill in forms. They say things like "no sparks now but the switch is black and the kids touch it".
-ReachNT reads that with word rules and a learning model for wording the rules miss.
-The key design choice: if it's unsure, or anything sounds dangerous, a person checks the same day, and it never downgrades danger on its own.
-We tested it on wording it had never seen. The model alone is decent, a ROC-AUC of 0.84. With the person in the loop, the system caught 99.3 percent of dangerous reports.
-And we're honest about its limits: its confidence isn't reliable, so we never show tenants a percentage.</a:t>
+              <a:t>[HARSH, about 40 seconds]
+Now the AI. Tenants say things like "no sparks now but the switch is black and the kids touch it".
+ReachNT reads that with word rules and a learning model for wording the rules miss. If it's unsure, or anything sounds dangerous, a person checks the same day. It never downgrades danger on its own.
+On wording the model never saw, it scored a ROC-AUC of 0.84. With the person in the loop, the system caught 99.3 percent of dangerous reports. Its confidence isn't reliable, so tenants never see a percentage.</a:t>
             </a:r>
             <a:endParaRPr lang="en-US" dirty="0"/>
           </a:p>
@@ -2152,13 +2144,10 @@
           <a:p>
             <a:r>
               <a:rPr lang="en-US" dirty="0"/>
-              <a:t>[AASHISH, about 35 seconds]
-Thanks Harsh. There's a quieter unfairness too.
-If points come only from what tenants say, "my nana lives here, nine of us, third time I rang" beats "toilet blocked, please come". Same house, same need.
-So whoever the tenant tells asks the same six questions, with a free interpreter, and the tenancy record fills in the rest.
-Tier one, like someone on dialysis or a newborn, gets more points, and losing power or water becomes an emergency for them.
-On three thousand made-up households, saying less cost 43 points from words alone. With the questions, about 5.
-And the clock starts when the tenant first told anyone.</a:t>
+              <a:t>[AASHISH, about 40 seconds]
+There's a quieter unfairness too. If points come only from what tenants say, "my nana lives here, nine of us, third time I rang" beats "toilet blocked, please come". Same house, same need.
+So whoever the tenant tells asks the same six questions, with a free interpreter. Tier one, like someone on dialysis or a newborn, gets more points, and losing power or water becomes an emergency for them.
+Across three thousand made-up households, saying less cost 50 points from words alone. With the questions, about 5.</a:t>
             </a:r>
             <a:endParaRPr lang="en-US" dirty="0"/>
           </a:p>
@@ -2246,11 +2235,10 @@
           <a:p>
             <a:r>
               <a:rPr lang="en-US" dirty="0"/>
-              <a:t>[AASHISH, about 40 seconds]
-This was my favourite decision. Early on I suggested Uber's H3, an open-source map grid made of hexagons, and Harsh built the whole system around it.
-Why hexagons? The middle square has neighbours at two different distances, the sides and the corners. A hexagon's six neighbours are all the same distance away.
-So "within two hexagons" means the same distance in every direction, and the rule for sharing a trip treats every community the same.
-And one grid does four jobs: shared trips, privacy, public numbers by area, and the maps.</a:t>
+              <a:t>[AASHISH, about 35 seconds]
+This was my favourite decision. I suggested Uber's H3, an open-source grid of hexagons, and Harsh built the system around it.
+A square's neighbours sit at two distances, sides and corners. A hexagon's six neighbours are all the same distance away. So "within two hexagons" is fair in every direction, and the rule for sharing a trip treats every community the same.
+One grid does four jobs: shared trips, privacy, public numbers by area, and the maps.</a:t>
             </a:r>
             <a:endParaRPr lang="en-US" dirty="0"/>
           </a:p>
@@ -2340,9 +2328,8 @@
               <a:rPr lang="en-US" dirty="0"/>
               <a:t>[HARSH, about 35 seconds]
 Every week Google's OR-Tools plans the trips around crew hours, road closures and airstrips. A job running out of time gets a boost onto the next trip.
-Instead of two trips out and back, one tradesperson does one loop, and H3 tells us which pairs are close enough. And a plumber and an electrician going to the same place share the ute or the plane.
-That saves about $77 on every repair, and because the savings buy more visits, households spend 17% fewer days living with faults.
-And it's fast: the solver proved 99.2 percent of over 25 thousand weekly plans to be the best possible plan.</a:t>
+One tradesperson does one loop instead of two trips, and H3 tells us which pairs are close enough. That saves about $76 on every repair, and households spend 17% fewer days living with faults.
+The solver proved 99.5 percent of twenty-six thousand weekly plans to be the best possible.</a:t>
             </a:r>
             <a:endParaRPr lang="en-US" dirty="0"/>
           </a:p>
@@ -2430,12 +2417,11 @@
           <a:p>
             <a:r>
               <a:rPr lang="en-US" dirty="0"/>
-              <a:t>[HARSH, about 50 seconds]
+              <a:t>[HARSH, about 45 seconds]
 So what does it buy? A year of 37,508 made-up requests over the real Territory.
-Planning for the cheapest jobs costs $559 a repair. ReachNT costs $816. About 46% more.
-For that, nine in ten urgent remote repairs are fixed within 3 days instead of 62, and households live with faults for 73% fewer days. That's the chart.
-We didn't trust one lucky year, so we ran five. The result held every time.
-We're not saying cost doesn't matter. We're saying the trade-off should be visible, priced, and signed by a person.</a:t>
+Planning for the cheapest jobs costs $561 a repair. ReachNT costs $821, about 47% more.
+For that, nine in ten urgent remote repairs are fixed within 3 days instead of 62, and households live with faults for 74% fewer days. Against a cheaper plan that also guarantees urgent jobs, ReachNT costs 5% more for 29% fewer fault-days.
+We ran five random years. The result held every time. The trade-off should be visible, priced, and signed by a person.</a:t>
             </a:r>
             <a:endParaRPr lang="en-US" dirty="0"/>
           </a:p>
@@ -4521,7 +4507,7 @@
                 <a:ea typeface="Calibri" pitchFamily="34" charset="-122"/>
                 <a:cs typeface="Calibri" pitchFamily="34" charset="-120"/>
               </a:rPr>
-              <a:t>Every dangerous fault was made safe the day it was reported.</a:t>
+              <a:t>Dangerous faults the reader recognised were made safe within a day (we assume a maintenance officer on hand).</a:t>
             </a:r>
             <a:endParaRPr lang="en-US" sz="1300" dirty="0"/>
           </a:p>
@@ -6013,7 +5999,7 @@
                 <a:ea typeface="Calibri" pitchFamily="34" charset="-122"/>
                 <a:cs typeface="Calibri" pitchFamily="34" charset="-120"/>
               </a:rPr>
-              <a:t>98 automated checks on every code change: data, the reader, fair intake, the planner, the server</a:t>
+              <a:t>148 automated checks on every code change: data, the reader, fair intake, the planner, the server</a:t>
             </a:r>
             <a:endParaRPr lang="en-US" sz="1500" dirty="0"/>
           </a:p>
@@ -7214,7 +7200,7 @@
                   <a:srgbClr val="C9CFD6"/>
                 </a:solidFill>
               </a:rPr>
-              <a:t>ReachNT fixes 9 in 10 urgent remote repairs within 3 days instead of 62, for 46% more, and makes someone own that choice.</a:t>
+              <a:t>ReachNT fixes 9 in 10 urgent remote repairs within 3 days instead of 62, for 47% more, and makes someone own that choice.</a:t>
             </a:r>
             <a:endParaRPr lang="en-US" sz="2200" dirty="0"/>
           </a:p>
@@ -7869,7 +7855,7 @@
                 <a:ea typeface="Calibri" pitchFamily="34" charset="-122"/>
                 <a:cs typeface="Calibri" pitchFamily="34" charset="-120"/>
               </a:rPr>
-              <a:t>“Your no water to the house repair is urgent. Waiting 57 days. Held up by travel cost.”</a:t>
+              <a:t>“Your no power to the house repair is urgent. Waiting 56 days. Held up by travel cost.”</a:t>
             </a:r>
             <a:endParaRPr lang="en-US" sz="1800" dirty="0"/>
           </a:p>
@@ -7908,7 +7894,7 @@
                 <a:ea typeface="Calibri" pitchFamily="34" charset="-122"/>
                 <a:cs typeface="Calibri" pitchFamily="34" charset="-120"/>
               </a:rPr>
-              <a:t>For 28 days no plumber was sent to your community. It costs about $7,700 to fly one there and back. That was a cost decision, not a judgement about your repair. Nobody signed off on it.</a:t>
+              <a:t>For 28 days no electrician was sent to your community. It costs about $8,100 to fly one there and back. That was a cost decision, not a judgement about your repair. Nobody signed off on it.</a:t>
             </a:r>
             <a:endParaRPr lang="en-US" sz="1500" dirty="0"/>
           </a:p>
@@ -9021,24 +9007,26 @@
         </p:nvSpPr>
         <p:spPr>
           <a:xfrm>
-            <a:off x="548640" y="5760720"/>
-            <a:ext cx="11064240" cy="457200"/>
-          </a:xfrm>
-          <a:prstGeom prst="rect">
-            <a:avLst/>
-          </a:prstGeom>
-          <a:noFill/>
-          <a:ln/>
-        </p:spPr>
-        <p:txBody>
-          <a:bodyPr wrap="square" lIns="0" tIns="0" rIns="0" bIns="0" rtlCol="0" anchor="t"/>
+            <a:off x="548640" y="5669280"/>
+            <a:ext cx="11064240" cy="594360"/>
+          </a:xfrm>
+          <a:prstGeom prst="rect">
+            <a:avLst/>
+          </a:prstGeom>
+          <a:noFill/>
+          <a:ln/>
+        </p:spPr>
+        <p:txBody>
+          <a:bodyPr wrap="square" lIns="0" tIns="0" rIns="0" bIns="0" rtlCol="0" anchor="t">
+            <a:normAutofit/>
+          </a:bodyPr>
           <a:lstStyle/>
           <a:p>
             <a:pPr indent="0" marL="0">
               <a:buNone/>
             </a:pPr>
             <a:r>
-              <a:rPr lang="en-US" sz="1600" i="1" dirty="0">
+              <a:rPr lang="en-US" sz="1400" i="1" dirty="0">
                 <a:solidFill>
                   <a:srgbClr val="4A525C"/>
                 </a:solidFill>
@@ -9046,9 +9034,9 @@
                 <a:ea typeface="Calibri" pitchFamily="34" charset="-122"/>
                 <a:cs typeface="Calibri" pitchFamily="34" charset="-120"/>
               </a:rPr>
-              <a:t>One tool, three views: the coordinator plans, the tradesperson gets a run sheet that works without signal, and the tenant gets a straight answer.</a:t>
-            </a:r>
-            <a:endParaRPr lang="en-US" sz="1600" dirty="0"/>
+              <a:t>One tool, four views: the coordinator plans, the tradesperson gets a run sheet that works without signal, the tenant gets a straight answer, and the housing officer records for tenants without the app.</a:t>
+            </a:r>
+            <a:endParaRPr lang="en-US" sz="1400" dirty="0"/>
           </a:p>
         </p:txBody>
       </p:sp>
@@ -9820,7 +9808,7 @@
                 <a:ea typeface="Arial" pitchFamily="34" charset="-122"/>
                 <a:cs typeface="Arial" pitchFamily="34" charset="-120"/>
               </a:rPr>
-              <a:t>40%</a:t>
+              <a:t>42%</a:t>
             </a:r>
             <a:endParaRPr lang="en-US" sz="4000" dirty="0"/>
           </a:p>
@@ -10391,7 +10379,7 @@
                 <a:ea typeface="Arial" pitchFamily="34" charset="-122"/>
                 <a:cs typeface="Arial" pitchFamily="34" charset="-120"/>
               </a:rPr>
-              <a:t>43 → 5</a:t>
+              <a:t>50 → 5</a:t>
             </a:r>
             <a:endParaRPr lang="en-US" sz="3600" dirty="0"/>
           </a:p>
@@ -10469,7 +10457,7 @@
                 <a:ea typeface="Arial" pitchFamily="34" charset="-122"/>
                 <a:cs typeface="Arial" pitchFamily="34" charset="-120"/>
               </a:rPr>
-              <a:t>97% → 12%</a:t>
+              <a:t>95% → 6%</a:t>
             </a:r>
             <a:endParaRPr lang="en-US" sz="3600" dirty="0"/>
           </a:p>
@@ -10547,7 +10535,7 @@
                 <a:ea typeface="Arial" pitchFamily="34" charset="-122"/>
                 <a:cs typeface="Arial" pitchFamily="34" charset="-120"/>
               </a:rPr>
-              <a:t>4% → 91%</a:t>
+              <a:t>13% → 89%</a:t>
             </a:r>
             <a:endParaRPr lang="en-US" sz="3600" dirty="0"/>
           </a:p>
@@ -11475,7 +11463,7 @@
                 <a:ea typeface="Calibri" pitchFamily="34" charset="-122"/>
                 <a:cs typeface="Calibri" pitchFamily="34" charset="-120"/>
               </a:rPr>
-              <a:t>Communities within 2 hexagons (about 90 km) can share a trip, saving $70–$77 per repair</a:t>
+              <a:t>Communities within 2 hexagons (about 90 km) can share a trip, saving $67–$76 per repair</a:t>
             </a:r>
             <a:endParaRPr lang="en-US" sz="1400" dirty="0"/>
           </a:p>
@@ -12603,7 +12591,7 @@
                 <a:ea typeface="Calibri" pitchFamily="34" charset="-122"/>
                 <a:cs typeface="Calibri" pitchFamily="34" charset="-120"/>
               </a:rPr>
-              <a:t>Trades going to the same place travel together: a further $139 off every repair.</a:t>
+              <a:t>Trades going to the same place travel together: a further $105 off every repair.</a:t>
             </a:r>
             <a:endParaRPr lang="en-US" sz="1400" dirty="0"/>
           </a:p>
@@ -12642,7 +12630,7 @@
                 <a:ea typeface="Arial" pitchFamily="34" charset="-122"/>
                 <a:cs typeface="Arial" pitchFamily="34" charset="-120"/>
               </a:rPr>
-              <a:t>$77</a:t>
+              <a:t>$76</a:t>
             </a:r>
             <a:endParaRPr lang="en-US" sz="4800" dirty="0"/>
           </a:p>
@@ -12798,7 +12786,7 @@
                 <a:ea typeface="Arial" pitchFamily="34" charset="-122"/>
                 <a:cs typeface="Arial" pitchFamily="34" charset="-120"/>
               </a:rPr>
-              <a:t>99.2%</a:t>
+              <a:t>99.5%</a:t>
             </a:r>
             <a:endParaRPr lang="en-US" sz="4000" dirty="0"/>
           </a:p>
@@ -12837,7 +12825,7 @@
                 <a:ea typeface="Calibri" pitchFamily="34" charset="-122"/>
                 <a:cs typeface="Calibri" pitchFamily="34" charset="-120"/>
               </a:rPr>
-              <a:t>of 25,972 weekly plans proved the best possible, in milliseconds</a:t>
+              <a:t>of 26,018 weekly plans proved the best possible, in milliseconds</a:t>
             </a:r>
             <a:endParaRPr lang="en-US" sz="1500" dirty="0"/>
           </a:p>
@@ -13278,7 +13266,7 @@
                           <a:ea typeface="Calibri" pitchFamily="34" charset="-122"/>
                           <a:cs typeface="Calibri" pitchFamily="34" charset="-120"/>
                         </a:rPr>
-                        <a:t>$559</a:t>
+                        <a:t>$561</a:t>
                       </a:r>
                       <a:endParaRPr lang="en-US" sz="1500" dirty="0">
                         <a:latin typeface="Calibri" charset="0"/>
@@ -13346,7 +13334,7 @@
                           <a:ea typeface="Calibri" pitchFamily="34" charset="-122"/>
                           <a:cs typeface="Calibri" pitchFamily="34" charset="-120"/>
                         </a:rPr>
-                        <a:t>$816</a:t>
+                        <a:t>$821</a:t>
                       </a:r>
                       <a:endParaRPr lang="en-US" sz="1500" dirty="0">
                         <a:latin typeface="Calibri" charset="0"/>
@@ -13690,7 +13678,7 @@
                           <a:ea typeface="Calibri" pitchFamily="34" charset="-122"/>
                           <a:cs typeface="Calibri" pitchFamily="34" charset="-120"/>
                         </a:rPr>
-                        <a:t>232k</a:t>
+                        <a:t>233k</a:t>
                       </a:r>
                       <a:endParaRPr lang="en-US" sz="1500" dirty="0">
                         <a:latin typeface="Calibri" charset="0"/>
@@ -13758,7 +13746,7 @@
                           <a:ea typeface="Calibri" pitchFamily="34" charset="-122"/>
                           <a:cs typeface="Calibri" pitchFamily="34" charset="-120"/>
                         </a:rPr>
-                        <a:t>63k</a:t>
+                        <a:t>62k</a:t>
                       </a:r>
                       <a:endParaRPr lang="en-US" sz="1500" dirty="0">
                         <a:latin typeface="Calibri" charset="0"/>
@@ -13874,7 +13862,7 @@
                 <a:ea typeface="Calibri" pitchFamily="34" charset="-122"/>
                 <a:cs typeface="Calibri" pitchFamily="34" charset="-120"/>
               </a:rPr>
-              <a:t>+46% cost, 73% fewer days with a fault</a:t>
+              <a:t>+47% cost, 74% fewer days with a fault</a:t>
             </a:r>
             <a:endParaRPr lang="en-US" sz="2000" dirty="0"/>
           </a:p>
@@ -13913,7 +13901,7 @@
                 <a:ea typeface="Calibri" pitchFamily="34" charset="-122"/>
                 <a:cs typeface="Calibri" pitchFamily="34" charset="-120"/>
               </a:rPr>
-              <a:t>It held in all five random years we tested: 73%–75% fewer fault-days, for 45%–48% more per repair.</a:t>
+              <a:t>It held in all five random years we tested: 74%–77% fewer fault-days, for 45%–49% more per repair.</a:t>
             </a:r>
             <a:endParaRPr lang="en-US" sz="1500" dirty="0"/>
           </a:p>

</xml_diff>

<commit_message>
Apply judge-panel fixes to deck, script, report and privacy
Demo steps follow the real first job (Binjari house 29) and where each
button is; slide 3's callout says remote overall; slide 9 compares with
cheapest-first plus the urgent guarantee; the footer says costs are
assumed and calibrated; slide 6 no longer claims a Kriol test.
Health-related intake answers are not readable by analysts or the
planner. Trade-off screenshot retaken with current numbers.
</commit_message>
<xml_diff>
--- a/docs/deck/DataChallenge_Team AIC015_Slides.pptx
+++ b/docs/deck/DataChallenge_Team AIC015_Slides.pptx
@@ -121,23 +121,23 @@
   <p:extLst>
     <p:ext uri="{521415D9-36F7-43E2-AB2F-B90AF26B5E84}">
       <p14:sectionLst xmlns:p14="http://schemas.microsoft.com/office/powerpoint/2010/main">
-        <p14:section name="Opening" id="{27e90edc-0601-c98b-685e-f64a9016f346}">
+        <p14:section name="Opening" id="{23ec944c-2ee2-1414-5c55-d5e23d4bf08b}">
           <p14:sldIdLst>
             <p14:sldId id="256"/>
           </p14:sldIdLst>
         </p14:section>
-        <p14:section name="Problem" id="{be6f30e2-82e6-c3db-9985-6379069d8e36}">
+        <p14:section name="Problem" id="{b1e87c2d-6148-fc31-8e88-2e409a5923fa}">
           <p14:sldIdLst>
             <p14:sldId id="257"/>
             <p14:sldId id="258"/>
           </p14:sldIdLst>
         </p14:section>
-        <p14:section name="Solution" id="{3cbeac2e-656c-dade-007b-602af4751b30}">
+        <p14:section name="Solution" id="{df3d6294-f69a-b5c5-7007-5b432ebc92d4}">
           <p14:sldIdLst>
             <p14:sldId id="259"/>
           </p14:sldIdLst>
         </p14:section>
-        <p14:section name="Technology" id="{54aedcee-4b63-83fd-ffc0-961ece5b1b40}">
+        <p14:section name="Technology" id="{2aab84b5-26fa-d130-e609-fea8d8e47868}">
           <p14:sldIdLst>
             <p14:sldId id="260"/>
             <p14:sldId id="261"/>
@@ -145,24 +145,24 @@
             <p14:sldId id="263"/>
           </p14:sldIdLst>
         </p14:section>
-        <p14:section name="Results" id="{63e99fde-657d-11e2-bb76-a339faf9e147}">
+        <p14:section name="Results" id="{6d01b3f4-8ebd-f1f5-22c5-cbf0b321dc1d}">
           <p14:sldIdLst>
             <p14:sldId id="264"/>
             <p14:sldId id="265"/>
           </p14:sldIdLst>
         </p14:section>
-        <p14:section name="Product" id="{a85cf71c-c120-e517-08a8-916121c75c2b}">
+        <p14:section name="Product" id="{55f0e854-4969-1baa-97b1-aaaf0c9ecc3d}">
           <p14:sldIdLst>
             <p14:sldId id="266"/>
           </p14:sldIdLst>
         </p14:section>
-        <p14:section name="Trust" id="{da7e7cf2-83eb-14f8-5129-58b4ab03059b}">
+        <p14:section name="Trust" id="{4c26cf00-bdc3-ae95-2f41-e579ca584192}">
           <p14:sldIdLst>
             <p14:sldId id="267"/>
             <p14:sldId id="268"/>
           </p14:sldIdLst>
         </p14:section>
-        <p14:section name="Close" id="{2121a657-4dc3-d692-6016-5269d1a865cf}">
+        <p14:section name="Close" id="{19e89e19-73a9-b7bf-5f65-815d2b566774}">
           <p14:sldIdLst>
             <p14:sldId id="269"/>
             <p14:sldId id="270"/>
@@ -582,7 +582,7 @@
                     <c:v>Cheapest first</c:v>
                   </c:pt>
                   <c:pt idx="1">
-                    <c:v>Urgent first, no sharing</c:v>
+                    <c:v>Cheapest first + urgent guarantee</c:v>
                   </c:pt>
                   <c:pt idx="2">
                     <c:v>ReachNT</c:v>
@@ -601,7 +601,7 @@
                   <c:v>233</c:v>
                 </c:pt>
                 <c:pt idx="1">
-                  <c:v>75</c:v>
+                  <c:v>87</c:v>
                 </c:pt>
                 <c:pt idx="2">
                   <c:v>62</c:v>
@@ -1323,7 +1323,7 @@
               <a:rPr lang="en-US" dirty="0"/>
               <a:t>[HARSH, about 60 seconds, including a 40-second live demo]
 This is the working prototype, live at reachnt dot vercel dot app. Each hexagon is a community, the number is repairs waiting, and the blue lines are shared trips.
-[Live demo, 40 seconds, practised beforehand: Tradesperson, tap Done on the first card. Housing officer, Ngukurr, the same house: "Still broken", Record. Coordinator, Checks, "Choose a crew", Send. Tenant: it opens on that repair, showing the reopened timeline.]
+[Live demo, 40 seconds, practised beforehand (Early Feb, ReachNT plan): Tradesperson (plumber), tap Done on the first card, Binjari house 29. Housing officer, switch community to Binjari, house 29: "Still broken", Record. Coordinator, Checks, scroll to "Tenant says it's still broken", "Choose a crew", pick crew B, Send. Tenant: it opens on that repair, showing the reopened timeline.]
 Tradespeople get a run sheet that works with no signal, and tenants see every week their repair waited, and why.</a:t>
             </a:r>
             <a:endParaRPr lang="en-US" dirty="0"/>
@@ -1871,7 +1871,7 @@
               <a:rPr lang="en-US" dirty="0"/>
               <a:t>[AASHISH, about 35 seconds]
 Why? Because the obvious way to plan repairs is to fix the most jobs for your money.
-We simulated a whole year across the Territory. Planning for the cheapest jobs, town tenants get urgent repairs in 3 days. Remote tenants wait up to 62.
+We simulated a whole year across the Territory. Planning for the cheapest jobs, town tenants get urgent repairs in 3 days. Remote tenants wait up to 62, and longer in the hardest places.
 Nobody wrote a rule saying remote families wait. It's a side effect of chasing efficiency, and nobody is accountable for it. That's the gap we set out to close.</a:t>
             </a:r>
             <a:endParaRPr lang="en-US" dirty="0"/>
@@ -2738,7 +2738,7 @@
                   <a:srgbClr val="6B7480"/>
                 </a:solidFill>
               </a:rPr>
-              <a:t>ReachNT · Team AIC015 Top Enders · repair requests are synthetic; communities, roads and costs are real</a:t>
+              <a:t>ReachNT · Team AIC015 Top Enders · requests synthetic; communities, roads and clocks real; costs assumed, calibrated to Nous 2017</a:t>
             </a:r>
             <a:endParaRPr lang="en-US" sz="1000" dirty="0"/>
           </a:p>
@@ -2893,7 +2893,7 @@
                   <a:srgbClr val="9AA3AD"/>
                 </a:solidFill>
               </a:rPr>
-              <a:t>ReachNT · Team AIC015 Top Enders · repair requests are synthetic; communities, roads and costs are real</a:t>
+              <a:t>ReachNT · Team AIC015 Top Enders · requests synthetic; communities, roads and clocks real; costs assumed, calibrated to Nous 2017</a:t>
             </a:r>
             <a:endParaRPr lang="en-US" sz="1000" dirty="0"/>
           </a:p>
@@ -8126,7 +8126,7 @@
                 <a:ea typeface="Calibri" pitchFamily="34" charset="-122"/>
                 <a:cs typeface="Calibri" pitchFamily="34" charset="-120"/>
               </a:rPr>
-              <a:t>for 9 in 10 urgent remote repairs, against 3 days in town</a:t>
+              <a:t>for 9 in 10 urgent remote repairs overall (longer in the hardest-to-reach places), against 3 days in town</a:t>
             </a:r>
             <a:endParaRPr lang="en-US" sz="1600" dirty="0"/>
           </a:p>
@@ -10196,7 +10196,7 @@
                 <a:ea typeface="Calibri" pitchFamily="34" charset="-122"/>
                 <a:cs typeface="Calibri" pitchFamily="34" charset="-120"/>
               </a:rPr>
-              <a:t>Told in a few words, in Kriol, to the housing officer</a:t>
+              <a:t>Told in a few words to the housing officer</a:t>
             </a:r>
             <a:endParaRPr lang="en-US" sz="1350" dirty="0"/>
           </a:p>
@@ -10235,7 +10235,7 @@
                 <a:ea typeface="Calibri" pitchFamily="34" charset="-122"/>
                 <a:cs typeface="Calibri" pitchFamily="34" charset="-120"/>
               </a:rPr>
-              <a:t>“toilet blocked pls come”. Same house, same need. From the words alone: up to 45 points less</a:t>
+              <a:t>“toilet blocked pls come”. Same house, same need. From the words alone, this example loses 45 points</a:t>
             </a:r>
             <a:endParaRPr lang="en-US" sz="1300" dirty="0"/>
           </a:p>

</xml_diff>